<commit_message>
Update presentation with 5-section content-first focus and AI agent extensibility
</commit_message>
<xml_diff>
--- a/vventra_presentation.pptx
+++ b/vventra_presentation.pptx
@@ -12,8 +12,6 @@
     <p:sldId id="260" r:id="rId12"/>
     <p:sldId id="261" r:id="rId13"/>
     <p:sldId id="262" r:id="rId14"/>
-    <p:sldId id="263" r:id="rId15"/>
-    <p:sldId id="264" r:id="rId16"/>
   </p:sldIdLst>
   <p:sldSz cx="12191695" cy="6858000" type="screen4x3"/>
   <p:notesSz cx="6858000" cy="9144000"/>
@@ -510,7 +508,7 @@
           <a:lstStyle/>
           <a:p>
             <a:r>
-              <a:t>Welcome everyone. Today I'm presenting vvEntra — an institutional marketplace and transaction engine designed specifically for buying and selling software businesses and digital IP safely. I rebuilt this platform completely from scratch using zero external dependencies, introduced an institutional design system, and developed a proprietary 4-step Atomic Handover Protocol to eliminate fraud.</a:t>
+              <a:t>Today I'm presenting a complete, content-focused breakdown of vvEntra. We will focus directly on substance: what problem the website solves, the mutual benefits for users and our platform, every major functionality, the zero-dependency tech stack and its AI-agent extensibility, our core innovation compared to the original reference site, and key lessons learned.</a:t>
             </a:r>
           </a:p>
         </p:txBody>
@@ -580,7 +578,7 @@
           <a:lstStyle/>
           <a:p>
             <a:r>
-              <a:t>To understand vvEntra, think of it like an institutional real estate escrow service, but for software companies. Right now, selling an app or SaaS business is dangerous. Traditional brokers take 15% and take months, while listing sites are full of scams. vvEntra solves this by verifying financial numbers directly with Stripe, auditing source code, and holding both money and code in escrow until both parties are 100% satisfied.</a:t>
+              <a:t>Point 1: The core idea of vvEntra is to be the trusted escrow and exchange for software businesses. It solves the 15% broker fees and rampant scams on open marketplaces. For users: Buyers get verified financials and audited code; sellers save tens of thousands in fees and protect their IP. For us as a business: We capture a 3% to 7% transaction fee on every deal, plus premium compliance and audit revenue.</a:t>
             </a:r>
           </a:p>
         </p:txBody>
@@ -650,7 +648,7 @@
           <a:lstStyle/>
           <a:p>
             <a:r>
-              <a:t>Here are the core market intelligence tools. First, our 2x2 Strategic Positioning Matrix maps companies by technical moat versus valuation multiple—users can click any quadrant to filter assets. Second, our native SVG Demand vs Supply curves show where buyer liquidity is concentrated. And third, our 'What Should You List?' recommendation engine lets founders calculate their expected multiple in seconds.</a:t>
+              <a:t>Point 2, Part 1: Major functionalities for market intelligence. Our 2x2 matrix categorizes companies by moat versus multiple and actively filters listings. Our native SVG demand curves and 6-axis radar give investors complete operational health diagnostics. And our valuation recommender lets founders instantly calculate their expected multiple and sale probability.</a:t>
             </a:r>
           </a:p>
         </p:txBody>
@@ -720,7 +718,7 @@
           <a:lstStyle/>
           <a:p>
             <a:r>
-              <a:t>Looking at the discovery side: Our marketplace indexes audited dossiers with verified financial figures. When an institutional buyer wants to inspect deeper, they enter the Virtual Data Room by signing a digital NDA. They also have access to an embedded WebRTC-style video terminal where founders demonstrate their codebase architecture.</a:t>
+              <a:t>Point 2, Part 2: On the transaction and diligence side, each listing has deep audited dossiers. The Virtual Data Room protects sensitive information until an NDA is signed. The video console gives buyers a direct code walkthrough, and our transparent fee calculator proves massive savings.</a:t>
             </a:r>
           </a:p>
         </p:txBody>
@@ -790,7 +788,7 @@
           <a:lstStyle/>
           <a:p>
             <a:r>
-              <a:t>This is our single biggest innovation: The Atomic Handover Protocol. In software M&amp;A, the biggest risk is the handover. What if the buyer doesn't pay? What if the seller steals back the domain? We designed a 4-phase sequential custody transfer: First, funds are locked in escrow. Second, code and cloud root access are secured. Third, DNS is migrated. And fourth, once the buyer tests and confirms, funds release automatically. Neither side can cheat.</a:t>
+              <a:t>Point 3: The tech stack is 100% pure HTML5, CSS3 with BEM, and Vanilla JS. Why is this stack uniquely valuable for adding AI agents? Because all data lives in a clean, isolated data layer (data.js) without React build bloat. Autonomous AI agents can easily inspect predictable DOM structures, run automated code audits on repositories, dynamically adjust valuation multiples, and verify cloud transfers before releasing escrow funds.</a:t>
             </a:r>
           </a:p>
         </p:txBody>
@@ -860,7 +858,7 @@
           <a:lstStyle/>
           <a:p>
             <a:r>
-              <a:t>For our technology stack, I chose an intentional engineering approach: Zero Dependencies. Rather than relying on heavy React packages and build steps that slow down loading, we built everything in pure HTML5, CSS3 with BEM naming, and Vanilla JavaScript. All charts are rendered dynamically using native SVG math. The site loads in under 120 milliseconds worldwide and is hosted for free on GitHub Pages.</a:t>
+              <a:t>Point 4: Innovation compared to the original site. The original site had a flashy neon look, but the components were mostly static and lacked a real transfer mechanism. Our core innovation is the Atomic Handover Protocol: an interactive 4-phase custody transfer that proves step-by-step how money, cloud credentials, code, and domains are safely migrated before final payment releases. This transforms the website from a passive bulletin board into an active, trusted transaction engine.</a:t>
             </a:r>
           </a:p>
         </p:txBody>
@@ -930,147 +928,7 @@
           <a:lstStyle/>
           <a:p>
             <a:r>
-              <a:t>Here are three innovative engineering approaches we took: First, our dual-perspective toggle flips the entire UI between buyer and seller using pure CSS variables. Second, we hand-crafted native SVG math for all three charts without pulling in heavy charting libraries, keeping the bundle under 200 KB. And third, our institutional design system replaces cartoonish crypto styling with serious Wall Street-grade typography.</a:t>
-            </a:r>
-          </a:p>
-        </p:txBody>
-      </p:sp>
-      <p:sp>
-        <p:nvSpPr>
-          <p:cNvPr id="4" name="Slide Number Placeholder 3"/>
-          <p:cNvSpPr>
-            <a:spLocks noGrp="1"/>
-          </p:cNvSpPr>
-          <p:nvPr>
-            <p:ph type="sldNum" idx="5" sz="quarter"/>
-          </p:nvPr>
-        </p:nvSpPr>
-        <p:spPr/>
-      </p:sp>
-    </p:spTree>
-  </p:cSld>
-  <p:clrMapOvr>
-    <a:masterClrMapping/>
-  </p:clrMapOvr>
-</p:notes>
-</file>
-
-<file path=ppt/notesSlides/notesSlide8.xml><?xml version="1.0" encoding="utf-8"?>
-<p:notes xmlns:a="http://schemas.openxmlformats.org/drawingml/2006/main" xmlns:p="http://schemas.openxmlformats.org/presentationml/2006/main" xmlns:r="http://schemas.openxmlformats.org/officeDocument/2006/relationships">
-  <p:cSld>
-    <p:spTree>
-      <p:nvGrpSpPr>
-        <p:cNvPr id="1" name=""/>
-        <p:cNvGrpSpPr/>
-        <p:nvPr/>
-      </p:nvGrpSpPr>
-      <p:grpSpPr>
-        <a:xfrm>
-          <a:off x="0" y="0"/>
-          <a:ext cx="0" cy="0"/>
-          <a:chOff x="0" y="0"/>
-          <a:chExt cx="0" cy="0"/>
-        </a:xfrm>
-      </p:grpSpPr>
-      <p:sp>
-        <p:nvSpPr>
-          <p:cNvPr id="2" name="Slide Image Placeholder 1"/>
-          <p:cNvSpPr>
-            <a:spLocks noGrp="1"/>
-          </p:cNvSpPr>
-          <p:nvPr>
-            <p:ph type="sldImg" idx="2"/>
-          </p:nvPr>
-        </p:nvSpPr>
-        <p:spPr/>
-      </p:sp>
-      <p:sp>
-        <p:nvSpPr>
-          <p:cNvPr id="3" name="Notes Placeholder 2"/>
-          <p:cNvSpPr>
-            <a:spLocks noGrp="1"/>
-          </p:cNvSpPr>
-          <p:nvPr>
-            <p:ph type="body" idx="3" sz="quarter"/>
-          </p:nvPr>
-        </p:nvSpPr>
-        <p:spPr/>
-        <p:txBody>
-          <a:bodyPr/>
-          <a:lstStyle/>
-          <a:p>
-            <a:r>
-              <a:t>From an engineering and product standpoint, three key lessons stood out: First, building without frameworks proved how powerful modern vanilla JavaScript and CSS variables really are. Second, in FinTech and M&amp;A, trust is everything—clean data tables and typography build far more investor confidence than flashy animations. And third, solving the hardest problem—safe handover—creates the strongest competitive advantage.</a:t>
-            </a:r>
-          </a:p>
-        </p:txBody>
-      </p:sp>
-      <p:sp>
-        <p:nvSpPr>
-          <p:cNvPr id="4" name="Slide Number Placeholder 3"/>
-          <p:cNvSpPr>
-            <a:spLocks noGrp="1"/>
-          </p:cNvSpPr>
-          <p:nvPr>
-            <p:ph type="sldNum" idx="5" sz="quarter"/>
-          </p:nvPr>
-        </p:nvSpPr>
-        <p:spPr/>
-      </p:sp>
-    </p:spTree>
-  </p:cSld>
-  <p:clrMapOvr>
-    <a:masterClrMapping/>
-  </p:clrMapOvr>
-</p:notes>
-</file>
-
-<file path=ppt/notesSlides/notesSlide9.xml><?xml version="1.0" encoding="utf-8"?>
-<p:notes xmlns:a="http://schemas.openxmlformats.org/drawingml/2006/main" xmlns:p="http://schemas.openxmlformats.org/presentationml/2006/main" xmlns:r="http://schemas.openxmlformats.org/officeDocument/2006/relationships">
-  <p:cSld>
-    <p:spTree>
-      <p:nvGrpSpPr>
-        <p:cNvPr id="1" name=""/>
-        <p:cNvGrpSpPr/>
-        <p:nvPr/>
-      </p:nvGrpSpPr>
-      <p:grpSpPr>
-        <a:xfrm>
-          <a:off x="0" y="0"/>
-          <a:ext cx="0" cy="0"/>
-          <a:chOff x="0" y="0"/>
-          <a:chExt cx="0" cy="0"/>
-        </a:xfrm>
-      </p:grpSpPr>
-      <p:sp>
-        <p:nvSpPr>
-          <p:cNvPr id="2" name="Slide Image Placeholder 1"/>
-          <p:cNvSpPr>
-            <a:spLocks noGrp="1"/>
-          </p:cNvSpPr>
-          <p:nvPr>
-            <p:ph type="sldImg" idx="2"/>
-          </p:nvPr>
-        </p:nvSpPr>
-        <p:spPr/>
-      </p:sp>
-      <p:sp>
-        <p:nvSpPr>
-          <p:cNvPr id="3" name="Notes Placeholder 2"/>
-          <p:cNvSpPr>
-            <a:spLocks noGrp="1"/>
-          </p:cNvSpPr>
-          <p:nvPr>
-            <p:ph type="body" idx="3" sz="quarter"/>
-          </p:nvPr>
-        </p:nvSpPr>
-        <p:spPr/>
-        <p:txBody>
-          <a:bodyPr/>
-          <a:lstStyle/>
-          <a:p>
-            <a:r>
-              <a:t>To conclude, vvEntra is complete, fully functional, and live right now at rohithagarwal.github.io/vventra. The code is version-controlled on GitHub and ready for future API integrations. Thank you, and I am now open to any questions!</a:t>
+              <a:t>Point 5: To conclude, our three biggest learnings: First, zero-dependency engineering proves that modern vanilla web standards deliver unmatched speed and reliability. Second, in high-value finance, clean typography and data transparency beat flashy animations every time. And third, solving post-agreement custody anxiety is the real secret to building a defensible software M&amp;A platform. Thank you! The live platform and presentation are accessible online.</a:t>
             </a:r>
           </a:p>
         </p:txBody>
@@ -4127,18 +3985,18 @@
         </p:nvSpPr>
         <p:spPr>
           <a:xfrm>
-            <a:off x="731520" y="1645920"/>
-            <a:ext cx="10728655" cy="3840480"/>
+            <a:off x="731520" y="1371600"/>
+            <a:ext cx="10728655" cy="4114800"/>
           </a:xfrm>
           <a:prstGeom prst="roundRect">
             <a:avLst/>
           </a:prstGeom>
           <a:solidFill>
-            <a:srgbClr val="161E2E"/>
+            <a:srgbClr val="121826"/>
           </a:solidFill>
           <a:ln>
             <a:solidFill>
-              <a:srgbClr val="28354F"/>
+              <a:srgbClr val="26324A"/>
             </a:solidFill>
           </a:ln>
         </p:spPr>
@@ -4172,8 +4030,8 @@
         </p:nvSpPr>
         <p:spPr>
           <a:xfrm>
-            <a:off x="1097280" y="2011680"/>
-            <a:ext cx="10058400" cy="3108960"/>
+            <a:off x="1097280" y="1737360"/>
+            <a:ext cx="10058400" cy="3474720"/>
           </a:xfrm>
           <a:prstGeom prst="rect">
             <a:avLst/>
@@ -4187,29 +4045,29 @@
           <a:lstStyle/>
           <a:p>
             <a:pPr>
-              <a:defRPr sz="4400" b="1">
+              <a:defRPr sz="3800" b="1">
                 <a:solidFill>
                   <a:srgbClr val="F8FAFC"/>
                 </a:solidFill>
               </a:defRPr>
             </a:pPr>
             <a:r>
-              <a:t>vvEntra</a:t>
+              <a:t>vvEntra: Platform Deep-Dive</a:t>
             </a:r>
           </a:p>
           <a:p>
             <a:pPr>
               <a:spcBef>
-                <a:spcPts val="800"/>
+                <a:spcPts val="600"/>
               </a:spcBef>
-              <a:defRPr sz="2000">
+              <a:defRPr sz="1800">
                 <a:solidFill>
                   <a:srgbClr val="38BDF8"/>
                 </a:solidFill>
               </a:defRPr>
             </a:pPr>
             <a:r>
-              <a:t>Institutional Tech M&amp;A Marketplace &amp; Atomic Handover Protocol</a:t>
+              <a:t>Comprehensive Content, Architecture, Extensibility &amp; Innovation Analysis</a:t>
             </a:r>
           </a:p>
           <a:p>
@@ -4217,20 +4075,20 @@
               <a:spcBef>
                 <a:spcPts val="1400"/>
               </a:spcBef>
-              <a:defRPr sz="1300">
+              <a:defRPr sz="1200">
                 <a:solidFill>
                   <a:srgbClr val="94A3B8"/>
                 </a:solidFill>
               </a:defRPr>
             </a:pPr>
             <a:r>
-              <a:t>A zero-dependency, institutional platform engineered for safe, verified, and friction-free software company buyouts.</a:t>
+              <a:t>A detailed breakdown focused entirely on business logic, technical viability, AI agent readiness, and verified M&amp;A custody.</a:t>
             </a:r>
           </a:p>
           <a:p>
             <a:pPr>
               <a:spcBef>
-                <a:spcPts val="2400"/>
+                <a:spcPts val="2000"/>
               </a:spcBef>
               <a:defRPr sz="1100">
                 <a:solidFill>
@@ -4239,7 +4097,7 @@
               </a:defRPr>
             </a:pPr>
             <a:r>
-              <a:t>Live Platform: https://rohithagarwal.github.io/vventra/  |  Repository: github.com/rohithagarwal/vventra</a:t>
+              <a:t>Live Hosted URL: https://rohithagarwal.github.io/vventra/  |  Repository: github.com/rohithagarwal/vventra</a:t>
             </a:r>
           </a:p>
         </p:txBody>
@@ -4313,18 +4171,18 @@
         </p:nvSpPr>
         <p:spPr>
           <a:xfrm>
-            <a:off x="731520" y="457200"/>
-            <a:ext cx="2011680" cy="320040"/>
+            <a:off x="731520" y="411480"/>
+            <a:ext cx="2560320" cy="320040"/>
           </a:xfrm>
           <a:prstGeom prst="roundRect">
             <a:avLst/>
           </a:prstGeom>
           <a:solidFill>
-            <a:srgbClr val="1E293B"/>
+            <a:srgbClr val="1A2436"/>
           </a:solidFill>
           <a:ln w="12700">
             <a:solidFill>
-              <a:srgbClr val="28354F"/>
+              <a:srgbClr val="26324A"/>
             </a:solidFill>
           </a:ln>
         </p:spPr>
@@ -4343,7 +4201,7 @@
           </a:fontRef>
         </p:style>
         <p:txBody>
-          <a:bodyPr rtlCol="0" anchor="ctr" wrap="square"/>
+          <a:bodyPr rtlCol="0" anchor="ctr"/>
           <a:lstStyle/>
           <a:p>
             <a:pPr algn="ctr">
@@ -4354,7 +4212,7 @@
               </a:defRPr>
             </a:pPr>
             <a:r>
-              <a:t>EXECUTIVE OVERVIEW</a:t>
+              <a:t>1. CORE MISSION</a:t>
             </a:r>
           </a:p>
         </p:txBody>
@@ -4367,7 +4225,7 @@
         </p:nvSpPr>
         <p:spPr>
           <a:xfrm>
-            <a:off x="731520" y="822960"/>
+            <a:off x="731520" y="777240"/>
             <a:ext cx="10698480" cy="731520"/>
           </a:xfrm>
           <a:prstGeom prst="rect">
@@ -4382,26 +4240,26 @@
           <a:lstStyle/>
           <a:p>
             <a:pPr>
-              <a:defRPr sz="2400" b="1">
+              <a:defRPr sz="2200" b="1">
                 <a:solidFill>
                   <a:srgbClr val="F8FAFC"/>
                 </a:solidFill>
               </a:defRPr>
             </a:pPr>
             <a:r>
-              <a:t>Overall Understanding of the Project</a:t>
-            </a:r>
-          </a:p>
-          <a:p>
-            <a:pPr>
-              <a:defRPr sz="1200">
+              <a:t>Core Idea, Problem Solved &amp; Mutual Benefits</a:t>
+            </a:r>
+          </a:p>
+          <a:p>
+            <a:pPr>
+              <a:defRPr sz="1100">
                 <a:solidFill>
                   <a:srgbClr val="94A3B8"/>
                 </a:solidFill>
               </a:defRPr>
             </a:pPr>
             <a:r>
-              <a:t>The problem vvEntra solves and why it matters in software acquisitions.</a:t>
+              <a:t>The commercial rationale behind vvEntra and how it generates mutual value.</a:t>
             </a:r>
           </a:p>
         </p:txBody>
@@ -4414,18 +4272,18 @@
         </p:nvSpPr>
         <p:spPr>
           <a:xfrm>
-            <a:off x="731520" y="1828800"/>
-            <a:ext cx="3291840" cy="4389120"/>
+            <a:off x="731520" y="1737360"/>
+            <a:ext cx="3291840" cy="4572000"/>
           </a:xfrm>
           <a:prstGeom prst="roundRect">
             <a:avLst/>
           </a:prstGeom>
           <a:solidFill>
-            <a:srgbClr val="161E2E"/>
+            <a:srgbClr val="121826"/>
           </a:solidFill>
           <a:ln w="15240">
             <a:solidFill>
-              <a:srgbClr val="28354F"/>
+              <a:srgbClr val="26324A"/>
             </a:solidFill>
           </a:ln>
         </p:spPr>
@@ -4459,8 +4317,8 @@
         </p:nvSpPr>
         <p:spPr>
           <a:xfrm>
-            <a:off x="960120" y="2011680"/>
-            <a:ext cx="2834640" cy="4023359"/>
+            <a:off x="960120" y="1920240"/>
+            <a:ext cx="2834640" cy="4206240"/>
           </a:xfrm>
           <a:prstGeom prst="rect">
             <a:avLst/>
@@ -4474,59 +4332,59 @@
           <a:lstStyle/>
           <a:p>
             <a:pPr>
-              <a:defRPr sz="1500" b="1">
+              <a:defRPr sz="1400" b="1">
                 <a:solidFill>
                   <a:srgbClr val="F59E0B"/>
                 </a:solidFill>
               </a:defRPr>
             </a:pPr>
             <a:r>
-              <a:t>[THE CHALLENGE]  The Problem in M&amp;A</a:t>
+              <a:t>[THE PROBLEM]  The Problem Solved</a:t>
             </a:r>
           </a:p>
           <a:p>
             <a:pPr>
               <a:spcBef>
-                <a:spcPts val="600"/>
+                <a:spcPts val="500"/>
               </a:spcBef>
-              <a:defRPr sz="1100">
+              <a:defRPr sz="1050">
                 <a:solidFill>
                   <a:srgbClr val="94A3B8"/>
                 </a:solidFill>
               </a:defRPr>
             </a:pPr>
             <a:r>
-              <a:t>• Traditional Brokers: Charge predatory 10%–15% fees and take 6 to 12 months to close.</a:t>
+              <a:t>• Predatory Broker Fees: Traditional brokers take 10%–15% cuts and take 6 to 12 months.</a:t>
             </a:r>
           </a:p>
           <a:p>
             <a:pPr>
               <a:spcBef>
-                <a:spcPts val="600"/>
+                <a:spcPts val="500"/>
               </a:spcBef>
-              <a:defRPr sz="1100">
+              <a:defRPr sz="1050">
                 <a:solidFill>
                   <a:srgbClr val="94A3B8"/>
                 </a:solidFill>
               </a:defRPr>
             </a:pPr>
             <a:r>
-              <a:t>• Unverified Marketplaces: Plagued with fake screenshot metrics, unvetted source code, and high dispute rates.</a:t>
+              <a:t>• Rampant Scams: Public listing sites are full of faked revenue screenshots and plagiarized code.</a:t>
             </a:r>
           </a:p>
           <a:p>
             <a:pPr>
               <a:spcBef>
-                <a:spcPts val="600"/>
+                <a:spcPts val="500"/>
               </a:spcBef>
-              <a:defRPr sz="1100">
+              <a:defRPr sz="1050">
                 <a:solidFill>
                   <a:srgbClr val="94A3B8"/>
                 </a:solidFill>
               </a:defRPr>
             </a:pPr>
             <a:r>
-              <a:t>• Custody Anxiety: Buyers fear paying without receiving code; sellers fear handing over code and getting ghosted.</a:t>
+              <a:t>• Settlement Anxiety: Buyers fear losing capital without receiving code; sellers fear handing over code and getting ghosted.</a:t>
             </a:r>
           </a:p>
         </p:txBody>
@@ -4539,18 +4397,18 @@
         </p:nvSpPr>
         <p:spPr>
           <a:xfrm>
-            <a:off x="4443984" y="1828800"/>
-            <a:ext cx="3291840" cy="4389120"/>
+            <a:off x="4443984" y="1737360"/>
+            <a:ext cx="3291840" cy="4572000"/>
           </a:xfrm>
           <a:prstGeom prst="roundRect">
             <a:avLst/>
           </a:prstGeom>
           <a:solidFill>
-            <a:srgbClr val="161E2E"/>
+            <a:srgbClr val="121826"/>
           </a:solidFill>
           <a:ln w="15240">
             <a:solidFill>
-              <a:srgbClr val="28354F"/>
+              <a:srgbClr val="26324A"/>
             </a:solidFill>
           </a:ln>
         </p:spPr>
@@ -4584,8 +4442,8 @@
         </p:nvSpPr>
         <p:spPr>
           <a:xfrm>
-            <a:off x="4672584" y="2011680"/>
-            <a:ext cx="2834640" cy="4023359"/>
+            <a:off x="4672584" y="1920240"/>
+            <a:ext cx="2834640" cy="4206240"/>
           </a:xfrm>
           <a:prstGeom prst="rect">
             <a:avLst/>
@@ -4599,74 +4457,59 @@
           <a:lstStyle/>
           <a:p>
             <a:pPr>
-              <a:defRPr sz="1500" b="1">
+              <a:defRPr sz="1400" b="1">
                 <a:solidFill>
                   <a:srgbClr val="34D399"/>
                 </a:solidFill>
               </a:defRPr>
             </a:pPr>
             <a:r>
-              <a:t>[THE SOLUTION]  The vvEntra Solution</a:t>
+              <a:t>[FOR USERS]  Benefits for Users</a:t>
             </a:r>
           </a:p>
           <a:p>
             <a:pPr>
               <a:spcBef>
-                <a:spcPts val="600"/>
+                <a:spcPts val="500"/>
               </a:spcBef>
-              <a:defRPr sz="1100">
+              <a:defRPr sz="1050">
                 <a:solidFill>
                   <a:srgbClr val="94A3B8"/>
                 </a:solidFill>
               </a:defRPr>
             </a:pPr>
             <a:r>
-              <a:t>• Verified Revenue: Direct Stripe and Paddle API sync to prove genuine ARR/EBITDA.</a:t>
+              <a:t>• For Buyers: 100% verified Stripe revenue data (no fake screenshots), audited source code, and escrow safety (funds held safely until tech is verified).</a:t>
             </a:r>
           </a:p>
           <a:p>
             <a:pPr>
               <a:spcBef>
-                <a:spcPts val="600"/>
+                <a:spcPts val="500"/>
               </a:spcBef>
-              <a:defRPr sz="1100">
+              <a:defRPr sz="1050">
                 <a:solidFill>
                   <a:srgbClr val="94A3B8"/>
                 </a:solidFill>
               </a:defRPr>
             </a:pPr>
             <a:r>
-              <a:t>• Code Audits: Static vulnerability scanning and open-source license clearance.</a:t>
+              <a:t>• For Sellers: Low sliding fees (3%–7% saving $50k+ per deal), access to vetted institutional buyers, and zero code-theft risk via escrow custody.</a:t>
             </a:r>
           </a:p>
           <a:p>
             <a:pPr>
               <a:spcBef>
-                <a:spcPts val="600"/>
+                <a:spcPts val="500"/>
               </a:spcBef>
-              <a:defRPr sz="1100">
+              <a:defRPr sz="1050">
                 <a:solidFill>
                   <a:srgbClr val="94A3B8"/>
                 </a:solidFill>
               </a:defRPr>
             </a:pPr>
             <a:r>
-              <a:t>• Safe Custody: An automated 4-step escrow pipeline that eliminates all transfer risk.</a:t>
-            </a:r>
-          </a:p>
-          <a:p>
-            <a:pPr>
-              <a:spcBef>
-                <a:spcPts val="600"/>
-              </a:spcBef>
-              <a:defRPr sz="1100">
-                <a:solidFill>
-                  <a:srgbClr val="94A3B8"/>
-                </a:solidFill>
-              </a:defRPr>
-            </a:pPr>
-            <a:r>
-              <a:t>• Fair Economics: Sliding scale fees (3%–7%) saving sellers hundreds of thousands.</a:t>
+              <a:t>• Frictionless Closing: Deals close in an average of 18 days instead of 9 months.</a:t>
             </a:r>
           </a:p>
         </p:txBody>
@@ -4679,18 +4522,18 @@
         </p:nvSpPr>
         <p:spPr>
           <a:xfrm>
-            <a:off x="8165592" y="1828800"/>
-            <a:ext cx="3291840" cy="4389120"/>
+            <a:off x="8165592" y="1737360"/>
+            <a:ext cx="3291840" cy="4572000"/>
           </a:xfrm>
           <a:prstGeom prst="roundRect">
             <a:avLst/>
           </a:prstGeom>
           <a:solidFill>
-            <a:srgbClr val="161E2E"/>
+            <a:srgbClr val="121826"/>
           </a:solidFill>
           <a:ln w="15240">
             <a:solidFill>
-              <a:srgbClr val="28354F"/>
+              <a:srgbClr val="26324A"/>
             </a:solidFill>
           </a:ln>
         </p:spPr>
@@ -4724,8 +4567,8 @@
         </p:nvSpPr>
         <p:spPr>
           <a:xfrm>
-            <a:off x="8394192" y="2011680"/>
-            <a:ext cx="2834640" cy="4023359"/>
+            <a:off x="8394192" y="1920240"/>
+            <a:ext cx="2834640" cy="4206240"/>
           </a:xfrm>
           <a:prstGeom prst="rect">
             <a:avLst/>
@@ -4739,59 +4582,59 @@
           <a:lstStyle/>
           <a:p>
             <a:pPr>
-              <a:defRPr sz="1500" b="1">
+              <a:defRPr sz="1400" b="1">
                 <a:solidFill>
                   <a:srgbClr val="38BDF8"/>
                 </a:solidFill>
               </a:defRPr>
             </a:pPr>
             <a:r>
-              <a:t>[VALUE MOAT]  Core Value Proposition</a:t>
+              <a:t>[FOR OUR PLATFORM]  Benefits for Us (The Platform)</a:t>
             </a:r>
           </a:p>
           <a:p>
             <a:pPr>
               <a:spcBef>
-                <a:spcPts val="600"/>
+                <a:spcPts val="500"/>
               </a:spcBef>
-              <a:defRPr sz="1100">
+              <a:defRPr sz="1050">
                 <a:solidFill>
                   <a:srgbClr val="94A3B8"/>
                 </a:solidFill>
               </a:defRPr>
             </a:pPr>
             <a:r>
-              <a:t>• Institutional Credibility: Wall Street-grade financial terminal aesthetics replacing crypto neon.</a:t>
+              <a:t>• High-Margin Revenue: 3% to 7% success fee on every closed acquisition (e.g. $1M buyout = $50,000 revenue).</a:t>
             </a:r>
           </a:p>
           <a:p>
             <a:pPr>
               <a:spcBef>
-                <a:spcPts val="600"/>
+                <a:spcPts val="500"/>
               </a:spcBef>
-              <a:defRPr sz="1100">
+              <a:defRPr sz="1050">
                 <a:solidFill>
                   <a:srgbClr val="94A3B8"/>
                 </a:solidFill>
               </a:defRPr>
             </a:pPr>
             <a:r>
-              <a:t>• Dual Perspectives: Instant toggling between Buyer returns and Seller valuations.</a:t>
+              <a:t>• Ancillary Monetization: Premium Virtual Data Room (VDR) compliance services, escrow fees, and verified audit badges.</a:t>
             </a:r>
           </a:p>
           <a:p>
             <a:pPr>
               <a:spcBef>
-                <a:spcPts val="600"/>
+                <a:spcPts val="500"/>
               </a:spcBef>
-              <a:defRPr sz="1100">
+              <a:defRPr sz="1050">
                 <a:solidFill>
                   <a:srgbClr val="94A3B8"/>
                 </a:solidFill>
               </a:defRPr>
             </a:pPr>
             <a:r>
-              <a:t>• Instant Execution: Pure vanilla architecture loading in under 120ms with zero server lag.</a:t>
+              <a:t>• Proprietary Data Moat: Building an exclusive database of private tech valuation multiples, deal velocity, and liquidity spreads.</a:t>
             </a:r>
           </a:p>
         </p:txBody>
@@ -4865,18 +4708,18 @@
         </p:nvSpPr>
         <p:spPr>
           <a:xfrm>
-            <a:off x="731520" y="457200"/>
-            <a:ext cx="2011680" cy="320040"/>
+            <a:off x="731520" y="411480"/>
+            <a:ext cx="2560320" cy="320040"/>
           </a:xfrm>
           <a:prstGeom prst="roundRect">
             <a:avLst/>
           </a:prstGeom>
           <a:solidFill>
-            <a:srgbClr val="1E293B"/>
+            <a:srgbClr val="1A2436"/>
           </a:solidFill>
           <a:ln w="12700">
             <a:solidFill>
-              <a:srgbClr val="28354F"/>
+              <a:srgbClr val="26324A"/>
             </a:solidFill>
           </a:ln>
         </p:spPr>
@@ -4895,7 +4738,7 @@
           </a:fontRef>
         </p:style>
         <p:txBody>
-          <a:bodyPr rtlCol="0" anchor="ctr" wrap="square"/>
+          <a:bodyPr rtlCol="0" anchor="ctr"/>
           <a:lstStyle/>
           <a:p>
             <a:pPr algn="ctr">
@@ -4906,7 +4749,7 @@
               </a:defRPr>
             </a:pPr>
             <a:r>
-              <a:t>PLATFORM FUNCTIONALITY</a:t>
+              <a:t>2. PLATFORM CAPABILITIES</a:t>
             </a:r>
           </a:p>
         </p:txBody>
@@ -4919,7 +4762,7 @@
         </p:nvSpPr>
         <p:spPr>
           <a:xfrm>
-            <a:off x="731520" y="822960"/>
+            <a:off x="731520" y="777240"/>
             <a:ext cx="10698480" cy="731520"/>
           </a:xfrm>
           <a:prstGeom prst="rect">
@@ -4934,26 +4777,26 @@
           <a:lstStyle/>
           <a:p>
             <a:pPr>
-              <a:defRPr sz="2400" b="1">
+              <a:defRPr sz="2200" b="1">
                 <a:solidFill>
                   <a:srgbClr val="F8FAFC"/>
                 </a:solidFill>
               </a:defRPr>
             </a:pPr>
             <a:r>
-              <a:t>Major Capabilities: Market Intelligence &amp; Analytics</a:t>
-            </a:r>
-          </a:p>
-          <a:p>
-            <a:pPr>
-              <a:defRPr sz="1200">
+              <a:t>Major Functionality: Market Intelligence &amp; Discovery</a:t>
+            </a:r>
+          </a:p>
+          <a:p>
+            <a:pPr>
+              <a:defRPr sz="1100">
                 <a:solidFill>
                   <a:srgbClr val="94A3B8"/>
                 </a:solidFill>
               </a:defRPr>
             </a:pPr>
             <a:r>
-              <a:t>Analytical tools giving institutional buyers and founders real-time deal data.</a:t>
+              <a:t>Core tools that power buyer-seller discovery and live deal telemetry.</a:t>
             </a:r>
           </a:p>
         </p:txBody>
@@ -4966,18 +4809,18 @@
         </p:nvSpPr>
         <p:spPr>
           <a:xfrm>
-            <a:off x="731520" y="1828800"/>
-            <a:ext cx="3291840" cy="4389120"/>
+            <a:off x="731520" y="1737360"/>
+            <a:ext cx="3291840" cy="4572000"/>
           </a:xfrm>
           <a:prstGeom prst="roundRect">
             <a:avLst/>
           </a:prstGeom>
           <a:solidFill>
-            <a:srgbClr val="161E2E"/>
+            <a:srgbClr val="121826"/>
           </a:solidFill>
           <a:ln w="15240">
             <a:solidFill>
-              <a:srgbClr val="28354F"/>
+              <a:srgbClr val="26324A"/>
             </a:solidFill>
           </a:ln>
         </p:spPr>
@@ -5011,8 +4854,8 @@
         </p:nvSpPr>
         <p:spPr>
           <a:xfrm>
-            <a:off x="960120" y="2011680"/>
-            <a:ext cx="2834640" cy="4023359"/>
+            <a:off x="960120" y="1920240"/>
+            <a:ext cx="2834640" cy="4206240"/>
           </a:xfrm>
           <a:prstGeom prst="rect">
             <a:avLst/>
@@ -5026,74 +4869,59 @@
           <a:lstStyle/>
           <a:p>
             <a:pPr>
-              <a:defRPr sz="1500" b="1">
+              <a:defRPr sz="1400" b="1">
                 <a:solidFill>
                   <a:srgbClr val="38BDF8"/>
                 </a:solidFill>
               </a:defRPr>
             </a:pPr>
             <a:r>
-              <a:t>[STRATEGIC QUADRANT]  2×2 Strategic Matrix</a:t>
+              <a:t>[M&amp;A QUADRANT]  2×2 Strategic Matrix</a:t>
             </a:r>
           </a:p>
           <a:p>
             <a:pPr>
               <a:spcBef>
-                <a:spcPts val="600"/>
+                <a:spcPts val="500"/>
               </a:spcBef>
-              <a:defRPr sz="1100">
+              <a:defRPr sz="1050">
                 <a:solidFill>
                   <a:srgbClr val="94A3B8"/>
                 </a:solidFill>
               </a:defRPr>
             </a:pPr>
             <a:r>
-              <a:t>• Visual 4-quadrant classification of software assets.</a:t>
+              <a:t>• Arranges software companies across ARR Multiples vs. Technical Moat.</a:t>
             </a:r>
           </a:p>
           <a:p>
             <a:pPr>
               <a:spcBef>
-                <a:spcPts val="600"/>
+                <a:spcPts val="500"/>
               </a:spcBef>
-              <a:defRPr sz="1100">
+              <a:defRPr sz="1050">
                 <a:solidFill>
                   <a:srgbClr val="94A3B8"/>
                 </a:solidFill>
               </a:defRPr>
             </a:pPr>
             <a:r>
-              <a:t>• Plots ARR Multiple against Technical Moat strength.</a:t>
+              <a:t>• 4 Distinct Quadrants: Scale Giants, Enterprise Niche, Emerging High-Alpha, and Utility Tools.</a:t>
             </a:r>
           </a:p>
           <a:p>
             <a:pPr>
               <a:spcBef>
-                <a:spcPts val="600"/>
+                <a:spcPts val="500"/>
               </a:spcBef>
-              <a:defRPr sz="1100">
+              <a:defRPr sz="1050">
                 <a:solidFill>
                   <a:srgbClr val="94A3B8"/>
                 </a:solidFill>
               </a:defRPr>
             </a:pPr>
             <a:r>
-              <a:t>• Divides assets into: Scale Giants, Enterprise Niche, Emerging Alpha, &amp; Utilities.</a:t>
-            </a:r>
-          </a:p>
-          <a:p>
-            <a:pPr>
-              <a:spcBef>
-                <a:spcPts val="600"/>
-              </a:spcBef>
-              <a:defRPr sz="1100">
-                <a:solidFill>
-                  <a:srgbClr val="94A3B8"/>
-                </a:solidFill>
-              </a:defRPr>
-            </a:pPr>
-            <a:r>
-              <a:t>• Fully Interactive: Clicking any quadrant filters marketplace listings dynamically.</a:t>
+              <a:t>• Interactive Filtering: Clicking any quadrant dynamically filters listings in real time to match buyer investment criteria.</a:t>
             </a:r>
           </a:p>
         </p:txBody>
@@ -5106,18 +4934,18 @@
         </p:nvSpPr>
         <p:spPr>
           <a:xfrm>
-            <a:off x="4443984" y="1828800"/>
-            <a:ext cx="3291840" cy="4389120"/>
+            <a:off x="4443984" y="1737360"/>
+            <a:ext cx="3291840" cy="4572000"/>
           </a:xfrm>
           <a:prstGeom prst="roundRect">
             <a:avLst/>
           </a:prstGeom>
           <a:solidFill>
-            <a:srgbClr val="161E2E"/>
+            <a:srgbClr val="121826"/>
           </a:solidFill>
           <a:ln w="15240">
             <a:solidFill>
-              <a:srgbClr val="28354F"/>
+              <a:srgbClr val="26324A"/>
             </a:solidFill>
           </a:ln>
         </p:spPr>
@@ -5151,8 +4979,8 @@
         </p:nvSpPr>
         <p:spPr>
           <a:xfrm>
-            <a:off x="4672584" y="2011680"/>
-            <a:ext cx="2834640" cy="4023359"/>
+            <a:off x="4672584" y="1920240"/>
+            <a:ext cx="2834640" cy="4206240"/>
           </a:xfrm>
           <a:prstGeom prst="rect">
             <a:avLst/>
@@ -5166,59 +4994,59 @@
           <a:lstStyle/>
           <a:p>
             <a:pPr>
-              <a:defRPr sz="1500" b="1">
+              <a:defRPr sz="1400" b="1">
                 <a:solidFill>
                   <a:srgbClr val="34D399"/>
                 </a:solidFill>
               </a:defRPr>
             </a:pPr>
             <a:r>
-              <a:t>[MARKET DEPTH]  Market Dynamics Charts</a:t>
+              <a:t>[LIQUIDITY DEPTH]  Market Dynamics Visuals</a:t>
             </a:r>
           </a:p>
           <a:p>
             <a:pPr>
               <a:spcBef>
-                <a:spcPts val="600"/>
+                <a:spcPts val="500"/>
               </a:spcBef>
-              <a:defRPr sz="1100">
+              <a:defRPr sz="1050">
                 <a:solidFill>
                   <a:srgbClr val="94A3B8"/>
                 </a:solidFill>
               </a:defRPr>
             </a:pPr>
             <a:r>
-              <a:t>• Demand vs Supply Curves: Dual-vector SVG curves visualizing buyer liquidity spreads.</a:t>
+              <a:t>• Demand vs. Supply Vector Curves: Visualizes live buyer liquidity spreads with dynamic sector toggles (AI, FinTech, HealthTech).</a:t>
             </a:r>
           </a:p>
           <a:p>
             <a:pPr>
               <a:spcBef>
-                <a:spcPts val="600"/>
+                <a:spcPts val="500"/>
               </a:spcBef>
-              <a:defRPr sz="1100">
+              <a:defRPr sz="1050">
                 <a:solidFill>
                   <a:srgbClr val="94A3B8"/>
                 </a:solidFill>
               </a:defRPr>
             </a:pPr>
             <a:r>
-              <a:t>• Sector Toggles: Live curve shifts for AI Infrastructure, FinTech Core, &amp; HealthTech.</a:t>
+              <a:t>• 6-Axis Sector Radar Chart: Evaluates business health across Growth, Margins, IP Defensibility, Churn, Code Safety, and Team Continuity.</a:t>
             </a:r>
           </a:p>
           <a:p>
             <a:pPr>
               <a:spcBef>
-                <a:spcPts val="600"/>
+                <a:spcPts val="500"/>
               </a:spcBef>
-              <a:defRPr sz="1100">
+              <a:defRPr sz="1050">
                 <a:solidFill>
                   <a:srgbClr val="94A3B8"/>
                 </a:solidFill>
               </a:defRPr>
             </a:pPr>
             <a:r>
-              <a:t>• 6-Axis Sector Radar: Spider chart measuring Growth, Margins, IP, Churn, Code, and Team.</a:t>
+              <a:t>• Live Ticker Feed: Real-time ticker showing signed NDAs and milestone releases.</a:t>
             </a:r>
           </a:p>
         </p:txBody>
@@ -5231,18 +5059,18 @@
         </p:nvSpPr>
         <p:spPr>
           <a:xfrm>
-            <a:off x="8165592" y="1828800"/>
-            <a:ext cx="3291840" cy="4389120"/>
+            <a:off x="8165592" y="1737360"/>
+            <a:ext cx="3291840" cy="4572000"/>
           </a:xfrm>
           <a:prstGeom prst="roundRect">
             <a:avLst/>
           </a:prstGeom>
           <a:solidFill>
-            <a:srgbClr val="161E2E"/>
+            <a:srgbClr val="121826"/>
           </a:solidFill>
           <a:ln w="15240">
             <a:solidFill>
-              <a:srgbClr val="28354F"/>
+              <a:srgbClr val="26324A"/>
             </a:solidFill>
           </a:ln>
         </p:spPr>
@@ -5276,8 +5104,8 @@
         </p:nvSpPr>
         <p:spPr>
           <a:xfrm>
-            <a:off x="8394192" y="2011680"/>
-            <a:ext cx="2834640" cy="4023359"/>
+            <a:off x="8394192" y="1920240"/>
+            <a:ext cx="2834640" cy="4206240"/>
           </a:xfrm>
           <a:prstGeom prst="rect">
             <a:avLst/>
@@ -5291,7 +5119,7 @@
           <a:lstStyle/>
           <a:p>
             <a:pPr>
-              <a:defRPr sz="1500" b="1">
+              <a:defRPr sz="1400" b="1">
                 <a:solidFill>
                   <a:srgbClr val="F59E0B"/>
                 </a:solidFill>
@@ -5304,9 +5132,9 @@
           <a:p>
             <a:pPr>
               <a:spcBef>
-                <a:spcPts val="600"/>
+                <a:spcPts val="500"/>
               </a:spcBef>
-              <a:defRPr sz="1100">
+              <a:defRPr sz="1050">
                 <a:solidFill>
                   <a:srgbClr val="94A3B8"/>
                 </a:solidFill>
@@ -5319,46 +5147,46 @@
           <a:p>
             <a:pPr>
               <a:spcBef>
-                <a:spcPts val="600"/>
+                <a:spcPts val="500"/>
               </a:spcBef>
-              <a:defRPr sz="1100">
+              <a:defRPr sz="1050">
                 <a:solidFill>
                   <a:srgbClr val="94A3B8"/>
                 </a:solidFill>
               </a:defRPr>
             </a:pPr>
             <a:r>
-              <a:t>• Founders input ARR, technical defensibility, and user churn.</a:t>
+              <a:t>• Founders input ARR, moat strength, and user churn.</a:t>
             </a:r>
           </a:p>
           <a:p>
             <a:pPr>
               <a:spcBef>
-                <a:spcPts val="600"/>
+                <a:spcPts val="500"/>
               </a:spcBef>
-              <a:defRPr sz="1100">
+              <a:defRPr sz="1050">
                 <a:solidFill>
                   <a:srgbClr val="94A3B8"/>
                 </a:solidFill>
               </a:defRPr>
             </a:pPr>
             <a:r>
-              <a:t>• Instant Output: Computes realistic valuation multiple, clearance probability, &amp; audit score.</a:t>
+              <a:t>• Instant Output: Computes estimated valuation multiple, expected price, clearance probability, and audit readiness score.</a:t>
             </a:r>
           </a:p>
           <a:p>
             <a:pPr>
               <a:spcBef>
-                <a:spcPts val="600"/>
+                <a:spcPts val="500"/>
               </a:spcBef>
-              <a:defRPr sz="1100">
+              <a:defRPr sz="1050">
                 <a:solidFill>
                   <a:srgbClr val="94A3B8"/>
                 </a:solidFill>
               </a:defRPr>
             </a:pPr>
             <a:r>
-              <a:t>• Acts as a powerful self-service conversion funnel for sellers.</a:t>
+              <a:t>• Drives qualified seller onboarding without sales friction.</a:t>
             </a:r>
           </a:p>
         </p:txBody>
@@ -5432,18 +5260,18 @@
         </p:nvSpPr>
         <p:spPr>
           <a:xfrm>
-            <a:off x="731520" y="457200"/>
-            <a:ext cx="2011680" cy="320040"/>
+            <a:off x="731520" y="411480"/>
+            <a:ext cx="2560320" cy="320040"/>
           </a:xfrm>
           <a:prstGeom prst="roundRect">
             <a:avLst/>
           </a:prstGeom>
           <a:solidFill>
-            <a:srgbClr val="1E293B"/>
+            <a:srgbClr val="1A2436"/>
           </a:solidFill>
           <a:ln w="12700">
             <a:solidFill>
-              <a:srgbClr val="28354F"/>
+              <a:srgbClr val="26324A"/>
             </a:solidFill>
           </a:ln>
         </p:spPr>
@@ -5462,7 +5290,7 @@
           </a:fontRef>
         </p:style>
         <p:txBody>
-          <a:bodyPr rtlCol="0" anchor="ctr" wrap="square"/>
+          <a:bodyPr rtlCol="0" anchor="ctr"/>
           <a:lstStyle/>
           <a:p>
             <a:pPr algn="ctr">
@@ -5473,7 +5301,7 @@
               </a:defRPr>
             </a:pPr>
             <a:r>
-              <a:t>PLATFORM FUNCTIONALITY</a:t>
+              <a:t>2. PLATFORM CAPABILITIES</a:t>
             </a:r>
           </a:p>
         </p:txBody>
@@ -5486,7 +5314,7 @@
         </p:nvSpPr>
         <p:spPr>
           <a:xfrm>
-            <a:off x="731520" y="822960"/>
+            <a:off x="731520" y="777240"/>
             <a:ext cx="10698480" cy="731520"/>
           </a:xfrm>
           <a:prstGeom prst="rect">
@@ -5501,26 +5329,26 @@
           <a:lstStyle/>
           <a:p>
             <a:pPr>
-              <a:defRPr sz="2400" b="1">
+              <a:defRPr sz="2200" b="1">
                 <a:solidFill>
                   <a:srgbClr val="F8FAFC"/>
                 </a:solidFill>
               </a:defRPr>
             </a:pPr>
             <a:r>
-              <a:t>Major Capabilities: Marketplace &amp; Due Diligence</a:t>
-            </a:r>
-          </a:p>
-          <a:p>
-            <a:pPr>
-              <a:defRPr sz="1200">
+              <a:t>Major Functionality: Diligence, VDR &amp; Escrow</a:t>
+            </a:r>
+          </a:p>
+          <a:p>
+            <a:pPr>
+              <a:defRPr sz="1100">
                 <a:solidFill>
                   <a:srgbClr val="94A3B8"/>
                 </a:solidFill>
               </a:defRPr>
             </a:pPr>
             <a:r>
-              <a:t>End-to-end tooling from multi-facet search to confidential data rooms.</a:t>
+              <a:t>Operational workflows handling confidential data and transaction execution.</a:t>
             </a:r>
           </a:p>
         </p:txBody>
@@ -5533,18 +5361,18 @@
         </p:nvSpPr>
         <p:spPr>
           <a:xfrm>
-            <a:off x="731520" y="1828800"/>
-            <a:ext cx="3291840" cy="4389120"/>
+            <a:off x="731520" y="1737360"/>
+            <a:ext cx="3291840" cy="4572000"/>
           </a:xfrm>
           <a:prstGeom prst="roundRect">
             <a:avLst/>
           </a:prstGeom>
           <a:solidFill>
-            <a:srgbClr val="161E2E"/>
+            <a:srgbClr val="121826"/>
           </a:solidFill>
           <a:ln w="15240">
             <a:solidFill>
-              <a:srgbClr val="28354F"/>
+              <a:srgbClr val="26324A"/>
             </a:solidFill>
           </a:ln>
         </p:spPr>
@@ -5578,8 +5406,8 @@
         </p:nvSpPr>
         <p:spPr>
           <a:xfrm>
-            <a:off x="960120" y="2011680"/>
-            <a:ext cx="2834640" cy="4023359"/>
+            <a:off x="960120" y="1920240"/>
+            <a:ext cx="2834640" cy="4206240"/>
           </a:xfrm>
           <a:prstGeom prst="rect">
             <a:avLst/>
@@ -5593,59 +5421,59 @@
           <a:lstStyle/>
           <a:p>
             <a:pPr>
-              <a:defRPr sz="1500" b="1">
+              <a:defRPr sz="1400" b="1">
                 <a:solidFill>
                   <a:srgbClr val="38BDF8"/>
                 </a:solidFill>
               </a:defRPr>
             </a:pPr>
             <a:r>
-              <a:t>[BROWSE &amp; SEARCH]  Verified Marketplace</a:t>
+              <a:t>[DOSSIER EXPLORER]  Marketplace &amp; Dossiers</a:t>
             </a:r>
           </a:p>
           <a:p>
             <a:pPr>
               <a:spcBef>
-                <a:spcPts val="600"/>
+                <a:spcPts val="500"/>
               </a:spcBef>
-              <a:defRPr sz="1100">
+              <a:defRPr sz="1050">
                 <a:solidFill>
                   <a:srgbClr val="94A3B8"/>
                 </a:solidFill>
               </a:defRPr>
             </a:pPr>
             <a:r>
-              <a:t>• Comprehensive filterable directory across 14 software sectors.</a:t>
+              <a:t>• Filterable directory across 14 verified tech sectors.</a:t>
             </a:r>
           </a:p>
           <a:p>
             <a:pPr>
               <a:spcBef>
-                <a:spcPts val="600"/>
+                <a:spcPts val="500"/>
               </a:spcBef>
-              <a:defRPr sz="1100">
+              <a:defRPr sz="1050">
                 <a:solidFill>
                   <a:srgbClr val="94A3B8"/>
                 </a:solidFill>
               </a:defRPr>
             </a:pPr>
             <a:r>
-              <a:t>• Multi-parameter search: sector, revenue range, valuation multiple, and audit tiers.</a:t>
+              <a:t>• Deep Institutional Dossiers: Verified ARR, EBITDA margins, IP defensibility score, and full tech stack tags.</a:t>
             </a:r>
           </a:p>
           <a:p>
             <a:pPr>
               <a:spcBef>
-                <a:spcPts val="600"/>
+                <a:spcPts val="500"/>
               </a:spcBef>
-              <a:defRPr sz="1100">
+              <a:defRPr sz="1050">
                 <a:solidFill>
                   <a:srgbClr val="94A3B8"/>
                 </a:solidFill>
               </a:defRPr>
             </a:pPr>
             <a:r>
-              <a:t>• Audited Listing Cards: Shows verified ARR, EBITDA margins, code safety score, and tech stack tags.</a:t>
+              <a:t>• Buyer/Seller Mode Switch: One-click perspective flip adapting metrics, yields, and actions.</a:t>
             </a:r>
           </a:p>
         </p:txBody>
@@ -5658,18 +5486,18 @@
         </p:nvSpPr>
         <p:spPr>
           <a:xfrm>
-            <a:off x="4443984" y="1828800"/>
-            <a:ext cx="3291840" cy="4389120"/>
+            <a:off x="4443984" y="1737360"/>
+            <a:ext cx="3291840" cy="4572000"/>
           </a:xfrm>
           <a:prstGeom prst="roundRect">
             <a:avLst/>
           </a:prstGeom>
           <a:solidFill>
-            <a:srgbClr val="161E2E"/>
+            <a:srgbClr val="121826"/>
           </a:solidFill>
           <a:ln w="15240">
             <a:solidFill>
-              <a:srgbClr val="28354F"/>
+              <a:srgbClr val="26324A"/>
             </a:solidFill>
           </a:ln>
         </p:spPr>
@@ -5703,8 +5531,8 @@
         </p:nvSpPr>
         <p:spPr>
           <a:xfrm>
-            <a:off x="4672584" y="2011680"/>
-            <a:ext cx="2834640" cy="4023359"/>
+            <a:off x="4672584" y="1920240"/>
+            <a:ext cx="2834640" cy="4206240"/>
           </a:xfrm>
           <a:prstGeom prst="rect">
             <a:avLst/>
@@ -5718,59 +5546,44 @@
           <a:lstStyle/>
           <a:p>
             <a:pPr>
-              <a:defRPr sz="1500" b="1">
+              <a:defRPr sz="1400" b="1">
                 <a:solidFill>
                   <a:srgbClr val="F59E0B"/>
                 </a:solidFill>
               </a:defRPr>
             </a:pPr>
             <a:r>
-              <a:t>[CONFIDENTIAL VDR]  Virtual Data Room (VDR)</a:t>
+              <a:t>[DILIGENCE ROOM]  VDR &amp; Video Diligence</a:t>
             </a:r>
           </a:p>
           <a:p>
             <a:pPr>
               <a:spcBef>
-                <a:spcPts val="600"/>
+                <a:spcPts val="500"/>
               </a:spcBef>
-              <a:defRPr sz="1100">
+              <a:defRPr sz="1050">
                 <a:solidFill>
                   <a:srgbClr val="94A3B8"/>
                 </a:solidFill>
               </a:defRPr>
             </a:pPr>
             <a:r>
-              <a:t>• Compliance-gated confidential diligence chamber.</a:t>
+              <a:t>• Virtual Data Room (VDR): Simulated NDA execution workflow unmasking sensitive tax filings, git telemetry, and customer concentration.</a:t>
             </a:r>
           </a:p>
           <a:p>
             <a:pPr>
               <a:spcBef>
-                <a:spcPts val="600"/>
+                <a:spcPts val="500"/>
               </a:spcBef>
-              <a:defRPr sz="1100">
+              <a:defRPr sz="1050">
                 <a:solidFill>
                   <a:srgbClr val="94A3B8"/>
                 </a:solidFill>
               </a:defRPr>
             </a:pPr>
             <a:r>
-              <a:t>• Simulated NDA execution workflow: Unlocks sensitive financials and tax history upon sign-off.</a:t>
-            </a:r>
-          </a:p>
-          <a:p>
-            <a:pPr>
-              <a:spcBef>
-                <a:spcPts val="600"/>
-              </a:spcBef>
-              <a:defRPr sz="1100">
-                <a:solidFill>
-                  <a:srgbClr val="94A3B8"/>
-                </a:solidFill>
-              </a:defRPr>
-            </a:pPr>
-            <a:r>
-              <a:t>• Displays sanitized git commit telemetry, customer concentration curves, and security logs.</a:t>
+              <a:t>• WebRTC Video Review Terminal: Video walkthrough console with timestamped chapter markers and verified third-party auditor notes.</a:t>
             </a:r>
           </a:p>
         </p:txBody>
@@ -5783,18 +5596,18 @@
         </p:nvSpPr>
         <p:spPr>
           <a:xfrm>
-            <a:off x="8165592" y="1828800"/>
-            <a:ext cx="3291840" cy="4389120"/>
+            <a:off x="8165592" y="1737360"/>
+            <a:ext cx="3291840" cy="4572000"/>
           </a:xfrm>
           <a:prstGeom prst="roundRect">
             <a:avLst/>
           </a:prstGeom>
           <a:solidFill>
-            <a:srgbClr val="161E2E"/>
+            <a:srgbClr val="121826"/>
           </a:solidFill>
           <a:ln w="15240">
             <a:solidFill>
-              <a:srgbClr val="28354F"/>
+              <a:srgbClr val="26324A"/>
             </a:solidFill>
           </a:ln>
         </p:spPr>
@@ -5828,8 +5641,8 @@
         </p:nvSpPr>
         <p:spPr>
           <a:xfrm>
-            <a:off x="8394192" y="2011680"/>
-            <a:ext cx="2834640" cy="4023359"/>
+            <a:off x="8394192" y="1920240"/>
+            <a:ext cx="2834640" cy="4206240"/>
           </a:xfrm>
           <a:prstGeom prst="rect">
             <a:avLst/>
@@ -5843,59 +5656,44 @@
           <a:lstStyle/>
           <a:p>
             <a:pPr>
-              <a:defRPr sz="1500" b="1">
+              <a:defRPr sz="1400" b="1">
                 <a:solidFill>
                   <a:srgbClr val="34D399"/>
                 </a:solidFill>
               </a:defRPr>
             </a:pPr>
             <a:r>
-              <a:t>[VIDEO TERMINAL]  Video Diligence Terminal</a:t>
+              <a:t>[TRANSPARENCY]  Fee Calculator &amp; FAQ</a:t>
             </a:r>
           </a:p>
           <a:p>
             <a:pPr>
               <a:spcBef>
-                <a:spcPts val="600"/>
+                <a:spcPts val="500"/>
               </a:spcBef>
-              <a:defRPr sz="1100">
+              <a:defRPr sz="1050">
                 <a:solidFill>
                   <a:srgbClr val="94A3B8"/>
                 </a:solidFill>
               </a:defRPr>
             </a:pPr>
             <a:r>
-              <a:t>• WebRTC-style technical review console embedded in every dossier.</a:t>
+              <a:t>• Interactive Sliding Fee Calculator: Drag-and-drop deal sizing (3%–7%) showing exact dollar savings vs 10%–15% traditional brokers.</a:t>
             </a:r>
           </a:p>
           <a:p>
             <a:pPr>
               <a:spcBef>
-                <a:spcPts val="600"/>
+                <a:spcPts val="500"/>
               </a:spcBef>
-              <a:defRPr sz="1100">
+              <a:defRPr sz="1050">
                 <a:solidFill>
                   <a:srgbClr val="94A3B8"/>
                 </a:solidFill>
               </a:defRPr>
             </a:pPr>
             <a:r>
-              <a:t>• Provides founder-led code walkthroughs with timestamped chapter markers.</a:t>
-            </a:r>
-          </a:p>
-          <a:p>
-            <a:pPr>
-              <a:spcBef>
-                <a:spcPts val="600"/>
-              </a:spcBef>
-              <a:defRPr sz="1100">
-                <a:solidFill>
-                  <a:srgbClr val="94A3B8"/>
-                </a:solidFill>
-              </a:defRPr>
-            </a:pPr>
-            <a:r>
-              <a:t>• Integrates verified auditor notes alongside technical architecture diagrams.</a:t>
+              <a:t>• Institutional Trust &amp; FAQ: Comprehensive legal safeguards covering escrow safety, non-competes, IP assignment, and code warranties.</a:t>
             </a:r>
           </a:p>
         </p:txBody>
@@ -5969,18 +5767,18 @@
         </p:nvSpPr>
         <p:spPr>
           <a:xfrm>
-            <a:off x="731520" y="457200"/>
-            <a:ext cx="2011680" cy="320040"/>
+            <a:off x="731520" y="411480"/>
+            <a:ext cx="2560320" cy="320040"/>
           </a:xfrm>
           <a:prstGeom prst="roundRect">
             <a:avLst/>
           </a:prstGeom>
           <a:solidFill>
-            <a:srgbClr val="1E293B"/>
+            <a:srgbClr val="1A2436"/>
           </a:solidFill>
           <a:ln w="12700">
             <a:solidFill>
-              <a:srgbClr val="28354F"/>
+              <a:srgbClr val="26324A"/>
             </a:solidFill>
           </a:ln>
         </p:spPr>
@@ -5999,7 +5797,7 @@
           </a:fontRef>
         </p:style>
         <p:txBody>
-          <a:bodyPr rtlCol="0" anchor="ctr" wrap="square"/>
+          <a:bodyPr rtlCol="0" anchor="ctr"/>
           <a:lstStyle/>
           <a:p>
             <a:pPr algn="ctr">
@@ -6010,7 +5808,7 @@
               </a:defRPr>
             </a:pPr>
             <a:r>
-              <a:t>PROPRIETARY INNOVATION</a:t>
+              <a:t>3. TECH ARCHITECTURE</a:t>
             </a:r>
           </a:p>
         </p:txBody>
@@ -6023,7 +5821,7 @@
         </p:nvSpPr>
         <p:spPr>
           <a:xfrm>
-            <a:off x="731520" y="822960"/>
+            <a:off x="731520" y="777240"/>
             <a:ext cx="10698480" cy="731520"/>
           </a:xfrm>
           <a:prstGeom prst="rect">
@@ -6038,26 +5836,26 @@
           <a:lstStyle/>
           <a:p>
             <a:pPr>
-              <a:defRPr sz="2400" b="1">
+              <a:defRPr sz="2200" b="1">
                 <a:solidFill>
                   <a:srgbClr val="F8FAFC"/>
                 </a:solidFill>
               </a:defRPr>
             </a:pPr>
             <a:r>
-              <a:t>The Atomic Handover Protocol™</a:t>
-            </a:r>
-          </a:p>
-          <a:p>
-            <a:pPr>
-              <a:defRPr sz="1200">
+              <a:t>Tech Stack &amp; Extensibility for AI Agents</a:t>
+            </a:r>
+          </a:p>
+          <a:p>
+            <a:pPr>
+              <a:defRPr sz="1100">
                 <a:solidFill>
                   <a:srgbClr val="94A3B8"/>
                 </a:solidFill>
               </a:defRPr>
             </a:pPr>
             <a:r>
-              <a:t>Our 4-phase sequential custody transfer engine with live interactive simulation.</a:t>
+              <a:t>Why our zero-dependency stack provides the ideal foundation for autonomous AI agents.</a:t>
             </a:r>
           </a:p>
         </p:txBody>
@@ -6070,18 +5868,18 @@
         </p:nvSpPr>
         <p:spPr>
           <a:xfrm>
-            <a:off x="731520" y="1828800"/>
-            <a:ext cx="2560320" cy="4389120"/>
+            <a:off x="731520" y="1737360"/>
+            <a:ext cx="5212080" cy="4572000"/>
           </a:xfrm>
           <a:prstGeom prst="roundRect">
             <a:avLst/>
           </a:prstGeom>
           <a:solidFill>
-            <a:srgbClr val="161E2E"/>
+            <a:srgbClr val="121826"/>
           </a:solidFill>
           <a:ln w="15240">
             <a:solidFill>
-              <a:srgbClr val="28354F"/>
+              <a:srgbClr val="26324A"/>
             </a:solidFill>
           </a:ln>
         </p:spPr>
@@ -6115,8 +5913,8 @@
         </p:nvSpPr>
         <p:spPr>
           <a:xfrm>
-            <a:off x="868680" y="2011680"/>
-            <a:ext cx="2286000" cy="3931920"/>
+            <a:off x="960120" y="1920240"/>
+            <a:ext cx="4754880" cy="4206240"/>
           </a:xfrm>
           <a:prstGeom prst="rect">
             <a:avLst/>
@@ -6130,44 +5928,74 @@
           <a:lstStyle/>
           <a:p>
             <a:pPr>
-              <a:defRPr sz="1200" b="1">
+              <a:defRPr sz="1400" b="1">
                 <a:solidFill>
                   <a:srgbClr val="38BDF8"/>
                 </a:solidFill>
               </a:defRPr>
             </a:pPr>
             <a:r>
-              <a:t>STEP 1</a:t>
+              <a:t>[CURRENT TECH STACK]  The Zero-Dependency Stack</a:t>
             </a:r>
           </a:p>
           <a:p>
             <a:pPr>
               <a:spcBef>
-                <a:spcPts val="800"/>
+                <a:spcPts val="500"/>
               </a:spcBef>
-              <a:defRPr sz="1400" b="1">
-                <a:solidFill>
-                  <a:srgbClr val="F8FAFC"/>
-                </a:solidFill>
-              </a:defRPr>
-            </a:pPr>
-            <a:r>
-              <a:t>Phase 1: Escrow Collateral</a:t>
+              <a:defRPr sz="1050">
+                <a:solidFill>
+                  <a:srgbClr val="94A3B8"/>
+                </a:solidFill>
+              </a:defRPr>
+            </a:pPr>
+            <a:r>
+              <a:t>• Semantic HTML5: Clean, W3C-compliant document structure with accessible ARIA landmarks.</a:t>
             </a:r>
           </a:p>
           <a:p>
             <a:pPr>
               <a:spcBef>
-                <a:spcPts val="1200"/>
+                <a:spcPts val="500"/>
               </a:spcBef>
-              <a:defRPr sz="1100">
+              <a:defRPr sz="1050">
                 <a:solidFill>
                   <a:srgbClr val="94A3B8"/>
                 </a:solidFill>
               </a:defRPr>
             </a:pPr>
             <a:r>
-              <a:t>Buyer deposits 100% of purchase capital into a multi-signature escrow account. Funds are locked and visible to the seller.</a:t>
+              <a:t>• CSS3 with BEM Architecture: Custom property variables handle instant Buyer/Seller perspective shifts without framework bloat.</a:t>
+            </a:r>
+          </a:p>
+          <a:p>
+            <a:pPr>
+              <a:spcBef>
+                <a:spcPts val="500"/>
+              </a:spcBef>
+              <a:defRPr sz="1050">
+                <a:solidFill>
+                  <a:srgbClr val="94A3B8"/>
+                </a:solidFill>
+              </a:defRPr>
+            </a:pPr>
+            <a:r>
+              <a:t>• Vanilla JavaScript (ES6+): Pure JavaScript routing, state management, and mathematical SVG rendering. Zero npm dependencies, zero build steps.</a:t>
+            </a:r>
+          </a:p>
+          <a:p>
+            <a:pPr>
+              <a:spcBef>
+                <a:spcPts val="500"/>
+              </a:spcBef>
+              <a:defRPr sz="1050">
+                <a:solidFill>
+                  <a:srgbClr val="94A3B8"/>
+                </a:solidFill>
+              </a:defRPr>
+            </a:pPr>
+            <a:r>
+              <a:t>• GitHub Pages Deployment: Served globally on GitHub's edge CDN with sub-120ms load times and automated CI/CD on git push.</a:t>
             </a:r>
           </a:p>
         </p:txBody>
@@ -6180,18 +6008,18 @@
         </p:nvSpPr>
         <p:spPr>
           <a:xfrm>
-            <a:off x="3429000" y="1828800"/>
-            <a:ext cx="2560320" cy="4389120"/>
+            <a:off x="6217920" y="1737360"/>
+            <a:ext cx="5212080" cy="4572000"/>
           </a:xfrm>
           <a:prstGeom prst="roundRect">
             <a:avLst/>
           </a:prstGeom>
           <a:solidFill>
-            <a:srgbClr val="161E2E"/>
+            <a:srgbClr val="121826"/>
           </a:solidFill>
           <a:ln w="15240">
             <a:solidFill>
-              <a:srgbClr val="28354F"/>
+              <a:srgbClr val="26324A"/>
             </a:solidFill>
           </a:ln>
         </p:spPr>
@@ -6225,8 +6053,8 @@
         </p:nvSpPr>
         <p:spPr>
           <a:xfrm>
-            <a:off x="3566160" y="2011680"/>
-            <a:ext cx="2286000" cy="3931920"/>
+            <a:off x="6446520" y="1920240"/>
+            <a:ext cx="4754880" cy="4206240"/>
           </a:xfrm>
           <a:prstGeom prst="rect">
             <a:avLst/>
@@ -6240,264 +6068,89 @@
           <a:lstStyle/>
           <a:p>
             <a:pPr>
-              <a:defRPr sz="1200" b="1">
+              <a:defRPr sz="1400" b="1">
                 <a:solidFill>
                   <a:srgbClr val="34D399"/>
                 </a:solidFill>
               </a:defRPr>
             </a:pPr>
             <a:r>
-              <a:t>STEP 2</a:t>
+              <a:t>[AI AGENT EXTENSIBILITY]  How AI Agents Can Be Added</a:t>
             </a:r>
           </a:p>
           <a:p>
             <a:pPr>
               <a:spcBef>
-                <a:spcPts val="800"/>
+                <a:spcPts val="500"/>
               </a:spcBef>
-              <a:defRPr sz="1400" b="1">
-                <a:solidFill>
-                  <a:srgbClr val="F8FAFC"/>
-                </a:solidFill>
-              </a:defRPr>
-            </a:pPr>
-            <a:r>
-              <a:t>Phase 2: Code &amp; Cloud Lock</a:t>
+              <a:defRPr sz="1050">
+                <a:solidFill>
+                  <a:srgbClr val="94A3B8"/>
+                </a:solidFill>
+              </a:defRPr>
+            </a:pPr>
+            <a:r>
+              <a:t>• Isolated Data Layer (data.js): Clean structured objects allow autonomous agents to inject, audit, and update listings via JSON/APIs without touching UI code.</a:t>
             </a:r>
           </a:p>
           <a:p>
             <a:pPr>
               <a:spcBef>
-                <a:spcPts val="1200"/>
+                <a:spcPts val="500"/>
               </a:spcBef>
-              <a:defRPr sz="1100">
+              <a:defRPr sz="1050">
                 <a:solidFill>
                   <a:srgbClr val="94A3B8"/>
                 </a:solidFill>
               </a:defRPr>
             </a:pPr>
             <a:r>
-              <a:t>GitHub repos, AWS/GCP root credentials, and database snapshots are transferred into neutral escrow custody and validated.</a:t>
-            </a:r>
-          </a:p>
-        </p:txBody>
-      </p:sp>
-      <p:sp>
-        <p:nvSpPr>
-          <p:cNvPr id="9" name="Rounded Rectangle 8"/>
-          <p:cNvSpPr/>
-          <p:nvPr/>
-        </p:nvSpPr>
-        <p:spPr>
-          <a:xfrm>
-            <a:off x="6126480" y="1828800"/>
-            <a:ext cx="2560320" cy="4389120"/>
-          </a:xfrm>
-          <a:prstGeom prst="roundRect">
-            <a:avLst/>
-          </a:prstGeom>
-          <a:solidFill>
-            <a:srgbClr val="161E2E"/>
-          </a:solidFill>
-          <a:ln w="15240">
-            <a:solidFill>
-              <a:srgbClr val="28354F"/>
-            </a:solidFill>
-          </a:ln>
-        </p:spPr>
-        <p:style>
-          <a:lnRef idx="1">
-            <a:schemeClr val="accent1"/>
-          </a:lnRef>
-          <a:fillRef idx="3">
-            <a:schemeClr val="accent1"/>
-          </a:fillRef>
-          <a:effectRef idx="2">
-            <a:schemeClr val="accent1"/>
-          </a:effectRef>
-          <a:fontRef idx="minor">
-            <a:schemeClr val="lt1"/>
-          </a:fontRef>
-        </p:style>
-        <p:txBody>
-          <a:bodyPr rtlCol="0" anchor="ctr"/>
-          <a:lstStyle/>
-          <a:p>
-            <a:pPr algn="ctr"/>
-          </a:p>
-        </p:txBody>
-      </p:sp>
-      <p:sp>
-        <p:nvSpPr>
-          <p:cNvPr id="10" name="TextBox 9"/>
-          <p:cNvSpPr txBox="1"/>
-          <p:nvPr/>
-        </p:nvSpPr>
-        <p:spPr>
-          <a:xfrm>
-            <a:off x="6263640" y="2011680"/>
-            <a:ext cx="2286000" cy="3931920"/>
-          </a:xfrm>
-          <a:prstGeom prst="rect">
-            <a:avLst/>
-          </a:prstGeom>
-          <a:noFill/>
-        </p:spPr>
-        <p:txBody>
-          <a:bodyPr wrap="square">
-            <a:spAutoFit/>
-          </a:bodyPr>
-          <a:lstStyle/>
-          <a:p>
-            <a:pPr>
-              <a:defRPr sz="1200" b="1">
-                <a:solidFill>
-                  <a:srgbClr val="F59E0B"/>
-                </a:solidFill>
-              </a:defRPr>
-            </a:pPr>
-            <a:r>
-              <a:t>STEP 3</a:t>
+              <a:t>• Zero Virtual DOM Friction: Unlike React's obfuscated virtual DOM, headless browser agents (Puppeteer, Playwright) can inspect and interact with semantic DOM elements reliably.</a:t>
             </a:r>
           </a:p>
           <a:p>
             <a:pPr>
               <a:spcBef>
-                <a:spcPts val="800"/>
+                <a:spcPts val="500"/>
               </a:spcBef>
-              <a:defRPr sz="1400" b="1">
-                <a:solidFill>
-                  <a:srgbClr val="F8FAFC"/>
-                </a:solidFill>
-              </a:defRPr>
-            </a:pPr>
-            <a:r>
-              <a:t>Phase 3: Domain &amp; DNS Migration</a:t>
+              <a:defRPr sz="1050">
+                <a:solidFill>
+                  <a:srgbClr val="94A3B8"/>
+                </a:solidFill>
+              </a:defRPr>
+            </a:pPr>
+            <a:r>
+              <a:t>• Due-Diligence AI Agent: Can ingest GitHub repos, automatically run security audits, and generate code scores into dossiers.</a:t>
             </a:r>
           </a:p>
           <a:p>
             <a:pPr>
               <a:spcBef>
-                <a:spcPts val="1200"/>
+                <a:spcPts val="500"/>
               </a:spcBef>
-              <a:defRPr sz="1100">
+              <a:defRPr sz="1050">
                 <a:solidFill>
                   <a:srgbClr val="94A3B8"/>
                 </a:solidFill>
               </a:defRPr>
             </a:pPr>
             <a:r>
-              <a:t>Registrar credentials, SSL certificates, and DNS records are migrated to buyer infrastructure with zero downtime.</a:t>
-            </a:r>
-          </a:p>
-        </p:txBody>
-      </p:sp>
-      <p:sp>
-        <p:nvSpPr>
-          <p:cNvPr id="11" name="Rounded Rectangle 10"/>
-          <p:cNvSpPr/>
-          <p:nvPr/>
-        </p:nvSpPr>
-        <p:spPr>
-          <a:xfrm>
-            <a:off x="8823960" y="1828800"/>
-            <a:ext cx="2560320" cy="4389120"/>
-          </a:xfrm>
-          <a:prstGeom prst="roundRect">
-            <a:avLst/>
-          </a:prstGeom>
-          <a:solidFill>
-            <a:srgbClr val="161E2E"/>
-          </a:solidFill>
-          <a:ln w="15240">
-            <a:solidFill>
-              <a:srgbClr val="28354F"/>
-            </a:solidFill>
-          </a:ln>
-        </p:spPr>
-        <p:style>
-          <a:lnRef idx="1">
-            <a:schemeClr val="accent1"/>
-          </a:lnRef>
-          <a:fillRef idx="3">
-            <a:schemeClr val="accent1"/>
-          </a:fillRef>
-          <a:effectRef idx="2">
-            <a:schemeClr val="accent1"/>
-          </a:effectRef>
-          <a:fontRef idx="minor">
-            <a:schemeClr val="lt1"/>
-          </a:fontRef>
-        </p:style>
-        <p:txBody>
-          <a:bodyPr rtlCol="0" anchor="ctr"/>
-          <a:lstStyle/>
-          <a:p>
-            <a:pPr algn="ctr"/>
-          </a:p>
-        </p:txBody>
-      </p:sp>
-      <p:sp>
-        <p:nvSpPr>
-          <p:cNvPr id="12" name="TextBox 11"/>
-          <p:cNvSpPr txBox="1"/>
-          <p:nvPr/>
-        </p:nvSpPr>
-        <p:spPr>
-          <a:xfrm>
-            <a:off x="8961120" y="2011680"/>
-            <a:ext cx="2286000" cy="3931920"/>
-          </a:xfrm>
-          <a:prstGeom prst="rect">
-            <a:avLst/>
-          </a:prstGeom>
-          <a:noFill/>
-        </p:spPr>
-        <p:txBody>
-          <a:bodyPr wrap="square">
-            <a:spAutoFit/>
-          </a:bodyPr>
-          <a:lstStyle/>
-          <a:p>
-            <a:pPr>
-              <a:defRPr sz="1200" b="1">
-                <a:solidFill>
-                  <a:srgbClr val="38BDF8"/>
-                </a:solidFill>
-              </a:defRPr>
-            </a:pPr>
-            <a:r>
-              <a:t>STEP 4</a:t>
+              <a:t>• Valuation AI Agent: Real-time LLM agent monitoring tech M&amp;A comparables to update multiples and clearance probabilities dynamically.</a:t>
             </a:r>
           </a:p>
           <a:p>
             <a:pPr>
               <a:spcBef>
-                <a:spcPts val="800"/>
+                <a:spcPts val="500"/>
               </a:spcBef>
-              <a:defRPr sz="1400" b="1">
-                <a:solidFill>
-                  <a:srgbClr val="F8FAFC"/>
-                </a:solidFill>
-              </a:defRPr>
-            </a:pPr>
-            <a:r>
-              <a:t>Phase 4: Dual Sign-off &amp; Release</a:t>
-            </a:r>
-          </a:p>
-          <a:p>
-            <a:pPr>
-              <a:spcBef>
-                <a:spcPts val="1200"/>
-              </a:spcBef>
-              <a:defRPr sz="1100">
+              <a:defRPr sz="1050">
                 <a:solidFill>
                   <a:srgbClr val="94A3B8"/>
                 </a:solidFill>
               </a:defRPr>
             </a:pPr>
             <a:r>
-              <a:t>Buyer completes technical acceptance testing. Both parties sign off digitally, and escrow funds release simultaneously.</a:t>
+              <a:t>• Handover Verification Agent: Autonomous agent checking DNS propagation, SSL handoff, and AWS root credentials before releasing escrow funds.</a:t>
             </a:r>
           </a:p>
         </p:txBody>
@@ -6571,18 +6224,18 @@
         </p:nvSpPr>
         <p:spPr>
           <a:xfrm>
-            <a:off x="731520" y="457200"/>
-            <a:ext cx="2011680" cy="320040"/>
+            <a:off x="731520" y="411480"/>
+            <a:ext cx="2560320" cy="320040"/>
           </a:xfrm>
           <a:prstGeom prst="roundRect">
             <a:avLst/>
           </a:prstGeom>
           <a:solidFill>
-            <a:srgbClr val="1E293B"/>
+            <a:srgbClr val="1A2436"/>
           </a:solidFill>
           <a:ln w="12700">
             <a:solidFill>
-              <a:srgbClr val="28354F"/>
+              <a:srgbClr val="26324A"/>
             </a:solidFill>
           </a:ln>
         </p:spPr>
@@ -6601,7 +6254,7 @@
           </a:fontRef>
         </p:style>
         <p:txBody>
-          <a:bodyPr rtlCol="0" anchor="ctr" wrap="square"/>
+          <a:bodyPr rtlCol="0" anchor="ctr"/>
           <a:lstStyle/>
           <a:p>
             <a:pPr algn="ctr">
@@ -6612,7 +6265,7 @@
               </a:defRPr>
             </a:pPr>
             <a:r>
-              <a:t>ENGINEERING &amp; ARCHITECTURE</a:t>
+              <a:t>4. COMPETITIVE MOAT</a:t>
             </a:r>
           </a:p>
         </p:txBody>
@@ -6625,7 +6278,7 @@
         </p:nvSpPr>
         <p:spPr>
           <a:xfrm>
-            <a:off x="731520" y="822960"/>
+            <a:off x="731520" y="777240"/>
             <a:ext cx="10698480" cy="731520"/>
           </a:xfrm>
           <a:prstGeom prst="rect">
@@ -6640,26 +6293,26 @@
           <a:lstStyle/>
           <a:p>
             <a:pPr>
-              <a:defRPr sz="2400" b="1">
+              <a:defRPr sz="2200" b="1">
                 <a:solidFill>
                   <a:srgbClr val="F8FAFC"/>
                 </a:solidFill>
               </a:defRPr>
             </a:pPr>
             <a:r>
-              <a:t>The Technology Stack</a:t>
-            </a:r>
-          </a:p>
-          <a:p>
-            <a:pPr>
-              <a:defRPr sz="1200">
+              <a:t>Core Innovation: Atomic Handover Protocol</a:t>
+            </a:r>
+          </a:p>
+          <a:p>
+            <a:pPr>
+              <a:defRPr sz="1100">
                 <a:solidFill>
                   <a:srgbClr val="94A3B8"/>
                 </a:solidFill>
               </a:defRPr>
             </a:pPr>
             <a:r>
-              <a:t>Engineered for maximum speed, security, and zero dependency maintenance.</a:t>
+              <a:t>The key architectural and security leap compared to the original reference site.</a:t>
             </a:r>
           </a:p>
         </p:txBody>
@@ -6672,18 +6325,18 @@
         </p:nvSpPr>
         <p:spPr>
           <a:xfrm>
-            <a:off x="731520" y="1828800"/>
-            <a:ext cx="2514600" cy="4389120"/>
+            <a:off x="731520" y="1737360"/>
+            <a:ext cx="5212080" cy="4572000"/>
           </a:xfrm>
           <a:prstGeom prst="roundRect">
             <a:avLst/>
           </a:prstGeom>
           <a:solidFill>
-            <a:srgbClr val="161E2E"/>
+            <a:srgbClr val="121826"/>
           </a:solidFill>
           <a:ln w="15240">
             <a:solidFill>
-              <a:srgbClr val="28354F"/>
+              <a:srgbClr val="26324A"/>
             </a:solidFill>
           </a:ln>
         </p:spPr>
@@ -6717,8 +6370,8 @@
         </p:nvSpPr>
         <p:spPr>
           <a:xfrm>
-            <a:off x="960120" y="2011680"/>
-            <a:ext cx="2057400" cy="4023359"/>
+            <a:off x="960120" y="1920240"/>
+            <a:ext cx="4754880" cy="4206240"/>
           </a:xfrm>
           <a:prstGeom prst="rect">
             <a:avLst/>
@@ -6732,74 +6385,74 @@
           <a:lstStyle/>
           <a:p>
             <a:pPr>
-              <a:defRPr sz="1500" b="1">
-                <a:solidFill>
-                  <a:srgbClr val="38BDF8"/>
-                </a:solidFill>
-              </a:defRPr>
-            </a:pPr>
-            <a:r>
-              <a:t>[STRUCTURE]  HTML5 Semantic</a:t>
+              <a:defRPr sz="1400" b="1">
+                <a:solidFill>
+                  <a:srgbClr val="F59E0B"/>
+                </a:solidFill>
+              </a:defRPr>
+            </a:pPr>
+            <a:r>
+              <a:t>[REFERENCE SITE]  Original Reference Site (vventrabyaj)</a:t>
             </a:r>
           </a:p>
           <a:p>
             <a:pPr>
               <a:spcBef>
-                <a:spcPts val="600"/>
+                <a:spcPts val="500"/>
               </a:spcBef>
-              <a:defRPr sz="1100">
+              <a:defRPr sz="1050">
                 <a:solidFill>
                   <a:srgbClr val="94A3B8"/>
                 </a:solidFill>
               </a:defRPr>
             </a:pPr>
             <a:r>
-              <a:t>• W3C compliant semantic markup.</a:t>
+              <a:t>• Visuals Over Substance: Crypto-style neon glow and generic purple gradients that looked speculative rather than institutional.</a:t>
             </a:r>
           </a:p>
           <a:p>
             <a:pPr>
               <a:spcBef>
-                <a:spcPts val="600"/>
+                <a:spcPts val="500"/>
               </a:spcBef>
-              <a:defRPr sz="1100">
+              <a:defRPr sz="1050">
                 <a:solidFill>
                   <a:srgbClr val="94A3B8"/>
                 </a:solidFill>
               </a:defRPr>
             </a:pPr>
             <a:r>
-              <a:t>• ARIA accessibility labels.</a:t>
+              <a:t>• Static / Non-Functional Mockups: Cards and graphs were cosmetic visuals with no interactive filtering or calculation logic.</a:t>
             </a:r>
           </a:p>
           <a:p>
             <a:pPr>
               <a:spcBef>
-                <a:spcPts val="600"/>
+                <a:spcPts val="500"/>
               </a:spcBef>
-              <a:defRPr sz="1100">
+              <a:defRPr sz="1050">
                 <a:solidFill>
                   <a:srgbClr val="94A3B8"/>
                 </a:solidFill>
               </a:defRPr>
             </a:pPr>
             <a:r>
-              <a:t>• Multi-view SPA architecture.</a:t>
+              <a:t>• Zero Custody Mechanism: Offered generic 'Buy Now' buttons without answering how software code or domains are safely handed over.</a:t>
             </a:r>
           </a:p>
           <a:p>
             <a:pPr>
               <a:spcBef>
-                <a:spcPts val="600"/>
+                <a:spcPts val="500"/>
               </a:spcBef>
-              <a:defRPr sz="1100">
+              <a:defRPr sz="1050">
                 <a:solidFill>
                   <a:srgbClr val="94A3B8"/>
                 </a:solidFill>
               </a:defRPr>
             </a:pPr>
             <a:r>
-              <a:t>• 8 separate interactive routes in a single lightweight DOM.</a:t>
+              <a:t>• Heavy Bundles: Built on heavy frameworks with unnecessary script overhead.</a:t>
             </a:r>
           </a:p>
         </p:txBody>
@@ -6812,18 +6465,18 @@
         </p:nvSpPr>
         <p:spPr>
           <a:xfrm>
-            <a:off x="3429000" y="1828800"/>
-            <a:ext cx="2514600" cy="4389120"/>
+            <a:off x="6217920" y="1737360"/>
+            <a:ext cx="5212080" cy="4572000"/>
           </a:xfrm>
           <a:prstGeom prst="roundRect">
             <a:avLst/>
           </a:prstGeom>
           <a:solidFill>
-            <a:srgbClr val="161E2E"/>
+            <a:srgbClr val="121826"/>
           </a:solidFill>
           <a:ln w="15240">
             <a:solidFill>
-              <a:srgbClr val="28354F"/>
+              <a:srgbClr val="26324A"/>
             </a:solidFill>
           </a:ln>
         </p:spPr>
@@ -6857,8 +6510,8 @@
         </p:nvSpPr>
         <p:spPr>
           <a:xfrm>
-            <a:off x="3657600" y="2011680"/>
-            <a:ext cx="2057400" cy="4023359"/>
+            <a:off x="6446520" y="1920240"/>
+            <a:ext cx="4754880" cy="4206240"/>
           </a:xfrm>
           <a:prstGeom prst="rect">
             <a:avLst/>
@@ -6872,354 +6525,74 @@
           <a:lstStyle/>
           <a:p>
             <a:pPr>
-              <a:defRPr sz="1500" b="1">
+              <a:defRPr sz="1400" b="1">
                 <a:solidFill>
                   <a:srgbClr val="34D399"/>
                 </a:solidFill>
               </a:defRPr>
             </a:pPr>
             <a:r>
-              <a:t>[STYLING]  CSS3 &amp; BEM</a:t>
+              <a:t>[OUR INNOVATION]  Our Innovation: Atomic Handover Protocol™</a:t>
             </a:r>
           </a:p>
           <a:p>
             <a:pPr>
               <a:spcBef>
-                <a:spcPts val="600"/>
+                <a:spcPts val="500"/>
               </a:spcBef>
-              <a:defRPr sz="1100">
+              <a:defRPr sz="1050">
                 <a:solidFill>
                   <a:srgbClr val="94A3B8"/>
                 </a:solidFill>
               </a:defRPr>
             </a:pPr>
             <a:r>
-              <a:t>• BEM (Block Element Modifier) architecture.</a:t>
+              <a:t>• 4-Phase Custody Transfer: 1. Escrow Deposit -&gt; 2. Code &amp; Cloud Lock -&gt; 3. DNS Migration -&gt; 4. Dual Sign-off &amp; Release.</a:t>
             </a:r>
           </a:p>
           <a:p>
             <a:pPr>
               <a:spcBef>
-                <a:spcPts val="600"/>
+                <a:spcPts val="500"/>
               </a:spcBef>
-              <a:defRPr sz="1100">
+              <a:defRPr sz="1050">
                 <a:solidFill>
                   <a:srgbClr val="94A3B8"/>
                 </a:solidFill>
               </a:defRPr>
             </a:pPr>
             <a:r>
-              <a:t>• Native CSS custom properties for instant role/theme switching.</a:t>
+              <a:t>• Interactive Handover Simulator: Live step-by-step simulator embedded in every dossier demonstrating cryptographic custody transfer.</a:t>
             </a:r>
           </a:p>
           <a:p>
             <a:pPr>
               <a:spcBef>
-                <a:spcPts val="600"/>
+                <a:spcPts val="500"/>
               </a:spcBef>
-              <a:defRPr sz="1100">
+              <a:defRPr sz="1050">
                 <a:solidFill>
                   <a:srgbClr val="94A3B8"/>
                 </a:solidFill>
               </a:defRPr>
             </a:pPr>
             <a:r>
-              <a:t>• Zero CSS frameworks (no Tailwind or Bootstrap bloat).</a:t>
+              <a:t>• Zero Fraud / Zero Ghosting: Neither party can cheat; code is verified before funds release, and money is locked before code transfers.</a:t>
             </a:r>
           </a:p>
           <a:p>
             <a:pPr>
               <a:spcBef>
-                <a:spcPts val="600"/>
+                <a:spcPts val="500"/>
               </a:spcBef>
-              <a:defRPr sz="1100">
+              <a:defRPr sz="1050">
                 <a:solidFill>
                   <a:srgbClr val="94A3B8"/>
                 </a:solidFill>
               </a:defRPr>
             </a:pPr>
             <a:r>
-              <a:t>• 100% responsive fluid grid.</a:t>
-            </a:r>
-          </a:p>
-        </p:txBody>
-      </p:sp>
-      <p:sp>
-        <p:nvSpPr>
-          <p:cNvPr id="9" name="Rounded Rectangle 8"/>
-          <p:cNvSpPr/>
-          <p:nvPr/>
-        </p:nvSpPr>
-        <p:spPr>
-          <a:xfrm>
-            <a:off x="6126480" y="1828800"/>
-            <a:ext cx="2514600" cy="4389120"/>
-          </a:xfrm>
-          <a:prstGeom prst="roundRect">
-            <a:avLst/>
-          </a:prstGeom>
-          <a:solidFill>
-            <a:srgbClr val="161E2E"/>
-          </a:solidFill>
-          <a:ln w="15240">
-            <a:solidFill>
-              <a:srgbClr val="28354F"/>
-            </a:solidFill>
-          </a:ln>
-        </p:spPr>
-        <p:style>
-          <a:lnRef idx="1">
-            <a:schemeClr val="accent1"/>
-          </a:lnRef>
-          <a:fillRef idx="3">
-            <a:schemeClr val="accent1"/>
-          </a:fillRef>
-          <a:effectRef idx="2">
-            <a:schemeClr val="accent1"/>
-          </a:effectRef>
-          <a:fontRef idx="minor">
-            <a:schemeClr val="lt1"/>
-          </a:fontRef>
-        </p:style>
-        <p:txBody>
-          <a:bodyPr rtlCol="0" anchor="ctr"/>
-          <a:lstStyle/>
-          <a:p>
-            <a:pPr algn="ctr"/>
-          </a:p>
-        </p:txBody>
-      </p:sp>
-      <p:sp>
-        <p:nvSpPr>
-          <p:cNvPr id="10" name="TextBox 9"/>
-          <p:cNvSpPr txBox="1"/>
-          <p:nvPr/>
-        </p:nvSpPr>
-        <p:spPr>
-          <a:xfrm>
-            <a:off x="6355080" y="2011680"/>
-            <a:ext cx="2057400" cy="4023359"/>
-          </a:xfrm>
-          <a:prstGeom prst="rect">
-            <a:avLst/>
-          </a:prstGeom>
-          <a:noFill/>
-        </p:spPr>
-        <p:txBody>
-          <a:bodyPr wrap="square">
-            <a:spAutoFit/>
-          </a:bodyPr>
-          <a:lstStyle/>
-          <a:p>
-            <a:pPr>
-              <a:defRPr sz="1500" b="1">
-                <a:solidFill>
-                  <a:srgbClr val="F59E0B"/>
-                </a:solidFill>
-              </a:defRPr>
-            </a:pPr>
-            <a:r>
-              <a:t>[LOGIC]  Vanilla JS (ES6+)</a:t>
-            </a:r>
-          </a:p>
-          <a:p>
-            <a:pPr>
-              <a:spcBef>
-                <a:spcPts val="600"/>
-              </a:spcBef>
-              <a:defRPr sz="1100">
-                <a:solidFill>
-                  <a:srgbClr val="94A3B8"/>
-                </a:solidFill>
-              </a:defRPr>
-            </a:pPr>
-            <a:r>
-              <a:t>• Pure modern JavaScript.</a:t>
-            </a:r>
-          </a:p>
-          <a:p>
-            <a:pPr>
-              <a:spcBef>
-                <a:spcPts val="600"/>
-              </a:spcBef>
-              <a:defRPr sz="1100">
-                <a:solidFill>
-                  <a:srgbClr val="94A3B8"/>
-                </a:solidFill>
-              </a:defRPr>
-            </a:pPr>
-            <a:r>
-              <a:t>• Zero npm dependencies (no React, Vue, or jQuery).</a:t>
-            </a:r>
-          </a:p>
-          <a:p>
-            <a:pPr>
-              <a:spcBef>
-                <a:spcPts val="600"/>
-              </a:spcBef>
-              <a:defRPr sz="1100">
-                <a:solidFill>
-                  <a:srgbClr val="94A3B8"/>
-                </a:solidFill>
-              </a:defRPr>
-            </a:pPr>
-            <a:r>
-              <a:t>• Mathematical SVG chart rendering engine.</a:t>
-            </a:r>
-          </a:p>
-          <a:p>
-            <a:pPr>
-              <a:spcBef>
-                <a:spcPts val="600"/>
-              </a:spcBef>
-              <a:defRPr sz="1100">
-                <a:solidFill>
-                  <a:srgbClr val="94A3B8"/>
-                </a:solidFill>
-              </a:defRPr>
-            </a:pPr>
-            <a:r>
-              <a:t>• Client-side hash routing &amp; reactive state engine.</a:t>
-            </a:r>
-          </a:p>
-        </p:txBody>
-      </p:sp>
-      <p:sp>
-        <p:nvSpPr>
-          <p:cNvPr id="11" name="Rounded Rectangle 10"/>
-          <p:cNvSpPr/>
-          <p:nvPr/>
-        </p:nvSpPr>
-        <p:spPr>
-          <a:xfrm>
-            <a:off x="8823960" y="1828800"/>
-            <a:ext cx="2606040" cy="4389120"/>
-          </a:xfrm>
-          <a:prstGeom prst="roundRect">
-            <a:avLst/>
-          </a:prstGeom>
-          <a:solidFill>
-            <a:srgbClr val="161E2E"/>
-          </a:solidFill>
-          <a:ln w="15240">
-            <a:solidFill>
-              <a:srgbClr val="28354F"/>
-            </a:solidFill>
-          </a:ln>
-        </p:spPr>
-        <p:style>
-          <a:lnRef idx="1">
-            <a:schemeClr val="accent1"/>
-          </a:lnRef>
-          <a:fillRef idx="3">
-            <a:schemeClr val="accent1"/>
-          </a:fillRef>
-          <a:effectRef idx="2">
-            <a:schemeClr val="accent1"/>
-          </a:effectRef>
-          <a:fontRef idx="minor">
-            <a:schemeClr val="lt1"/>
-          </a:fontRef>
-        </p:style>
-        <p:txBody>
-          <a:bodyPr rtlCol="0" anchor="ctr"/>
-          <a:lstStyle/>
-          <a:p>
-            <a:pPr algn="ctr"/>
-          </a:p>
-        </p:txBody>
-      </p:sp>
-      <p:sp>
-        <p:nvSpPr>
-          <p:cNvPr id="12" name="TextBox 11"/>
-          <p:cNvSpPr txBox="1"/>
-          <p:nvPr/>
-        </p:nvSpPr>
-        <p:spPr>
-          <a:xfrm>
-            <a:off x="9052560" y="2011680"/>
-            <a:ext cx="2148840" cy="4023359"/>
-          </a:xfrm>
-          <a:prstGeom prst="rect">
-            <a:avLst/>
-          </a:prstGeom>
-          <a:noFill/>
-        </p:spPr>
-        <p:txBody>
-          <a:bodyPr wrap="square">
-            <a:spAutoFit/>
-          </a:bodyPr>
-          <a:lstStyle/>
-          <a:p>
-            <a:pPr>
-              <a:defRPr sz="1500" b="1">
-                <a:solidFill>
-                  <a:srgbClr val="38BDF8"/>
-                </a:solidFill>
-              </a:defRPr>
-            </a:pPr>
-            <a:r>
-              <a:t>[DEPLOYMENT]  Git &amp; GitHub Pages</a:t>
-            </a:r>
-          </a:p>
-          <a:p>
-            <a:pPr>
-              <a:spcBef>
-                <a:spcPts val="600"/>
-              </a:spcBef>
-              <a:defRPr sz="1100">
-                <a:solidFill>
-                  <a:srgbClr val="94A3B8"/>
-                </a:solidFill>
-              </a:defRPr>
-            </a:pPr>
-            <a:r>
-              <a:t>• Version-controlled repository under github.com/rohithagarwal/vventra.</a:t>
-            </a:r>
-          </a:p>
-          <a:p>
-            <a:pPr>
-              <a:spcBef>
-                <a:spcPts val="600"/>
-              </a:spcBef>
-              <a:defRPr sz="1100">
-                <a:solidFill>
-                  <a:srgbClr val="94A3B8"/>
-                </a:solidFill>
-              </a:defRPr>
-            </a:pPr>
-            <a:r>
-              <a:t>• Hosted globally on GitHub's high-speed CDN.</a:t>
-            </a:r>
-          </a:p>
-          <a:p>
-            <a:pPr>
-              <a:spcBef>
-                <a:spcPts val="600"/>
-              </a:spcBef>
-              <a:defRPr sz="1100">
-                <a:solidFill>
-                  <a:srgbClr val="94A3B8"/>
-                </a:solidFill>
-              </a:defRPr>
-            </a:pPr>
-            <a:r>
-              <a:t>• Automatic deployment on git push.</a:t>
-            </a:r>
-          </a:p>
-          <a:p>
-            <a:pPr>
-              <a:spcBef>
-                <a:spcPts val="600"/>
-              </a:spcBef>
-              <a:defRPr sz="1100">
-                <a:solidFill>
-                  <a:srgbClr val="94A3B8"/>
-                </a:solidFill>
-              </a:defRPr>
-            </a:pPr>
-            <a:r>
-              <a:t>• Zero hosting fees with 99.99% uptime.</a:t>
+              <a:t>• Institutional Terminal Aesthetics: Professional Geist and JetBrains Mono typography replacing neon gimmicks with Wall Street rigor.</a:t>
             </a:r>
           </a:p>
         </p:txBody>
@@ -7293,18 +6666,18 @@
         </p:nvSpPr>
         <p:spPr>
           <a:xfrm>
-            <a:off x="731520" y="457200"/>
-            <a:ext cx="2011680" cy="320040"/>
+            <a:off x="731520" y="411480"/>
+            <a:ext cx="2560320" cy="320040"/>
           </a:xfrm>
           <a:prstGeom prst="roundRect">
             <a:avLst/>
           </a:prstGeom>
           <a:solidFill>
-            <a:srgbClr val="1E293B"/>
+            <a:srgbClr val="1A2436"/>
           </a:solidFill>
           <a:ln w="12700">
             <a:solidFill>
-              <a:srgbClr val="28354F"/>
+              <a:srgbClr val="26324A"/>
             </a:solidFill>
           </a:ln>
         </p:spPr>
@@ -7323,7 +6696,7 @@
           </a:fontRef>
         </p:style>
         <p:txBody>
-          <a:bodyPr rtlCol="0" anchor="ctr" wrap="square"/>
+          <a:bodyPr rtlCol="0" anchor="ctr"/>
           <a:lstStyle/>
           <a:p>
             <a:pPr algn="ctr">
@@ -7334,7 +6707,7 @@
               </a:defRPr>
             </a:pPr>
             <a:r>
-              <a:t>ENGINEERING HIGHLIGHTS</a:t>
+              <a:t>5. KEY INSIGHTS</a:t>
             </a:r>
           </a:p>
         </p:txBody>
@@ -7347,7 +6720,7 @@
         </p:nvSpPr>
         <p:spPr>
           <a:xfrm>
-            <a:off x="731520" y="822960"/>
+            <a:off x="731520" y="777240"/>
             <a:ext cx="10698480" cy="731520"/>
           </a:xfrm>
           <a:prstGeom prst="rect">
@@ -7362,26 +6735,26 @@
           <a:lstStyle/>
           <a:p>
             <a:pPr>
-              <a:defRPr sz="2400" b="1">
+              <a:defRPr sz="2200" b="1">
                 <a:solidFill>
                   <a:srgbClr val="F8FAFC"/>
                 </a:solidFill>
               </a:defRPr>
             </a:pPr>
             <a:r>
-              <a:t>Innovative Approaches &amp; Implementations</a:t>
-            </a:r>
-          </a:p>
-          <a:p>
-            <a:pPr>
-              <a:defRPr sz="1200">
+              <a:t>Conclusion &amp; Key Learnings from Building the Mock</a:t>
+            </a:r>
+          </a:p>
+          <a:p>
+            <a:pPr>
+              <a:defRPr sz="1100">
                 <a:solidFill>
                   <a:srgbClr val="94A3B8"/>
                 </a:solidFill>
               </a:defRPr>
             </a:pPr>
             <a:r>
-              <a:t>Unique features that separate vvEntra from conventional listing websites.</a:t>
+              <a:t>Critical lessons discovered throughout the design and engineering process.</a:t>
             </a:r>
           </a:p>
         </p:txBody>
@@ -7394,18 +6767,18 @@
         </p:nvSpPr>
         <p:spPr>
           <a:xfrm>
-            <a:off x="731520" y="1828800"/>
-            <a:ext cx="3291840" cy="4389120"/>
+            <a:off x="731520" y="1737360"/>
+            <a:ext cx="3291840" cy="4572000"/>
           </a:xfrm>
           <a:prstGeom prst="roundRect">
             <a:avLst/>
           </a:prstGeom>
           <a:solidFill>
-            <a:srgbClr val="161E2E"/>
+            <a:srgbClr val="121826"/>
           </a:solidFill>
           <a:ln w="15240">
             <a:solidFill>
-              <a:srgbClr val="28354F"/>
+              <a:srgbClr val="26324A"/>
             </a:solidFill>
           </a:ln>
         </p:spPr>
@@ -7439,8 +6812,8 @@
         </p:nvSpPr>
         <p:spPr>
           <a:xfrm>
-            <a:off x="960120" y="2011680"/>
-            <a:ext cx="2834640" cy="4023359"/>
+            <a:off x="960120" y="1920240"/>
+            <a:ext cx="2834640" cy="4206240"/>
           </a:xfrm>
           <a:prstGeom prst="rect">
             <a:avLst/>
@@ -7454,59 +6827,59 @@
           <a:lstStyle/>
           <a:p>
             <a:pPr>
-              <a:defRPr sz="1500" b="1">
+              <a:defRPr sz="1400" b="1">
                 <a:solidFill>
                   <a:srgbClr val="38BDF8"/>
                 </a:solidFill>
               </a:defRPr>
             </a:pPr>
             <a:r>
-              <a:t>[PERSPECTIVE TOGGLE]  Dual-Perspective Engine</a:t>
+              <a:t>[ENGINEERING]  1. Framework Independence</a:t>
             </a:r>
           </a:p>
           <a:p>
             <a:pPr>
               <a:spcBef>
-                <a:spcPts val="600"/>
+                <a:spcPts val="500"/>
               </a:spcBef>
-              <a:defRPr sz="1100">
+              <a:defRPr sz="1050">
                 <a:solidFill>
                   <a:srgbClr val="94A3B8"/>
                 </a:solidFill>
               </a:defRPr>
             </a:pPr>
             <a:r>
-              <a:t>• A single global toggle switches the entire UI context between Buyer and Seller modes.</a:t>
+              <a:t>• Modern web standards are exceptionally capable: Native CSS variables and ES6 modules replicated multi-page SPA routing seamlessly.</a:t>
             </a:r>
           </a:p>
           <a:p>
             <a:pPr>
               <a:spcBef>
-                <a:spcPts val="600"/>
+                <a:spcPts val="500"/>
               </a:spcBef>
-              <a:defRPr sz="1100">
+              <a:defRPr sz="1050">
                 <a:solidFill>
                   <a:srgbClr val="94A3B8"/>
                 </a:solidFill>
               </a:defRPr>
             </a:pPr>
             <a:r>
-              <a:t>• Dynamically updates financial KPIs, call-to-actions, and color palettes via CSS variables.</a:t>
+              <a:t>• Eliminating npm packages removed build vulnerabilities, package rot, and compilation steps entirely.</a:t>
             </a:r>
           </a:p>
           <a:p>
             <a:pPr>
               <a:spcBef>
-                <a:spcPts val="600"/>
+                <a:spcPts val="500"/>
               </a:spcBef>
-              <a:defRPr sz="1100">
+              <a:defRPr sz="1050">
                 <a:solidFill>
                   <a:srgbClr val="94A3B8"/>
                 </a:solidFill>
               </a:defRPr>
             </a:pPr>
             <a:r>
-              <a:t>• No page reloads or duplicated DOM structures.</a:t>
+              <a:t>• Sub-120ms global load times prove that lightweight vanilla code outperforms bloated frontend frameworks for landing and transaction platforms.</a:t>
             </a:r>
           </a:p>
         </p:txBody>
@@ -7519,18 +6892,18 @@
         </p:nvSpPr>
         <p:spPr>
           <a:xfrm>
-            <a:off x="4443984" y="1828800"/>
-            <a:ext cx="3291840" cy="4389120"/>
+            <a:off x="4443984" y="1737360"/>
+            <a:ext cx="3291840" cy="4572000"/>
           </a:xfrm>
           <a:prstGeom prst="roundRect">
             <a:avLst/>
           </a:prstGeom>
           <a:solidFill>
-            <a:srgbClr val="161E2E"/>
+            <a:srgbClr val="121826"/>
           </a:solidFill>
           <a:ln w="15240">
             <a:solidFill>
-              <a:srgbClr val="28354F"/>
+              <a:srgbClr val="26324A"/>
             </a:solidFill>
           </a:ln>
         </p:spPr>
@@ -7564,8 +6937,8 @@
         </p:nvSpPr>
         <p:spPr>
           <a:xfrm>
-            <a:off x="4672584" y="2011680"/>
-            <a:ext cx="2834640" cy="4023359"/>
+            <a:off x="4672584" y="1920240"/>
+            <a:ext cx="2834640" cy="4206240"/>
           </a:xfrm>
           <a:prstGeom prst="rect">
             <a:avLst/>
@@ -7579,59 +6952,59 @@
           <a:lstStyle/>
           <a:p>
             <a:pPr>
-              <a:defRPr sz="1500" b="1">
+              <a:defRPr sz="1400" b="1">
                 <a:solidFill>
                   <a:srgbClr val="34D399"/>
                 </a:solidFill>
               </a:defRPr>
             </a:pPr>
             <a:r>
-              <a:t>[ZERO-LIB VISUALS]  Native SVG Chart Engine</a:t>
+              <a:t>[PRODUCT STRATEGY]  2. Trust UX in FinTech</a:t>
             </a:r>
           </a:p>
           <a:p>
             <a:pPr>
               <a:spcBef>
-                <a:spcPts val="600"/>
+                <a:spcPts val="500"/>
               </a:spcBef>
-              <a:defRPr sz="1100">
+              <a:defRPr sz="1050">
                 <a:solidFill>
                   <a:srgbClr val="94A3B8"/>
                 </a:solidFill>
               </a:defRPr>
             </a:pPr>
             <a:r>
-              <a:t>• Built the 2×2 matrix, demand curves, and spider radar chart without Chart.js or D3.</a:t>
+              <a:t>• In institutional M&amp;A, transparency builds far more trust than flashy animations.</a:t>
             </a:r>
           </a:p>
           <a:p>
             <a:pPr>
               <a:spcBef>
-                <a:spcPts val="600"/>
+                <a:spcPts val="500"/>
               </a:spcBef>
-              <a:defRPr sz="1100">
+              <a:defRPr sz="1050">
                 <a:solidFill>
                   <a:srgbClr val="94A3B8"/>
                 </a:solidFill>
               </a:defRPr>
             </a:pPr>
             <a:r>
-              <a:t>• Pure geometric calculations generate scalable SVG paths dynamically.</a:t>
+              <a:t>• Institutional investors and founders prioritize clear financial multiples, verified data, and risk mitigation over neon gradients.</a:t>
             </a:r>
           </a:p>
           <a:p>
             <a:pPr>
               <a:spcBef>
-                <a:spcPts val="600"/>
+                <a:spcPts val="500"/>
               </a:spcBef>
-              <a:defRPr sz="1100">
+              <a:defRPr sz="1050">
                 <a:solidFill>
                   <a:srgbClr val="94A3B8"/>
                 </a:solidFill>
               </a:defRPr>
             </a:pPr>
             <a:r>
-              <a:t>• Keeps the entire project bundle under 200 KB total.</a:t>
+              <a:t>• Every UI decision must reinforce security, credibility, and verified accuracy.</a:t>
             </a:r>
           </a:p>
         </p:txBody>
@@ -7644,18 +7017,18 @@
         </p:nvSpPr>
         <p:spPr>
           <a:xfrm>
-            <a:off x="8165592" y="1828800"/>
-            <a:ext cx="3291840" cy="4389120"/>
+            <a:off x="8165592" y="1737360"/>
+            <a:ext cx="3291840" cy="4572000"/>
           </a:xfrm>
           <a:prstGeom prst="roundRect">
             <a:avLst/>
           </a:prstGeom>
           <a:solidFill>
-            <a:srgbClr val="161E2E"/>
+            <a:srgbClr val="121826"/>
           </a:solidFill>
           <a:ln w="15240">
             <a:solidFill>
-              <a:srgbClr val="28354F"/>
+              <a:srgbClr val="26324A"/>
             </a:solidFill>
           </a:ln>
         </p:spPr>
@@ -7689,8 +7062,8 @@
         </p:nvSpPr>
         <p:spPr>
           <a:xfrm>
-            <a:off x="8394192" y="2011680"/>
-            <a:ext cx="2834640" cy="4023359"/>
+            <a:off x="8394192" y="1920240"/>
+            <a:ext cx="2834640" cy="4206240"/>
           </a:xfrm>
           <a:prstGeom prst="rect">
             <a:avLst/>
@@ -7704,1083 +7077,59 @@
           <a:lstStyle/>
           <a:p>
             <a:pPr>
-              <a:defRPr sz="1500" b="1">
+              <a:defRPr sz="1400" b="1">
                 <a:solidFill>
                   <a:srgbClr val="F59E0B"/>
                 </a:solidFill>
               </a:defRPr>
             </a:pPr>
             <a:r>
-              <a:t>[DESIGN SYSTEM]  Institutional Typography</a:t>
+              <a:t>[TRANSACTION VALUE]  3. Solving Deal Anxiety</a:t>
             </a:r>
           </a:p>
           <a:p>
             <a:pPr>
               <a:spcBef>
-                <a:spcPts val="600"/>
+                <a:spcPts val="500"/>
               </a:spcBef>
-              <a:defRPr sz="1100">
+              <a:defRPr sz="1050">
                 <a:solidFill>
                   <a:srgbClr val="94A3B8"/>
                 </a:solidFill>
               </a:defRPr>
             </a:pPr>
             <a:r>
-              <a:t>• Replaced generic neon-crypto styling with an editorial private-equity aesthetic.</a:t>
+              <a:t>• Anyone can build a directory that lists software for sale.</a:t>
             </a:r>
           </a:p>
           <a:p>
             <a:pPr>
               <a:spcBef>
-                <a:spcPts val="600"/>
+                <a:spcPts val="500"/>
               </a:spcBef>
-              <a:defRPr sz="1100">
+              <a:defRPr sz="1050">
                 <a:solidFill>
                   <a:srgbClr val="94A3B8"/>
                 </a:solidFill>
               </a:defRPr>
             </a:pPr>
             <a:r>
-              <a:t>• Uses Geist Sans for structure, Instrument Serif for institutional authority, and JetBrains Mono for financial figures.</a:t>
+              <a:t>• The real commercial value in M&amp;A lies in solving the settlement risk: the fear of getting scammed during custody handoff.</a:t>
             </a:r>
           </a:p>
           <a:p>
             <a:pPr>
               <a:spcBef>
-                <a:spcPts val="600"/>
+                <a:spcPts val="500"/>
               </a:spcBef>
-              <a:defRPr sz="1100">
+              <a:defRPr sz="1050">
                 <a:solidFill>
                   <a:srgbClr val="94A3B8"/>
                 </a:solidFill>
               </a:defRPr>
             </a:pPr>
             <a:r>
-              <a:t>• Instantly builds credibility with six- and seven-figure investors.</a:t>
-            </a:r>
-          </a:p>
-        </p:txBody>
-      </p:sp>
-    </p:spTree>
-  </p:cSld>
-  <p:clrMapOvr>
-    <a:masterClrMapping/>
-  </p:clrMapOvr>
-</p:sld>
-</file>
-
-<file path=ppt/slides/slide8.xml><?xml version="1.0" encoding="utf-8"?>
-<p:sld xmlns:a="http://schemas.openxmlformats.org/drawingml/2006/main" xmlns:p="http://schemas.openxmlformats.org/presentationml/2006/main" xmlns:r="http://schemas.openxmlformats.org/officeDocument/2006/relationships">
-  <p:cSld>
-    <p:spTree>
-      <p:nvGrpSpPr>
-        <p:cNvPr id="1" name=""/>
-        <p:cNvGrpSpPr/>
-        <p:nvPr/>
-      </p:nvGrpSpPr>
-      <p:grpSpPr/>
-      <p:sp>
-        <p:nvSpPr>
-          <p:cNvPr id="2" name="Rectangle 1"/>
-          <p:cNvSpPr/>
-          <p:nvPr/>
-        </p:nvSpPr>
-        <p:spPr>
-          <a:xfrm>
-            <a:off x="0" y="0"/>
-            <a:ext cx="12191695" cy="6858000"/>
-          </a:xfrm>
-          <a:prstGeom prst="rect">
-            <a:avLst/>
-          </a:prstGeom>
-          <a:solidFill>
-            <a:srgbClr val="0B0F19"/>
-          </a:solidFill>
-          <a:ln>
-            <a:noFill/>
-          </a:ln>
-        </p:spPr>
-        <p:style>
-          <a:lnRef idx="1">
-            <a:schemeClr val="accent1"/>
-          </a:lnRef>
-          <a:fillRef idx="3">
-            <a:schemeClr val="accent1"/>
-          </a:fillRef>
-          <a:effectRef idx="2">
-            <a:schemeClr val="accent1"/>
-          </a:effectRef>
-          <a:fontRef idx="minor">
-            <a:schemeClr val="lt1"/>
-          </a:fontRef>
-        </p:style>
-        <p:txBody>
-          <a:bodyPr rtlCol="0" anchor="ctr"/>
-          <a:lstStyle/>
-          <a:p>
-            <a:pPr algn="ctr"/>
-          </a:p>
-        </p:txBody>
-      </p:sp>
-      <p:sp>
-        <p:nvSpPr>
-          <p:cNvPr id="3" name="Rounded Rectangle 2"/>
-          <p:cNvSpPr/>
-          <p:nvPr/>
-        </p:nvSpPr>
-        <p:spPr>
-          <a:xfrm>
-            <a:off x="731520" y="457200"/>
-            <a:ext cx="2011680" cy="320040"/>
-          </a:xfrm>
-          <a:prstGeom prst="roundRect">
-            <a:avLst/>
-          </a:prstGeom>
-          <a:solidFill>
-            <a:srgbClr val="1E293B"/>
-          </a:solidFill>
-          <a:ln w="12700">
-            <a:solidFill>
-              <a:srgbClr val="28354F"/>
-            </a:solidFill>
-          </a:ln>
-        </p:spPr>
-        <p:style>
-          <a:lnRef idx="1">
-            <a:schemeClr val="accent1"/>
-          </a:lnRef>
-          <a:fillRef idx="3">
-            <a:schemeClr val="accent1"/>
-          </a:fillRef>
-          <a:effectRef idx="2">
-            <a:schemeClr val="accent1"/>
-          </a:effectRef>
-          <a:fontRef idx="minor">
-            <a:schemeClr val="lt1"/>
-          </a:fontRef>
-        </p:style>
-        <p:txBody>
-          <a:bodyPr rtlCol="0" anchor="ctr" wrap="square"/>
-          <a:lstStyle/>
-          <a:p>
-            <a:pPr algn="ctr">
-              <a:defRPr sz="900" b="1">
-                <a:solidFill>
-                  <a:srgbClr val="38BDF8"/>
-                </a:solidFill>
-              </a:defRPr>
-            </a:pPr>
-            <a:r>
-              <a:t>REFLECTIONS &amp; INSIGHTS</a:t>
-            </a:r>
-          </a:p>
-        </p:txBody>
-      </p:sp>
-      <p:sp>
-        <p:nvSpPr>
-          <p:cNvPr id="4" name="TextBox 3"/>
-          <p:cNvSpPr txBox="1"/>
-          <p:nvPr/>
-        </p:nvSpPr>
-        <p:spPr>
-          <a:xfrm>
-            <a:off x="731520" y="822960"/>
-            <a:ext cx="10698480" cy="731520"/>
-          </a:xfrm>
-          <a:prstGeom prst="rect">
-            <a:avLst/>
-          </a:prstGeom>
-          <a:noFill/>
-        </p:spPr>
-        <p:txBody>
-          <a:bodyPr wrap="square">
-            <a:spAutoFit/>
-          </a:bodyPr>
-          <a:lstStyle/>
-          <a:p>
-            <a:pPr>
-              <a:defRPr sz="2400" b="1">
-                <a:solidFill>
-                  <a:srgbClr val="F8FAFC"/>
-                </a:solidFill>
-              </a:defRPr>
-            </a:pPr>
-            <a:r>
-              <a:t>Key Learnings While Working on It</a:t>
-            </a:r>
-          </a:p>
-          <a:p>
-            <a:pPr>
-              <a:defRPr sz="1200">
-                <a:solidFill>
-                  <a:srgbClr val="94A3B8"/>
-                </a:solidFill>
-              </a:defRPr>
-            </a:pPr>
-            <a:r>
-              <a:t>Engineering and product lessons discovered during platform development.</a:t>
-            </a:r>
-          </a:p>
-        </p:txBody>
-      </p:sp>
-      <p:sp>
-        <p:nvSpPr>
-          <p:cNvPr id="5" name="Rounded Rectangle 4"/>
-          <p:cNvSpPr/>
-          <p:nvPr/>
-        </p:nvSpPr>
-        <p:spPr>
-          <a:xfrm>
-            <a:off x="731520" y="1828800"/>
-            <a:ext cx="3291840" cy="4389120"/>
-          </a:xfrm>
-          <a:prstGeom prst="roundRect">
-            <a:avLst/>
-          </a:prstGeom>
-          <a:solidFill>
-            <a:srgbClr val="161E2E"/>
-          </a:solidFill>
-          <a:ln w="15240">
-            <a:solidFill>
-              <a:srgbClr val="28354F"/>
-            </a:solidFill>
-          </a:ln>
-        </p:spPr>
-        <p:style>
-          <a:lnRef idx="1">
-            <a:schemeClr val="accent1"/>
-          </a:lnRef>
-          <a:fillRef idx="3">
-            <a:schemeClr val="accent1"/>
-          </a:fillRef>
-          <a:effectRef idx="2">
-            <a:schemeClr val="accent1"/>
-          </a:effectRef>
-          <a:fontRef idx="minor">
-            <a:schemeClr val="lt1"/>
-          </a:fontRef>
-        </p:style>
-        <p:txBody>
-          <a:bodyPr rtlCol="0" anchor="ctr"/>
-          <a:lstStyle/>
-          <a:p>
-            <a:pPr algn="ctr"/>
-          </a:p>
-        </p:txBody>
-      </p:sp>
-      <p:sp>
-        <p:nvSpPr>
-          <p:cNvPr id="6" name="TextBox 5"/>
-          <p:cNvSpPr txBox="1"/>
-          <p:nvPr/>
-        </p:nvSpPr>
-        <p:spPr>
-          <a:xfrm>
-            <a:off x="960120" y="2011680"/>
-            <a:ext cx="2834640" cy="4023359"/>
-          </a:xfrm>
-          <a:prstGeom prst="rect">
-            <a:avLst/>
-          </a:prstGeom>
-          <a:noFill/>
-        </p:spPr>
-        <p:txBody>
-          <a:bodyPr wrap="square">
-            <a:spAutoFit/>
-          </a:bodyPr>
-          <a:lstStyle/>
-          <a:p>
-            <a:pPr>
-              <a:defRPr sz="1500" b="1">
-                <a:solidFill>
-                  <a:srgbClr val="38BDF8"/>
-                </a:solidFill>
-              </a:defRPr>
-            </a:pPr>
-            <a:r>
-              <a:t>[ARCHITECTURE]  Framework Independence</a:t>
-            </a:r>
-          </a:p>
-          <a:p>
-            <a:pPr>
-              <a:spcBef>
-                <a:spcPts val="600"/>
-              </a:spcBef>
-              <a:defRPr sz="1100">
-                <a:solidFill>
-                  <a:srgbClr val="94A3B8"/>
-                </a:solidFill>
-              </a:defRPr>
-            </a:pPr>
-            <a:r>
-              <a:t>• Modern browsers have evolved: Native CSS custom properties and ES6 modules can replicate 95% of React's benefits.</a:t>
-            </a:r>
-          </a:p>
-          <a:p>
-            <a:pPr>
-              <a:spcBef>
-                <a:spcPts val="600"/>
-              </a:spcBef>
-              <a:defRPr sz="1100">
-                <a:solidFill>
-                  <a:srgbClr val="94A3B8"/>
-                </a:solidFill>
-              </a:defRPr>
-            </a:pPr>
-            <a:r>
-              <a:t>• Zero dependencies means zero vulnerability alerts, zero build-step breakages, and sub-150ms global load times.</a:t>
-            </a:r>
-          </a:p>
-          <a:p>
-            <a:pPr>
-              <a:spcBef>
-                <a:spcPts val="600"/>
-              </a:spcBef>
-              <a:defRPr sz="1100">
-                <a:solidFill>
-                  <a:srgbClr val="94A3B8"/>
-                </a:solidFill>
-              </a:defRPr>
-            </a:pPr>
-            <a:r>
-              <a:t>• Writing vanilla code sharpens core DOM and architectural fundamentals.</a:t>
-            </a:r>
-          </a:p>
-        </p:txBody>
-      </p:sp>
-      <p:sp>
-        <p:nvSpPr>
-          <p:cNvPr id="7" name="Rounded Rectangle 6"/>
-          <p:cNvSpPr/>
-          <p:nvPr/>
-        </p:nvSpPr>
-        <p:spPr>
-          <a:xfrm>
-            <a:off x="4443984" y="1828800"/>
-            <a:ext cx="3291840" cy="4389120"/>
-          </a:xfrm>
-          <a:prstGeom prst="roundRect">
-            <a:avLst/>
-          </a:prstGeom>
-          <a:solidFill>
-            <a:srgbClr val="161E2E"/>
-          </a:solidFill>
-          <a:ln w="15240">
-            <a:solidFill>
-              <a:srgbClr val="28354F"/>
-            </a:solidFill>
-          </a:ln>
-        </p:spPr>
-        <p:style>
-          <a:lnRef idx="1">
-            <a:schemeClr val="accent1"/>
-          </a:lnRef>
-          <a:fillRef idx="3">
-            <a:schemeClr val="accent1"/>
-          </a:fillRef>
-          <a:effectRef idx="2">
-            <a:schemeClr val="accent1"/>
-          </a:effectRef>
-          <a:fontRef idx="minor">
-            <a:schemeClr val="lt1"/>
-          </a:fontRef>
-        </p:style>
-        <p:txBody>
-          <a:bodyPr rtlCol="0" anchor="ctr"/>
-          <a:lstStyle/>
-          <a:p>
-            <a:pPr algn="ctr"/>
-          </a:p>
-        </p:txBody>
-      </p:sp>
-      <p:sp>
-        <p:nvSpPr>
-          <p:cNvPr id="8" name="TextBox 7"/>
-          <p:cNvSpPr txBox="1"/>
-          <p:nvPr/>
-        </p:nvSpPr>
-        <p:spPr>
-          <a:xfrm>
-            <a:off x="4672584" y="2011680"/>
-            <a:ext cx="2834640" cy="4023359"/>
-          </a:xfrm>
-          <a:prstGeom prst="rect">
-            <a:avLst/>
-          </a:prstGeom>
-          <a:noFill/>
-        </p:spPr>
-        <p:txBody>
-          <a:bodyPr wrap="square">
-            <a:spAutoFit/>
-          </a:bodyPr>
-          <a:lstStyle/>
-          <a:p>
-            <a:pPr>
-              <a:defRPr sz="1500" b="1">
-                <a:solidFill>
-                  <a:srgbClr val="34D399"/>
-                </a:solidFill>
-              </a:defRPr>
-            </a:pPr>
-            <a:r>
-              <a:t>[PRODUCT DESIGN]  Trust UX in FinTech</a:t>
-            </a:r>
-          </a:p>
-          <a:p>
-            <a:pPr>
-              <a:spcBef>
-                <a:spcPts val="600"/>
-              </a:spcBef>
-              <a:defRPr sz="1100">
-                <a:solidFill>
-                  <a:srgbClr val="94A3B8"/>
-                </a:solidFill>
-              </a:defRPr>
-            </a:pPr>
-            <a:r>
-              <a:t>• In high-value financial platforms, clarity beats flashiness every time.</a:t>
-            </a:r>
-          </a:p>
-          <a:p>
-            <a:pPr>
-              <a:spcBef>
-                <a:spcPts val="600"/>
-              </a:spcBef>
-              <a:defRPr sz="1100">
-                <a:solidFill>
-                  <a:srgbClr val="94A3B8"/>
-                </a:solidFill>
-              </a:defRPr>
-            </a:pPr>
-            <a:r>
-              <a:t>• Institutional users don't want neon glows; they want verified data tables, clear multiples, and verifiable audit trails.</a:t>
-            </a:r>
-          </a:p>
-          <a:p>
-            <a:pPr>
-              <a:spcBef>
-                <a:spcPts val="600"/>
-              </a:spcBef>
-              <a:defRPr sz="1100">
-                <a:solidFill>
-                  <a:srgbClr val="94A3B8"/>
-                </a:solidFill>
-              </a:defRPr>
-            </a:pPr>
-            <a:r>
-              <a:t>• Every UI element must answer: 'Why should I trust this platform with $1,000,000?'</a:t>
-            </a:r>
-          </a:p>
-        </p:txBody>
-      </p:sp>
-      <p:sp>
-        <p:nvSpPr>
-          <p:cNvPr id="9" name="Rounded Rectangle 8"/>
-          <p:cNvSpPr/>
-          <p:nvPr/>
-        </p:nvSpPr>
-        <p:spPr>
-          <a:xfrm>
-            <a:off x="8165592" y="1828800"/>
-            <a:ext cx="3291840" cy="4389120"/>
-          </a:xfrm>
-          <a:prstGeom prst="roundRect">
-            <a:avLst/>
-          </a:prstGeom>
-          <a:solidFill>
-            <a:srgbClr val="161E2E"/>
-          </a:solidFill>
-          <a:ln w="15240">
-            <a:solidFill>
-              <a:srgbClr val="28354F"/>
-            </a:solidFill>
-          </a:ln>
-        </p:spPr>
-        <p:style>
-          <a:lnRef idx="1">
-            <a:schemeClr val="accent1"/>
-          </a:lnRef>
-          <a:fillRef idx="3">
-            <a:schemeClr val="accent1"/>
-          </a:fillRef>
-          <a:effectRef idx="2">
-            <a:schemeClr val="accent1"/>
-          </a:effectRef>
-          <a:fontRef idx="minor">
-            <a:schemeClr val="lt1"/>
-          </a:fontRef>
-        </p:style>
-        <p:txBody>
-          <a:bodyPr rtlCol="0" anchor="ctr"/>
-          <a:lstStyle/>
-          <a:p>
-            <a:pPr algn="ctr"/>
-          </a:p>
-        </p:txBody>
-      </p:sp>
-      <p:sp>
-        <p:nvSpPr>
-          <p:cNvPr id="10" name="TextBox 9"/>
-          <p:cNvSpPr txBox="1"/>
-          <p:nvPr/>
-        </p:nvSpPr>
-        <p:spPr>
-          <a:xfrm>
-            <a:off x="8394192" y="2011680"/>
-            <a:ext cx="2834640" cy="4023359"/>
-          </a:xfrm>
-          <a:prstGeom prst="rect">
-            <a:avLst/>
-          </a:prstGeom>
-          <a:noFill/>
-        </p:spPr>
-        <p:txBody>
-          <a:bodyPr wrap="square">
-            <a:spAutoFit/>
-          </a:bodyPr>
-          <a:lstStyle/>
-          <a:p>
-            <a:pPr>
-              <a:defRPr sz="1500" b="1">
-                <a:solidFill>
-                  <a:srgbClr val="F59E0B"/>
-                </a:solidFill>
-              </a:defRPr>
-            </a:pPr>
-            <a:r>
-              <a:t>[TRANSACTION RISK]  Transaction Security First</a:t>
-            </a:r>
-          </a:p>
-          <a:p>
-            <a:pPr>
-              <a:spcBef>
-                <a:spcPts val="600"/>
-              </a:spcBef>
-              <a:defRPr sz="1100">
-                <a:solidFill>
-                  <a:srgbClr val="94A3B8"/>
-                </a:solidFill>
-              </a:defRPr>
-            </a:pPr>
-            <a:r>
-              <a:t>• A marketplace is only as good as its settlement safety.</a:t>
-            </a:r>
-          </a:p>
-          <a:p>
-            <a:pPr>
-              <a:spcBef>
-                <a:spcPts val="600"/>
-              </a:spcBef>
-              <a:defRPr sz="1100">
-                <a:solidFill>
-                  <a:srgbClr val="94A3B8"/>
-                </a:solidFill>
-              </a:defRPr>
-            </a:pPr>
-            <a:r>
-              <a:t>• Discovery and listing are easy; the hardest part of M&amp;A is the post-deal transfer.</a:t>
-            </a:r>
-          </a:p>
-          <a:p>
-            <a:pPr>
-              <a:spcBef>
-                <a:spcPts val="600"/>
-              </a:spcBef>
-              <a:defRPr sz="1100">
-                <a:solidFill>
-                  <a:srgbClr val="94A3B8"/>
-                </a:solidFill>
-              </a:defRPr>
-            </a:pPr>
-            <a:r>
-              <a:t>• Designing the Atomic Handover Protocol proved that solving deal anxiety is the ultimate competitive moat.</a:t>
-            </a:r>
-          </a:p>
-        </p:txBody>
-      </p:sp>
-    </p:spTree>
-  </p:cSld>
-  <p:clrMapOvr>
-    <a:masterClrMapping/>
-  </p:clrMapOvr>
-</p:sld>
-</file>
-
-<file path=ppt/slides/slide9.xml><?xml version="1.0" encoding="utf-8"?>
-<p:sld xmlns:a="http://schemas.openxmlformats.org/drawingml/2006/main" xmlns:p="http://schemas.openxmlformats.org/presentationml/2006/main" xmlns:r="http://schemas.openxmlformats.org/officeDocument/2006/relationships">
-  <p:cSld>
-    <p:spTree>
-      <p:nvGrpSpPr>
-        <p:cNvPr id="1" name=""/>
-        <p:cNvGrpSpPr/>
-        <p:nvPr/>
-      </p:nvGrpSpPr>
-      <p:grpSpPr/>
-      <p:sp>
-        <p:nvSpPr>
-          <p:cNvPr id="2" name="Rectangle 1"/>
-          <p:cNvSpPr/>
-          <p:nvPr/>
-        </p:nvSpPr>
-        <p:spPr>
-          <a:xfrm>
-            <a:off x="0" y="0"/>
-            <a:ext cx="12191695" cy="6858000"/>
-          </a:xfrm>
-          <a:prstGeom prst="rect">
-            <a:avLst/>
-          </a:prstGeom>
-          <a:solidFill>
-            <a:srgbClr val="0B0F19"/>
-          </a:solidFill>
-          <a:ln>
-            <a:noFill/>
-          </a:ln>
-        </p:spPr>
-        <p:style>
-          <a:lnRef idx="1">
-            <a:schemeClr val="accent1"/>
-          </a:lnRef>
-          <a:fillRef idx="3">
-            <a:schemeClr val="accent1"/>
-          </a:fillRef>
-          <a:effectRef idx="2">
-            <a:schemeClr val="accent1"/>
-          </a:effectRef>
-          <a:fontRef idx="minor">
-            <a:schemeClr val="lt1"/>
-          </a:fontRef>
-        </p:style>
-        <p:txBody>
-          <a:bodyPr rtlCol="0" anchor="ctr"/>
-          <a:lstStyle/>
-          <a:p>
-            <a:pPr algn="ctr"/>
-          </a:p>
-        </p:txBody>
-      </p:sp>
-      <p:sp>
-        <p:nvSpPr>
-          <p:cNvPr id="3" name="Rounded Rectangle 2"/>
-          <p:cNvSpPr/>
-          <p:nvPr/>
-        </p:nvSpPr>
-        <p:spPr>
-          <a:xfrm>
-            <a:off x="731520" y="457200"/>
-            <a:ext cx="2011680" cy="320040"/>
-          </a:xfrm>
-          <a:prstGeom prst="roundRect">
-            <a:avLst/>
-          </a:prstGeom>
-          <a:solidFill>
-            <a:srgbClr val="1E293B"/>
-          </a:solidFill>
-          <a:ln w="12700">
-            <a:solidFill>
-              <a:srgbClr val="28354F"/>
-            </a:solidFill>
-          </a:ln>
-        </p:spPr>
-        <p:style>
-          <a:lnRef idx="1">
-            <a:schemeClr val="accent1"/>
-          </a:lnRef>
-          <a:fillRef idx="3">
-            <a:schemeClr val="accent1"/>
-          </a:fillRef>
-          <a:effectRef idx="2">
-            <a:schemeClr val="accent1"/>
-          </a:effectRef>
-          <a:fontRef idx="minor">
-            <a:schemeClr val="lt1"/>
-          </a:fontRef>
-        </p:style>
-        <p:txBody>
-          <a:bodyPr rtlCol="0" anchor="ctr" wrap="square"/>
-          <a:lstStyle/>
-          <a:p>
-            <a:pPr algn="ctr">
-              <a:defRPr sz="900" b="1">
-                <a:solidFill>
-                  <a:srgbClr val="38BDF8"/>
-                </a:solidFill>
-              </a:defRPr>
-            </a:pPr>
-            <a:r>
-              <a:t>SUMMARY &amp; LIVE DELIVERABLES</a:t>
-            </a:r>
-          </a:p>
-        </p:txBody>
-      </p:sp>
-      <p:sp>
-        <p:nvSpPr>
-          <p:cNvPr id="4" name="TextBox 3"/>
-          <p:cNvSpPr txBox="1"/>
-          <p:nvPr/>
-        </p:nvSpPr>
-        <p:spPr>
-          <a:xfrm>
-            <a:off x="731520" y="822960"/>
-            <a:ext cx="10698480" cy="731520"/>
-          </a:xfrm>
-          <a:prstGeom prst="rect">
-            <a:avLst/>
-          </a:prstGeom>
-          <a:noFill/>
-        </p:spPr>
-        <p:txBody>
-          <a:bodyPr wrap="square">
-            <a:spAutoFit/>
-          </a:bodyPr>
-          <a:lstStyle/>
-          <a:p>
-            <a:pPr>
-              <a:defRPr sz="2400" b="1">
-                <a:solidFill>
-                  <a:srgbClr val="F8FAFC"/>
-                </a:solidFill>
-              </a:defRPr>
-            </a:pPr>
-            <a:r>
-              <a:t>Platform Summary &amp; Verified Links</a:t>
-            </a:r>
-          </a:p>
-          <a:p>
-            <a:pPr>
-              <a:defRPr sz="1200">
-                <a:solidFill>
-                  <a:srgbClr val="94A3B8"/>
-                </a:solidFill>
-              </a:defRPr>
-            </a:pPr>
-            <a:r>
-              <a:t>Complete project deliverables ready for testing and presentation.</a:t>
-            </a:r>
-          </a:p>
-        </p:txBody>
-      </p:sp>
-      <p:sp>
-        <p:nvSpPr>
-          <p:cNvPr id="5" name="Rounded Rectangle 4"/>
-          <p:cNvSpPr/>
-          <p:nvPr/>
-        </p:nvSpPr>
-        <p:spPr>
-          <a:xfrm>
-            <a:off x="731520" y="1828800"/>
-            <a:ext cx="5212080" cy="4389120"/>
-          </a:xfrm>
-          <a:prstGeom prst="roundRect">
-            <a:avLst/>
-          </a:prstGeom>
-          <a:solidFill>
-            <a:srgbClr val="161E2E"/>
-          </a:solidFill>
-          <a:ln w="15240">
-            <a:solidFill>
-              <a:srgbClr val="28354F"/>
-            </a:solidFill>
-          </a:ln>
-        </p:spPr>
-        <p:style>
-          <a:lnRef idx="1">
-            <a:schemeClr val="accent1"/>
-          </a:lnRef>
-          <a:fillRef idx="3">
-            <a:schemeClr val="accent1"/>
-          </a:fillRef>
-          <a:effectRef idx="2">
-            <a:schemeClr val="accent1"/>
-          </a:effectRef>
-          <a:fontRef idx="minor">
-            <a:schemeClr val="lt1"/>
-          </a:fontRef>
-        </p:style>
-        <p:txBody>
-          <a:bodyPr rtlCol="0" anchor="ctr"/>
-          <a:lstStyle/>
-          <a:p>
-            <a:pPr algn="ctr"/>
-          </a:p>
-        </p:txBody>
-      </p:sp>
-      <p:sp>
-        <p:nvSpPr>
-          <p:cNvPr id="6" name="TextBox 5"/>
-          <p:cNvSpPr txBox="1"/>
-          <p:nvPr/>
-        </p:nvSpPr>
-        <p:spPr>
-          <a:xfrm>
-            <a:off x="960120" y="2011680"/>
-            <a:ext cx="4754880" cy="4023359"/>
-          </a:xfrm>
-          <a:prstGeom prst="rect">
-            <a:avLst/>
-          </a:prstGeom>
-          <a:noFill/>
-        </p:spPr>
-        <p:txBody>
-          <a:bodyPr wrap="square">
-            <a:spAutoFit/>
-          </a:bodyPr>
-          <a:lstStyle/>
-          <a:p>
-            <a:pPr>
-              <a:defRPr sz="1500" b="1">
-                <a:solidFill>
-                  <a:srgbClr val="34D399"/>
-                </a:solidFill>
-              </a:defRPr>
-            </a:pPr>
-            <a:r>
-              <a:t>[STATUS: COMPLETE &amp; LIVE]  Project Deliverables</a:t>
-            </a:r>
-          </a:p>
-          <a:p>
-            <a:pPr>
-              <a:spcBef>
-                <a:spcPts val="600"/>
-              </a:spcBef>
-              <a:defRPr sz="1100">
-                <a:solidFill>
-                  <a:srgbClr val="94A3B8"/>
-                </a:solidFill>
-              </a:defRPr>
-            </a:pPr>
-            <a:r>
-              <a:t>• Complete 8-view institutional Single Page Application.</a:t>
-            </a:r>
-          </a:p>
-          <a:p>
-            <a:pPr>
-              <a:spcBef>
-                <a:spcPts val="600"/>
-              </a:spcBef>
-              <a:defRPr sz="1100">
-                <a:solidFill>
-                  <a:srgbClr val="94A3B8"/>
-                </a:solidFill>
-              </a:defRPr>
-            </a:pPr>
-            <a:r>
-              <a:t>• Live Atomic Handover Protocol simulator on every listing.</a:t>
-            </a:r>
-          </a:p>
-          <a:p>
-            <a:pPr>
-              <a:spcBef>
-                <a:spcPts val="600"/>
-              </a:spcBef>
-              <a:defRPr sz="1100">
-                <a:solidFill>
-                  <a:srgbClr val="94A3B8"/>
-                </a:solidFill>
-              </a:defRPr>
-            </a:pPr>
-            <a:r>
-              <a:t>• Interactive 2×2 Strategic Matrix and Demand/Supply curves.</a:t>
-            </a:r>
-          </a:p>
-          <a:p>
-            <a:pPr>
-              <a:spcBef>
-                <a:spcPts val="600"/>
-              </a:spcBef>
-              <a:defRPr sz="1100">
-                <a:solidFill>
-                  <a:srgbClr val="94A3B8"/>
-                </a:solidFill>
-              </a:defRPr>
-            </a:pPr>
-            <a:r>
-              <a:t>• Virtual Data Room (VDR) &amp; Video Review Terminal.</a:t>
-            </a:r>
-          </a:p>
-          <a:p>
-            <a:pPr>
-              <a:spcBef>
-                <a:spcPts val="600"/>
-              </a:spcBef>
-              <a:defRPr sz="1100">
-                <a:solidFill>
-                  <a:srgbClr val="94A3B8"/>
-                </a:solidFill>
-              </a:defRPr>
-            </a:pPr>
-            <a:r>
-              <a:t>• Dynamic fee calculator proving 60%+ savings vs brokers.</a:t>
-            </a:r>
-          </a:p>
-          <a:p>
-            <a:pPr>
-              <a:spcBef>
-                <a:spcPts val="600"/>
-              </a:spcBef>
-              <a:defRPr sz="1100">
-                <a:solidFill>
-                  <a:srgbClr val="94A3B8"/>
-                </a:solidFill>
-              </a:defRPr>
-            </a:pPr>
-            <a:r>
-              <a:t>• Fully tested: node -c syntax validation passed 100%.</a:t>
-            </a:r>
-          </a:p>
-        </p:txBody>
-      </p:sp>
-      <p:sp>
-        <p:nvSpPr>
-          <p:cNvPr id="7" name="Rounded Rectangle 6"/>
-          <p:cNvSpPr/>
-          <p:nvPr/>
-        </p:nvSpPr>
-        <p:spPr>
-          <a:xfrm>
-            <a:off x="6217920" y="1828800"/>
-            <a:ext cx="5212080" cy="4389120"/>
-          </a:xfrm>
-          <a:prstGeom prst="roundRect">
-            <a:avLst/>
-          </a:prstGeom>
-          <a:solidFill>
-            <a:srgbClr val="161E2E"/>
-          </a:solidFill>
-          <a:ln w="15240">
-            <a:solidFill>
-              <a:srgbClr val="28354F"/>
-            </a:solidFill>
-          </a:ln>
-        </p:spPr>
-        <p:style>
-          <a:lnRef idx="1">
-            <a:schemeClr val="accent1"/>
-          </a:lnRef>
-          <a:fillRef idx="3">
-            <a:schemeClr val="accent1"/>
-          </a:fillRef>
-          <a:effectRef idx="2">
-            <a:schemeClr val="accent1"/>
-          </a:effectRef>
-          <a:fontRef idx="minor">
-            <a:schemeClr val="lt1"/>
-          </a:fontRef>
-        </p:style>
-        <p:txBody>
-          <a:bodyPr rtlCol="0" anchor="ctr"/>
-          <a:lstStyle/>
-          <a:p>
-            <a:pPr algn="ctr"/>
-          </a:p>
-        </p:txBody>
-      </p:sp>
-      <p:sp>
-        <p:nvSpPr>
-          <p:cNvPr id="8" name="TextBox 7"/>
-          <p:cNvSpPr txBox="1"/>
-          <p:nvPr/>
-        </p:nvSpPr>
-        <p:spPr>
-          <a:xfrm>
-            <a:off x="6446520" y="2011680"/>
-            <a:ext cx="4754880" cy="4023359"/>
-          </a:xfrm>
-          <a:prstGeom prst="rect">
-            <a:avLst/>
-          </a:prstGeom>
-          <a:noFill/>
-        </p:spPr>
-        <p:txBody>
-          <a:bodyPr wrap="square">
-            <a:spAutoFit/>
-          </a:bodyPr>
-          <a:lstStyle/>
-          <a:p>
-            <a:pPr>
-              <a:defRPr sz="1500" b="1">
-                <a:solidFill>
-                  <a:srgbClr val="38BDF8"/>
-                </a:solidFill>
-              </a:defRPr>
-            </a:pPr>
-            <a:r>
-              <a:t>[VERIFIED DEPLOYMENT]  Live Access &amp; Source Code</a:t>
-            </a:r>
-          </a:p>
-          <a:p>
-            <a:pPr>
-              <a:spcBef>
-                <a:spcPts val="600"/>
-              </a:spcBef>
-              <a:defRPr sz="1100">
-                <a:solidFill>
-                  <a:srgbClr val="94A3B8"/>
-                </a:solidFill>
-              </a:defRPr>
-            </a:pPr>
-            <a:r>
-              <a:t>• Live Website URL: https://rohithagarwal.github.io/vventra/</a:t>
-            </a:r>
-          </a:p>
-          <a:p>
-            <a:pPr>
-              <a:spcBef>
-                <a:spcPts val="600"/>
-              </a:spcBef>
-              <a:defRPr sz="1100">
-                <a:solidFill>
-                  <a:srgbClr val="94A3B8"/>
-                </a:solidFill>
-              </a:defRPr>
-            </a:pPr>
-            <a:r>
-              <a:t>• GitHub Repository: https://github.com/rohithagarwal/vventra</a:t>
-            </a:r>
-          </a:p>
-          <a:p>
-            <a:pPr>
-              <a:spcBef>
-                <a:spcPts val="600"/>
-              </a:spcBef>
-              <a:defRPr sz="1100">
-                <a:solidFill>
-                  <a:srgbClr val="94A3B8"/>
-                </a:solidFill>
-              </a:defRPr>
-            </a:pPr>
-            <a:r>
-              <a:t>• Branch: main (Clean working tree, up to date with origin)</a:t>
-            </a:r>
-          </a:p>
-          <a:p>
-            <a:pPr>
-              <a:spcBef>
-                <a:spcPts val="600"/>
-              </a:spcBef>
-              <a:defRPr sz="1100">
-                <a:solidFill>
-                  <a:srgbClr val="94A3B8"/>
-                </a:solidFill>
-              </a:defRPr>
-            </a:pPr>
-            <a:r>
-              <a:t>• Zero hosting costs, served globally via GitHub CDN.</a:t>
-            </a:r>
-          </a:p>
-          <a:p>
-            <a:pPr>
-              <a:spcBef>
-                <a:spcPts val="600"/>
-              </a:spcBef>
-              <a:defRPr sz="1100">
-                <a:solidFill>
-                  <a:srgbClr val="94A3B8"/>
-                </a:solidFill>
-              </a:defRPr>
-            </a:pPr>
-            <a:r>
-              <a:t>• Easily editable locally with automatic deployment on git push.</a:t>
+              <a:t>• Engineering the Atomic Handover Protocol demonstrated that safety and escrow mechanics are the platform's primary competitive advantage.</a:t>
             </a:r>
           </a:p>
         </p:txBody>

</xml_diff>

<commit_message>
Simplify presentation: plain layout, simple vocabulary, efficient 6-slide structure
</commit_message>
<xml_diff>
--- a/vventra_presentation.pptx
+++ b/vventra_presentation.pptx
@@ -11,7 +11,6 @@
     <p:sldId id="259" r:id="rId11"/>
     <p:sldId id="260" r:id="rId12"/>
     <p:sldId id="261" r:id="rId13"/>
-    <p:sldId id="262" r:id="rId14"/>
   </p:sldIdLst>
   <p:sldSz cx="12191695" cy="6858000" type="screen4x3"/>
   <p:notesSz cx="6858000" cy="9144000"/>
@@ -508,7 +507,7 @@
           <a:lstStyle/>
           <a:p>
             <a:r>
-              <a:t>Today I'm presenting a complete, content-focused breakdown of vvEntra. We will focus directly on substance: what problem the website solves, the mutual benefits for users and our platform, every major functionality, the zero-dependency tech stack and its AI-agent extensibility, our core innovation compared to the original reference site, and key lessons learned.</a:t>
+              <a:t>Hello everyone. Today I'm presenting vvEntra. In simple terms, vvEntra is an online marketplace where people can buy and sell software businesses safely. I rebuilt the website using simple, clean code with zero extra libraries, made it load fast, and added a safe 4-step handover system so neither buyers nor sellers get scammed.</a:t>
             </a:r>
           </a:p>
         </p:txBody>
@@ -578,7 +577,7 @@
           <a:lstStyle/>
           <a:p>
             <a:r>
-              <a:t>Point 1: The core idea of vvEntra is to be the trusted escrow and exchange for software businesses. It solves the 15% broker fees and rampant scams on open marketplaces. For users: Buyers get verified financials and audited code; sellers save tens of thousands in fees and protect their IP. For us as a business: We capture a 3% to 7% transaction fee on every deal, plus premium compliance and audit revenue.</a:t>
+              <a:t>Point 1: What is the core idea? Think of it like a trusted real estate agent, but for apps and software instead of houses. It solves three simple problems: high broker fees, fake earnings screenshots, and the fear of getting scammed. Buyers get real, verified numbers and safe escrow. Sellers save tens of thousands in fees and protect their code. And for our platform, we make a clear 3% to 7% fee on every successful sale.</a:t>
             </a:r>
           </a:p>
         </p:txBody>
@@ -648,7 +647,7 @@
           <a:lstStyle/>
           <a:p>
             <a:r>
-              <a:t>Point 2, Part 1: Major functionalities for market intelligence. Our 2x2 matrix categorizes companies by moat versus multiple and actively filters listings. Our native SVG demand curves and 6-axis radar give investors complete operational health diagnostics. And our valuation recommender lets founders instantly calculate their expected multiple and sale probability.</a:t>
+              <a:t>Point 2: Here are the main features of the website. First, a top switch that flips between Buyer and Seller mode. Second, a dashboard with a 4-box grid where users can click to filter companies, and charts showing market demand. Third, a calculator that tells founders what their software is worth. Fourth, a clean marketplace to search apps. And fifth, a private data room to view sensitive business records safely.</a:t>
             </a:r>
           </a:p>
         </p:txBody>
@@ -718,7 +717,7 @@
           <a:lstStyle/>
           <a:p>
             <a:r>
-              <a:t>Point 2, Part 2: On the transaction and diligence side, each listing has deep audited dossiers. The Virtual Data Room protects sensitive information until an NDA is signed. The video console gives buyers a direct code walkthrough, and our transparent fee calculator proves massive savings.</a:t>
+              <a:t>Point 3: For our tech stack, we kept it 100% simple: pure HTML, CSS, and Vanilla JavaScript with zero extra libraries. Why is this helpful for adding AI agents? Because all data is stored in one clean file (data.js), and the web code is completely clean without complex React layers. AI agents can easily connect to it: an AI can scan GitHub code, an AI can automatically update prices, and an AI assistant can answer buyers' questions inside the private data room.</a:t>
             </a:r>
           </a:p>
         </p:txBody>
@@ -788,7 +787,7 @@
           <a:lstStyle/>
           <a:p>
             <a:r>
-              <a:t>Point 3: The tech stack is 100% pure HTML5, CSS3 with BEM, and Vanilla JS. Why is this stack uniquely valuable for adding AI agents? Because all data lives in a clean, isolated data layer (data.js) without React build bloat. Autonomous AI agents can easily inspect predictable DOM structures, run automated code audits on repositories, dynamically adjust valuation multiples, and verify cloud transfers before releasing escrow funds.</a:t>
+              <a:t>Point 4: What is our main innovation compared to the original site? The original site had flashy neon colors, but the buttons and charts didn't do much, and there was no way to safely transfer apps. We built the Safe 4-Step Handover system: money is locked in escrow, code is secured, the domain is moved, and the buyer confirms everything works before the money is released. We also added a live simulator on every listing so users can click through and see the safety for themselves.</a:t>
             </a:r>
           </a:p>
         </p:txBody>
@@ -858,77 +857,7 @@
           <a:lstStyle/>
           <a:p>
             <a:r>
-              <a:t>Point 4: Innovation compared to the original site. The original site had a flashy neon look, but the components were mostly static and lacked a real transfer mechanism. Our core innovation is the Atomic Handover Protocol: an interactive 4-phase custody transfer that proves step-by-step how money, cloud credentials, code, and domains are safely migrated before final payment releases. This transforms the website from a passive bulletin board into an active, trusted transaction engine.</a:t>
-            </a:r>
-          </a:p>
-        </p:txBody>
-      </p:sp>
-      <p:sp>
-        <p:nvSpPr>
-          <p:cNvPr id="4" name="Slide Number Placeholder 3"/>
-          <p:cNvSpPr>
-            <a:spLocks noGrp="1"/>
-          </p:cNvSpPr>
-          <p:nvPr>
-            <p:ph type="sldNum" idx="5" sz="quarter"/>
-          </p:nvPr>
-        </p:nvSpPr>
-        <p:spPr/>
-      </p:sp>
-    </p:spTree>
-  </p:cSld>
-  <p:clrMapOvr>
-    <a:masterClrMapping/>
-  </p:clrMapOvr>
-</p:notes>
-</file>
-
-<file path=ppt/notesSlides/notesSlide7.xml><?xml version="1.0" encoding="utf-8"?>
-<p:notes xmlns:a="http://schemas.openxmlformats.org/drawingml/2006/main" xmlns:p="http://schemas.openxmlformats.org/presentationml/2006/main" xmlns:r="http://schemas.openxmlformats.org/officeDocument/2006/relationships">
-  <p:cSld>
-    <p:spTree>
-      <p:nvGrpSpPr>
-        <p:cNvPr id="1" name=""/>
-        <p:cNvGrpSpPr/>
-        <p:nvPr/>
-      </p:nvGrpSpPr>
-      <p:grpSpPr>
-        <a:xfrm>
-          <a:off x="0" y="0"/>
-          <a:ext cx="0" cy="0"/>
-          <a:chOff x="0" y="0"/>
-          <a:chExt cx="0" cy="0"/>
-        </a:xfrm>
-      </p:grpSpPr>
-      <p:sp>
-        <p:nvSpPr>
-          <p:cNvPr id="2" name="Slide Image Placeholder 1"/>
-          <p:cNvSpPr>
-            <a:spLocks noGrp="1"/>
-          </p:cNvSpPr>
-          <p:nvPr>
-            <p:ph type="sldImg" idx="2"/>
-          </p:nvPr>
-        </p:nvSpPr>
-        <p:spPr/>
-      </p:sp>
-      <p:sp>
-        <p:nvSpPr>
-          <p:cNvPr id="3" name="Notes Placeholder 2"/>
-          <p:cNvSpPr>
-            <a:spLocks noGrp="1"/>
-          </p:cNvSpPr>
-          <p:nvPr>
-            <p:ph type="body" idx="3" sz="quarter"/>
-          </p:nvPr>
-        </p:nvSpPr>
-        <p:spPr/>
-        <p:txBody>
-          <a:bodyPr/>
-          <a:lstStyle/>
-          <a:p>
-            <a:r>
-              <a:t>Point 5: To conclude, our three biggest learnings: First, zero-dependency engineering proves that modern vanilla web standards deliver unmatched speed and reliability. Second, in high-value finance, clean typography and data transparency beat flashy animations every time. And third, solving post-agreement custody anxiety is the real secret to building a defensible software M&amp;A platform. Thank you! The live platform and presentation are accessible online.</a:t>
+              <a:t>Point 5: To wrap up, our three biggest learnings: First, simple code is faster and easier to maintain than heavy frameworks. Second, clean numbers and honest data build much more trust than flashy animations. And third, solving the safety problem of handing over code is what gives this platform real value. The website is live and ready to view. Thank you!</a:t>
             </a:r>
           </a:p>
         </p:txBody>
@@ -3949,7 +3878,7 @@
             <a:avLst/>
           </a:prstGeom>
           <a:solidFill>
-            <a:srgbClr val="0B0F19"/>
+            <a:srgbClr val="0F172A"/>
           </a:solidFill>
           <a:ln>
             <a:noFill/>
@@ -3992,11 +3921,11 @@
             <a:avLst/>
           </a:prstGeom>
           <a:solidFill>
-            <a:srgbClr val="121826"/>
+            <a:srgbClr val="1E293B"/>
           </a:solidFill>
           <a:ln>
             <a:solidFill>
-              <a:srgbClr val="26324A"/>
+              <a:srgbClr val="334155"/>
             </a:solidFill>
           </a:ln>
         </p:spPr>
@@ -4030,8 +3959,8 @@
         </p:nvSpPr>
         <p:spPr>
           <a:xfrm>
-            <a:off x="1097280" y="1737360"/>
-            <a:ext cx="10058400" cy="3474720"/>
+            <a:off x="1097280" y="1828800"/>
+            <a:ext cx="10058400" cy="3291840"/>
           </a:xfrm>
           <a:prstGeom prst="rect">
             <a:avLst/>
@@ -4045,14 +3974,14 @@
           <a:lstStyle/>
           <a:p>
             <a:pPr>
-              <a:defRPr sz="3800" b="1">
-                <a:solidFill>
-                  <a:srgbClr val="F8FAFC"/>
-                </a:solidFill>
-              </a:defRPr>
-            </a:pPr>
-            <a:r>
-              <a:t>vvEntra: Platform Deep-Dive</a:t>
+              <a:defRPr sz="4000" b="1">
+                <a:solidFill>
+                  <a:srgbClr val="FFFFFF"/>
+                </a:solidFill>
+              </a:defRPr>
+            </a:pPr>
+            <a:r>
+              <a:t>vvEntra</a:t>
             </a:r>
           </a:p>
           <a:p>
@@ -4067,7 +3996,7 @@
               </a:defRPr>
             </a:pPr>
             <a:r>
-              <a:t>Comprehensive Content, Architecture, Extensibility &amp; Innovation Analysis</a:t>
+              <a:t>A Safe Marketplace to Buy &amp; Sell Software Businesses</a:t>
             </a:r>
           </a:p>
           <a:p>
@@ -4075,29 +4004,29 @@
               <a:spcBef>
                 <a:spcPts val="1400"/>
               </a:spcBef>
-              <a:defRPr sz="1200">
-                <a:solidFill>
-                  <a:srgbClr val="94A3B8"/>
-                </a:solidFill>
-              </a:defRPr>
-            </a:pPr>
-            <a:r>
-              <a:t>A detailed breakdown focused entirely on business logic, technical viability, AI agent readiness, and verified M&amp;A custody.</a:t>
+              <a:defRPr sz="1300">
+                <a:solidFill>
+                  <a:srgbClr val="CBD5E1"/>
+                </a:solidFill>
+              </a:defRPr>
+            </a:pPr>
+            <a:r>
+              <a:t>A simple, fast website where developers and investors trade apps and software safely without getting scammed.</a:t>
             </a:r>
           </a:p>
           <a:p>
             <a:pPr>
               <a:spcBef>
-                <a:spcPts val="2000"/>
+                <a:spcPts val="2400"/>
               </a:spcBef>
               <a:defRPr sz="1100">
                 <a:solidFill>
-                  <a:srgbClr val="34D399"/>
-                </a:solidFill>
-              </a:defRPr>
-            </a:pPr>
-            <a:r>
-              <a:t>Live Hosted URL: https://rohithagarwal.github.io/vventra/  |  Repository: github.com/rohithagarwal/vventra</a:t>
+                  <a:srgbClr val="4ADE80"/>
+                </a:solidFill>
+              </a:defRPr>
+            </a:pPr>
+            <a:r>
+              <a:t>Live Website: https://rohithagarwal.github.io/vventra/  |  Repository: github.com/rohithagarwal/vventra</a:t>
             </a:r>
           </a:p>
         </p:txBody>
@@ -4135,7 +4064,7 @@
             <a:avLst/>
           </a:prstGeom>
           <a:solidFill>
-            <a:srgbClr val="0B0F19"/>
+            <a:srgbClr val="0F172A"/>
           </a:solidFill>
           <a:ln>
             <a:noFill/>
@@ -4171,18 +4100,18 @@
         </p:nvSpPr>
         <p:spPr>
           <a:xfrm>
-            <a:off x="731520" y="411480"/>
-            <a:ext cx="2560320" cy="320040"/>
+            <a:off x="731520" y="457200"/>
+            <a:ext cx="2011680" cy="320040"/>
           </a:xfrm>
           <a:prstGeom prst="roundRect">
             <a:avLst/>
           </a:prstGeom>
           <a:solidFill>
-            <a:srgbClr val="1A2436"/>
+            <a:srgbClr val="1E293B"/>
           </a:solidFill>
           <a:ln w="12700">
             <a:solidFill>
-              <a:srgbClr val="26324A"/>
+              <a:srgbClr val="334155"/>
             </a:solidFill>
           </a:ln>
         </p:spPr>
@@ -4212,7 +4141,7 @@
               </a:defRPr>
             </a:pPr>
             <a:r>
-              <a:t>1. CORE MISSION</a:t>
+              <a:t>1. CORE IDEA</a:t>
             </a:r>
           </a:p>
         </p:txBody>
@@ -4225,7 +4154,7 @@
         </p:nvSpPr>
         <p:spPr>
           <a:xfrm>
-            <a:off x="731520" y="777240"/>
+            <a:off x="731520" y="822960"/>
             <a:ext cx="10698480" cy="731520"/>
           </a:xfrm>
           <a:prstGeom prst="rect">
@@ -4242,24 +4171,24 @@
             <a:pPr>
               <a:defRPr sz="2200" b="1">
                 <a:solidFill>
-                  <a:srgbClr val="F8FAFC"/>
-                </a:solidFill>
-              </a:defRPr>
-            </a:pPr>
-            <a:r>
-              <a:t>Core Idea, Problem Solved &amp; Mutual Benefits</a:t>
+                  <a:srgbClr val="FFFFFF"/>
+                </a:solidFill>
+              </a:defRPr>
+            </a:pPr>
+            <a:r>
+              <a:t>What is vvEntra, What It Solves &amp; Why It Helps</a:t>
             </a:r>
           </a:p>
           <a:p>
             <a:pPr>
               <a:defRPr sz="1100">
                 <a:solidFill>
-                  <a:srgbClr val="94A3B8"/>
-                </a:solidFill>
-              </a:defRPr>
-            </a:pPr>
-            <a:r>
-              <a:t>The commercial rationale behind vvEntra and how it generates mutual value.</a:t>
+                  <a:srgbClr val="CBD5E1"/>
+                </a:solidFill>
+              </a:defRPr>
+            </a:pPr>
+            <a:r>
+              <a:t>A simple explanation of the business and who it helps.</a:t>
             </a:r>
           </a:p>
         </p:txBody>
@@ -4279,11 +4208,11 @@
             <a:avLst/>
           </a:prstGeom>
           <a:solidFill>
-            <a:srgbClr val="121826"/>
+            <a:srgbClr val="1E293B"/>
           </a:solidFill>
           <a:ln w="15240">
             <a:solidFill>
-              <a:srgbClr val="26324A"/>
+              <a:srgbClr val="334155"/>
             </a:solidFill>
           </a:ln>
         </p:spPr>
@@ -4334,57 +4263,57 @@
             <a:pPr>
               <a:defRPr sz="1400" b="1">
                 <a:solidFill>
-                  <a:srgbClr val="F59E0B"/>
-                </a:solidFill>
-              </a:defRPr>
-            </a:pPr>
-            <a:r>
-              <a:t>[THE PROBLEM]  The Problem Solved</a:t>
+                  <a:srgbClr val="FBBF24"/>
+                </a:solidFill>
+              </a:defRPr>
+            </a:pPr>
+            <a:r>
+              <a:t>[THE PROBLEM]  The Problem It Solves</a:t>
             </a:r>
           </a:p>
           <a:p>
             <a:pPr>
               <a:spcBef>
-                <a:spcPts val="500"/>
+                <a:spcPts val="600"/>
               </a:spcBef>
-              <a:defRPr sz="1050">
-                <a:solidFill>
-                  <a:srgbClr val="94A3B8"/>
-                </a:solidFill>
-              </a:defRPr>
-            </a:pPr>
-            <a:r>
-              <a:t>• Predatory Broker Fees: Traditional brokers take 10%–15% cuts and take 6 to 12 months.</a:t>
+              <a:defRPr sz="1100">
+                <a:solidFill>
+                  <a:srgbClr val="CBD5E1"/>
+                </a:solidFill>
+              </a:defRPr>
+            </a:pPr>
+            <a:r>
+              <a:t>• Expensive Middlemen: Traditional brokers charge huge fees (10% to 15%) and take 6 to 12 months.</a:t>
             </a:r>
           </a:p>
           <a:p>
             <a:pPr>
               <a:spcBef>
-                <a:spcPts val="500"/>
+                <a:spcPts val="600"/>
               </a:spcBef>
-              <a:defRPr sz="1050">
-                <a:solidFill>
-                  <a:srgbClr val="94A3B8"/>
-                </a:solidFill>
-              </a:defRPr>
-            </a:pPr>
-            <a:r>
-              <a:t>• Rampant Scams: Public listing sites are full of faked revenue screenshots and plagiarized code.</a:t>
+              <a:defRPr sz="1100">
+                <a:solidFill>
+                  <a:srgbClr val="CBD5E1"/>
+                </a:solidFill>
+              </a:defRPr>
+            </a:pPr>
+            <a:r>
+              <a:t>• Fake Numbers: Public websites are full of fake revenue screenshots and stolen code.</a:t>
             </a:r>
           </a:p>
           <a:p>
             <a:pPr>
               <a:spcBef>
-                <a:spcPts val="500"/>
+                <a:spcPts val="600"/>
               </a:spcBef>
-              <a:defRPr sz="1050">
-                <a:solidFill>
-                  <a:srgbClr val="94A3B8"/>
-                </a:solidFill>
-              </a:defRPr>
-            </a:pPr>
-            <a:r>
-              <a:t>• Settlement Anxiety: Buyers fear losing capital without receiving code; sellers fear handing over code and getting ghosted.</a:t>
+              <a:defRPr sz="1100">
+                <a:solidFill>
+                  <a:srgbClr val="CBD5E1"/>
+                </a:solidFill>
+              </a:defRPr>
+            </a:pPr>
+            <a:r>
+              <a:t>• Fear of Getting Cheated: Buyers are afraid to pay first and get ghosted. Sellers are afraid to give away code without getting paid.</a:t>
             </a:r>
           </a:p>
         </p:txBody>
@@ -4404,11 +4333,11 @@
             <a:avLst/>
           </a:prstGeom>
           <a:solidFill>
-            <a:srgbClr val="121826"/>
+            <a:srgbClr val="1E293B"/>
           </a:solidFill>
           <a:ln w="15240">
             <a:solidFill>
-              <a:srgbClr val="26324A"/>
+              <a:srgbClr val="334155"/>
             </a:solidFill>
           </a:ln>
         </p:spPr>
@@ -4459,57 +4388,57 @@
             <a:pPr>
               <a:defRPr sz="1400" b="1">
                 <a:solidFill>
-                  <a:srgbClr val="34D399"/>
-                </a:solidFill>
-              </a:defRPr>
-            </a:pPr>
-            <a:r>
-              <a:t>[FOR USERS]  Benefits for Users</a:t>
+                  <a:srgbClr val="4ADE80"/>
+                </a:solidFill>
+              </a:defRPr>
+            </a:pPr>
+            <a:r>
+              <a:t>[FOR USERS]  Benefits for the User</a:t>
             </a:r>
           </a:p>
           <a:p>
             <a:pPr>
               <a:spcBef>
-                <a:spcPts val="500"/>
+                <a:spcPts val="600"/>
               </a:spcBef>
-              <a:defRPr sz="1050">
-                <a:solidFill>
-                  <a:srgbClr val="94A3B8"/>
-                </a:solidFill>
-              </a:defRPr>
-            </a:pPr>
-            <a:r>
-              <a:t>• For Buyers: 100% verified Stripe revenue data (no fake screenshots), audited source code, and escrow safety (funds held safely until tech is verified).</a:t>
+              <a:defRPr sz="1100">
+                <a:solidFill>
+                  <a:srgbClr val="CBD5E1"/>
+                </a:solidFill>
+              </a:defRPr>
+            </a:pPr>
+            <a:r>
+              <a:t>• For Buyers: Real earnings checked with Stripe (no fake screenshots); code is checked for bugs; money stays safe in escrow.</a:t>
             </a:r>
           </a:p>
           <a:p>
             <a:pPr>
               <a:spcBef>
-                <a:spcPts val="500"/>
+                <a:spcPts val="600"/>
               </a:spcBef>
-              <a:defRPr sz="1050">
-                <a:solidFill>
-                  <a:srgbClr val="94A3B8"/>
-                </a:solidFill>
-              </a:defRPr>
-            </a:pPr>
-            <a:r>
-              <a:t>• For Sellers: Low sliding fees (3%–7% saving $50k+ per deal), access to vetted institutional buyers, and zero code-theft risk via escrow custody.</a:t>
+              <a:defRPr sz="1100">
+                <a:solidFill>
+                  <a:srgbClr val="CBD5E1"/>
+                </a:solidFill>
+              </a:defRPr>
+            </a:pPr>
+            <a:r>
+              <a:t>• For Sellers: Much lower fees (3% to 7% instead of 15%, saving $50k+); code is never handed over until the buyer's money is locked.</a:t>
             </a:r>
           </a:p>
           <a:p>
             <a:pPr>
               <a:spcBef>
-                <a:spcPts val="500"/>
+                <a:spcPts val="600"/>
               </a:spcBef>
-              <a:defRPr sz="1050">
-                <a:solidFill>
-                  <a:srgbClr val="94A3B8"/>
-                </a:solidFill>
-              </a:defRPr>
-            </a:pPr>
-            <a:r>
-              <a:t>• Frictionless Closing: Deals close in an average of 18 days instead of 9 months.</a:t>
+              <a:defRPr sz="1100">
+                <a:solidFill>
+                  <a:srgbClr val="CBD5E1"/>
+                </a:solidFill>
+              </a:defRPr>
+            </a:pPr>
+            <a:r>
+              <a:t>• Fast Deals: Deals close in about 18 days instead of almost a year.</a:t>
             </a:r>
           </a:p>
         </p:txBody>
@@ -4529,11 +4458,11 @@
             <a:avLst/>
           </a:prstGeom>
           <a:solidFill>
-            <a:srgbClr val="121826"/>
+            <a:srgbClr val="1E293B"/>
           </a:solidFill>
           <a:ln w="15240">
             <a:solidFill>
-              <a:srgbClr val="26324A"/>
+              <a:srgbClr val="334155"/>
             </a:solidFill>
           </a:ln>
         </p:spPr>
@@ -4589,52 +4518,52 @@
               </a:defRPr>
             </a:pPr>
             <a:r>
-              <a:t>[FOR OUR PLATFORM]  Benefits for Us (The Platform)</a:t>
+              <a:t>[FOR OUR PLATFORM]  Benefits for Us (Our Business)</a:t>
             </a:r>
           </a:p>
           <a:p>
             <a:pPr>
               <a:spcBef>
-                <a:spcPts val="500"/>
+                <a:spcPts val="600"/>
               </a:spcBef>
-              <a:defRPr sz="1050">
-                <a:solidFill>
-                  <a:srgbClr val="94A3B8"/>
-                </a:solidFill>
-              </a:defRPr>
-            </a:pPr>
-            <a:r>
-              <a:t>• High-Margin Revenue: 3% to 7% success fee on every closed acquisition (e.g. $1M buyout = $50,000 revenue).</a:t>
+              <a:defRPr sz="1100">
+                <a:solidFill>
+                  <a:srgbClr val="CBD5E1"/>
+                </a:solidFill>
+              </a:defRPr>
+            </a:pPr>
+            <a:r>
+              <a:t>• Simple Business Model: We take a small 3% to 7% fee on every sale (e.g. $30,000 profit on a $500,000 deal).</a:t>
             </a:r>
           </a:p>
           <a:p>
             <a:pPr>
               <a:spcBef>
-                <a:spcPts val="500"/>
+                <a:spcPts val="600"/>
               </a:spcBef>
-              <a:defRPr sz="1050">
-                <a:solidFill>
-                  <a:srgbClr val="94A3B8"/>
-                </a:solidFill>
-              </a:defRPr>
-            </a:pPr>
-            <a:r>
-              <a:t>• Ancillary Monetization: Premium Virtual Data Room (VDR) compliance services, escrow fees, and verified audit badges.</a:t>
+              <a:defRPr sz="1100">
+                <a:solidFill>
+                  <a:srgbClr val="CBD5E1"/>
+                </a:solidFill>
+              </a:defRPr>
+            </a:pPr>
+            <a:r>
+              <a:t>• Extra Services: Revenue from code audits, escrow fees, and private deal room access.</a:t>
             </a:r>
           </a:p>
           <a:p>
             <a:pPr>
               <a:spcBef>
-                <a:spcPts val="500"/>
+                <a:spcPts val="600"/>
               </a:spcBef>
-              <a:defRPr sz="1050">
-                <a:solidFill>
-                  <a:srgbClr val="94A3B8"/>
-                </a:solidFill>
-              </a:defRPr>
-            </a:pPr>
-            <a:r>
-              <a:t>• Proprietary Data Moat: Building an exclusive database of private tech valuation multiples, deal velocity, and liquidity spreads.</a:t>
+              <a:defRPr sz="1100">
+                <a:solidFill>
+                  <a:srgbClr val="CBD5E1"/>
+                </a:solidFill>
+              </a:defRPr>
+            </a:pPr>
+            <a:r>
+              <a:t>• Valuable Market Data: We build a real database of how much software companies actually sell for.</a:t>
             </a:r>
           </a:p>
         </p:txBody>
@@ -4672,7 +4601,7 @@
             <a:avLst/>
           </a:prstGeom>
           <a:solidFill>
-            <a:srgbClr val="0B0F19"/>
+            <a:srgbClr val="0F172A"/>
           </a:solidFill>
           <a:ln>
             <a:noFill/>
@@ -4708,18 +4637,18 @@
         </p:nvSpPr>
         <p:spPr>
           <a:xfrm>
-            <a:off x="731520" y="411480"/>
-            <a:ext cx="2560320" cy="320040"/>
+            <a:off x="731520" y="457200"/>
+            <a:ext cx="2011680" cy="320040"/>
           </a:xfrm>
           <a:prstGeom prst="roundRect">
             <a:avLst/>
           </a:prstGeom>
           <a:solidFill>
-            <a:srgbClr val="1A2436"/>
+            <a:srgbClr val="1E293B"/>
           </a:solidFill>
           <a:ln w="12700">
             <a:solidFill>
-              <a:srgbClr val="26324A"/>
+              <a:srgbClr val="334155"/>
             </a:solidFill>
           </a:ln>
         </p:spPr>
@@ -4749,7 +4678,7 @@
               </a:defRPr>
             </a:pPr>
             <a:r>
-              <a:t>2. PLATFORM CAPABILITIES</a:t>
+              <a:t>2. MAIN FEATURES</a:t>
             </a:r>
           </a:p>
         </p:txBody>
@@ -4762,7 +4691,7 @@
         </p:nvSpPr>
         <p:spPr>
           <a:xfrm>
-            <a:off x="731520" y="777240"/>
+            <a:off x="731520" y="822960"/>
             <a:ext cx="10698480" cy="731520"/>
           </a:xfrm>
           <a:prstGeom prst="rect">
@@ -4779,24 +4708,24 @@
             <a:pPr>
               <a:defRPr sz="2200" b="1">
                 <a:solidFill>
-                  <a:srgbClr val="F8FAFC"/>
-                </a:solidFill>
-              </a:defRPr>
-            </a:pPr>
-            <a:r>
-              <a:t>Major Functionality: Market Intelligence &amp; Discovery</a:t>
+                  <a:srgbClr val="FFFFFF"/>
+                </a:solidFill>
+              </a:defRPr>
+            </a:pPr>
+            <a:r>
+              <a:t>Each Major Functionality of the Website</a:t>
             </a:r>
           </a:p>
           <a:p>
             <a:pPr>
               <a:defRPr sz="1100">
                 <a:solidFill>
-                  <a:srgbClr val="94A3B8"/>
-                </a:solidFill>
-              </a:defRPr>
-            </a:pPr>
-            <a:r>
-              <a:t>Core tools that power buyer-seller discovery and live deal telemetry.</a:t>
+                  <a:srgbClr val="CBD5E1"/>
+                </a:solidFill>
+              </a:defRPr>
+            </a:pPr>
+            <a:r>
+              <a:t>What users can actually do on the website.</a:t>
             </a:r>
           </a:p>
         </p:txBody>
@@ -4816,11 +4745,11 @@
             <a:avLst/>
           </a:prstGeom>
           <a:solidFill>
-            <a:srgbClr val="121826"/>
+            <a:srgbClr val="1E293B"/>
           </a:solidFill>
           <a:ln w="15240">
             <a:solidFill>
-              <a:srgbClr val="26324A"/>
+              <a:srgbClr val="334155"/>
             </a:solidFill>
           </a:ln>
         </p:spPr>
@@ -4876,52 +4805,52 @@
               </a:defRPr>
             </a:pPr>
             <a:r>
-              <a:t>[M&amp;A QUADRANT]  2×2 Strategic Matrix</a:t>
+              <a:t>[DASHBOARD]  Market Tools &amp; Dashboard</a:t>
             </a:r>
           </a:p>
           <a:p>
             <a:pPr>
               <a:spcBef>
-                <a:spcPts val="500"/>
+                <a:spcPts val="600"/>
               </a:spcBef>
-              <a:defRPr sz="1050">
-                <a:solidFill>
-                  <a:srgbClr val="94A3B8"/>
-                </a:solidFill>
-              </a:defRPr>
-            </a:pPr>
-            <a:r>
-              <a:t>• Arranges software companies across ARR Multiples vs. Technical Moat.</a:t>
+              <a:defRPr sz="1100">
+                <a:solidFill>
+                  <a:srgbClr val="CBD5E1"/>
+                </a:solidFill>
+              </a:defRPr>
+            </a:pPr>
+            <a:r>
+              <a:t>• Buyer / Seller Switch: One click changes the view to show what buyers care about (returns) or what sellers care about (how much their app is worth).</a:t>
             </a:r>
           </a:p>
           <a:p>
             <a:pPr>
               <a:spcBef>
-                <a:spcPts val="500"/>
+                <a:spcPts val="600"/>
               </a:spcBef>
-              <a:defRPr sz="1050">
-                <a:solidFill>
-                  <a:srgbClr val="94A3B8"/>
-                </a:solidFill>
-              </a:defRPr>
-            </a:pPr>
-            <a:r>
-              <a:t>• 4 Distinct Quadrants: Scale Giants, Enterprise Niche, Emerging High-Alpha, and Utility Tools.</a:t>
+              <a:defRPr sz="1100">
+                <a:solidFill>
+                  <a:srgbClr val="CBD5E1"/>
+                </a:solidFill>
+              </a:defRPr>
+            </a:pPr>
+            <a:r>
+              <a:t>• 4-Box Market Grid: Groups apps into 4 simple buckets (Big apps, Fast growers, Niche tools, Basic utilities). Clicking any box filters the apps.</a:t>
             </a:r>
           </a:p>
           <a:p>
             <a:pPr>
               <a:spcBef>
-                <a:spcPts val="500"/>
+                <a:spcPts val="600"/>
               </a:spcBef>
-              <a:defRPr sz="1050">
-                <a:solidFill>
-                  <a:srgbClr val="94A3B8"/>
-                </a:solidFill>
-              </a:defRPr>
-            </a:pPr>
-            <a:r>
-              <a:t>• Interactive Filtering: Clicking any quadrant dynamically filters listings in real time to match buyer investment criteria.</a:t>
+              <a:defRPr sz="1100">
+                <a:solidFill>
+                  <a:srgbClr val="CBD5E1"/>
+                </a:solidFill>
+              </a:defRPr>
+            </a:pPr>
+            <a:r>
+              <a:t>• Supply &amp; Demand Graph: Shows which software categories have the most buyers waiting.</a:t>
             </a:r>
           </a:p>
         </p:txBody>
@@ -4941,11 +4870,11 @@
             <a:avLst/>
           </a:prstGeom>
           <a:solidFill>
-            <a:srgbClr val="121826"/>
+            <a:srgbClr val="1E293B"/>
           </a:solidFill>
           <a:ln w="15240">
             <a:solidFill>
-              <a:srgbClr val="26324A"/>
+              <a:srgbClr val="334155"/>
             </a:solidFill>
           </a:ln>
         </p:spPr>
@@ -4996,57 +4925,42 @@
             <a:pPr>
               <a:defRPr sz="1400" b="1">
                 <a:solidFill>
-                  <a:srgbClr val="34D399"/>
-                </a:solidFill>
-              </a:defRPr>
-            </a:pPr>
-            <a:r>
-              <a:t>[LIQUIDITY DEPTH]  Market Dynamics Visuals</a:t>
+                  <a:srgbClr val="4ADE80"/>
+                </a:solidFill>
+              </a:defRPr>
+            </a:pPr>
+            <a:r>
+              <a:t>[BUY &amp; SELL]  Valuation &amp; Marketplace</a:t>
             </a:r>
           </a:p>
           <a:p>
             <a:pPr>
               <a:spcBef>
-                <a:spcPts val="500"/>
+                <a:spcPts val="600"/>
               </a:spcBef>
-              <a:defRPr sz="1050">
-                <a:solidFill>
-                  <a:srgbClr val="94A3B8"/>
-                </a:solidFill>
-              </a:defRPr>
-            </a:pPr>
-            <a:r>
-              <a:t>• Demand vs. Supply Vector Curves: Visualizes live buyer liquidity spreads with dynamic sector toggles (AI, FinTech, HealthTech).</a:t>
+              <a:defRPr sz="1100">
+                <a:solidFill>
+                  <a:srgbClr val="CBD5E1"/>
+                </a:solidFill>
+              </a:defRPr>
+            </a:pPr>
+            <a:r>
+              <a:t>• Price Calculator: A tool for sellers. You type in your revenue, and it instantly tells you what your app is worth and your chances of selling.</a:t>
             </a:r>
           </a:p>
           <a:p>
             <a:pPr>
               <a:spcBef>
-                <a:spcPts val="500"/>
+                <a:spcPts val="600"/>
               </a:spcBef>
-              <a:defRPr sz="1050">
-                <a:solidFill>
-                  <a:srgbClr val="94A3B8"/>
-                </a:solidFill>
-              </a:defRPr>
-            </a:pPr>
-            <a:r>
-              <a:t>• 6-Axis Sector Radar Chart: Evaluates business health across Growth, Margins, IP Defensibility, Churn, Code Safety, and Team Continuity.</a:t>
-            </a:r>
-          </a:p>
-          <a:p>
-            <a:pPr>
-              <a:spcBef>
-                <a:spcPts val="500"/>
-              </a:spcBef>
-              <a:defRPr sz="1050">
-                <a:solidFill>
-                  <a:srgbClr val="94A3B8"/>
-                </a:solidFill>
-              </a:defRPr>
-            </a:pPr>
-            <a:r>
-              <a:t>• Live Ticker Feed: Real-time ticker showing signed NDAs and milestone releases.</a:t>
+              <a:defRPr sz="1100">
+                <a:solidFill>
+                  <a:srgbClr val="CBD5E1"/>
+                </a:solidFill>
+              </a:defRPr>
+            </a:pPr>
+            <a:r>
+              <a:t>• Browse Marketplace: Search and filter apps by category (AI, Finance, Health) with real monthly earnings, profit, and programming languages shown clearly.</a:t>
             </a:r>
           </a:p>
         </p:txBody>
@@ -5066,11 +4980,11 @@
             <a:avLst/>
           </a:prstGeom>
           <a:solidFill>
-            <a:srgbClr val="121826"/>
+            <a:srgbClr val="1E293B"/>
           </a:solidFill>
           <a:ln w="15240">
             <a:solidFill>
-              <a:srgbClr val="26324A"/>
+              <a:srgbClr val="334155"/>
             </a:solidFill>
           </a:ln>
         </p:spPr>
@@ -5121,72 +5035,57 @@
             <a:pPr>
               <a:defRPr sz="1400" b="1">
                 <a:solidFill>
-                  <a:srgbClr val="F59E0B"/>
-                </a:solidFill>
-              </a:defRPr>
-            </a:pPr>
-            <a:r>
-              <a:t>[VALUATION ENGINE]  Seller Recommender Engine</a:t>
+                  <a:srgbClr val="FBBF24"/>
+                </a:solidFill>
+              </a:defRPr>
+            </a:pPr>
+            <a:r>
+              <a:t>[DEAL ROOM]  Private Room &amp; Calculator</a:t>
             </a:r>
           </a:p>
           <a:p>
             <a:pPr>
               <a:spcBef>
-                <a:spcPts val="500"/>
+                <a:spcPts val="600"/>
               </a:spcBef>
-              <a:defRPr sz="1050">
-                <a:solidFill>
-                  <a:srgbClr val="94A3B8"/>
-                </a:solidFill>
-              </a:defRPr>
-            </a:pPr>
-            <a:r>
-              <a:t>• 'What Should You List?' algorithmic calculator.</a:t>
+              <a:defRPr sz="1100">
+                <a:solidFill>
+                  <a:srgbClr val="CBD5E1"/>
+                </a:solidFill>
+              </a:defRPr>
+            </a:pPr>
+            <a:r>
+              <a:t>• Private Diligence Room: A locked room where buyers can view private tax files and code stats after signing an agreement.</a:t>
             </a:r>
           </a:p>
           <a:p>
             <a:pPr>
               <a:spcBef>
-                <a:spcPts val="500"/>
+                <a:spcPts val="600"/>
               </a:spcBef>
-              <a:defRPr sz="1050">
-                <a:solidFill>
-                  <a:srgbClr val="94A3B8"/>
-                </a:solidFill>
-              </a:defRPr>
-            </a:pPr>
-            <a:r>
-              <a:t>• Founders input ARR, moat strength, and user churn.</a:t>
+              <a:defRPr sz="1100">
+                <a:solidFill>
+                  <a:srgbClr val="CBD5E1"/>
+                </a:solidFill>
+              </a:defRPr>
+            </a:pPr>
+            <a:r>
+              <a:t>• Code Walkthrough Video: A video screen where the creator explains how the code works.</a:t>
             </a:r>
           </a:p>
           <a:p>
             <a:pPr>
               <a:spcBef>
-                <a:spcPts val="500"/>
+                <a:spcPts val="600"/>
               </a:spcBef>
-              <a:defRPr sz="1050">
-                <a:solidFill>
-                  <a:srgbClr val="94A3B8"/>
-                </a:solidFill>
-              </a:defRPr>
-            </a:pPr>
-            <a:r>
-              <a:t>• Instant Output: Computes estimated valuation multiple, expected price, clearance probability, and audit readiness score.</a:t>
-            </a:r>
-          </a:p>
-          <a:p>
-            <a:pPr>
-              <a:spcBef>
-                <a:spcPts val="500"/>
-              </a:spcBef>
-              <a:defRPr sz="1050">
-                <a:solidFill>
-                  <a:srgbClr val="94A3B8"/>
-                </a:solidFill>
-              </a:defRPr>
-            </a:pPr>
-            <a:r>
-              <a:t>• Drives qualified seller onboarding without sales friction.</a:t>
+              <a:defRPr sz="1100">
+                <a:solidFill>
+                  <a:srgbClr val="CBD5E1"/>
+                </a:solidFill>
+              </a:defRPr>
+            </a:pPr>
+            <a:r>
+              <a:t>• Fee Calculator: A slider showing exactly how many thousands of dollars you save compared to traditional brokers.</a:t>
             </a:r>
           </a:p>
         </p:txBody>
@@ -5224,7 +5123,7 @@
             <a:avLst/>
           </a:prstGeom>
           <a:solidFill>
-            <a:srgbClr val="0B0F19"/>
+            <a:srgbClr val="0F172A"/>
           </a:solidFill>
           <a:ln>
             <a:noFill/>
@@ -5260,18 +5159,18 @@
         </p:nvSpPr>
         <p:spPr>
           <a:xfrm>
-            <a:off x="731520" y="411480"/>
-            <a:ext cx="2560320" cy="320040"/>
+            <a:off x="731520" y="457200"/>
+            <a:ext cx="2011680" cy="320040"/>
           </a:xfrm>
           <a:prstGeom prst="roundRect">
             <a:avLst/>
           </a:prstGeom>
           <a:solidFill>
-            <a:srgbClr val="1A2436"/>
+            <a:srgbClr val="1E293B"/>
           </a:solidFill>
           <a:ln w="12700">
             <a:solidFill>
-              <a:srgbClr val="26324A"/>
+              <a:srgbClr val="334155"/>
             </a:solidFill>
           </a:ln>
         </p:spPr>
@@ -5301,7 +5200,7 @@
               </a:defRPr>
             </a:pPr>
             <a:r>
-              <a:t>2. PLATFORM CAPABILITIES</a:t>
+              <a:t>3. TECHNOLOGY</a:t>
             </a:r>
           </a:p>
         </p:txBody>
@@ -5314,7 +5213,7 @@
         </p:nvSpPr>
         <p:spPr>
           <a:xfrm>
-            <a:off x="731520" y="777240"/>
+            <a:off x="731520" y="822960"/>
             <a:ext cx="10698480" cy="731520"/>
           </a:xfrm>
           <a:prstGeom prst="rect">
@@ -5331,24 +5230,24 @@
             <a:pPr>
               <a:defRPr sz="2200" b="1">
                 <a:solidFill>
-                  <a:srgbClr val="F8FAFC"/>
-                </a:solidFill>
-              </a:defRPr>
-            </a:pPr>
-            <a:r>
-              <a:t>Major Functionality: Diligence, VDR &amp; Escrow</a:t>
+                  <a:srgbClr val="FFFFFF"/>
+                </a:solidFill>
+              </a:defRPr>
+            </a:pPr>
+            <a:r>
+              <a:t>The Tech Stack &amp; How AI Agents Can Be Added</a:t>
             </a:r>
           </a:p>
           <a:p>
             <a:pPr>
               <a:defRPr sz="1100">
                 <a:solidFill>
-                  <a:srgbClr val="94A3B8"/>
-                </a:solidFill>
-              </a:defRPr>
-            </a:pPr>
-            <a:r>
-              <a:t>Operational workflows handling confidential data and transaction execution.</a:t>
+                  <a:srgbClr val="CBD5E1"/>
+                </a:solidFill>
+              </a:defRPr>
+            </a:pPr>
+            <a:r>
+              <a:t>Simple code that makes the site fast and easy for AI to work with.</a:t>
             </a:r>
           </a:p>
         </p:txBody>
@@ -5362,17 +5261,17 @@
         <p:spPr>
           <a:xfrm>
             <a:off x="731520" y="1737360"/>
-            <a:ext cx="3291840" cy="4572000"/>
+            <a:ext cx="5212080" cy="4572000"/>
           </a:xfrm>
           <a:prstGeom prst="roundRect">
             <a:avLst/>
           </a:prstGeom>
           <a:solidFill>
-            <a:srgbClr val="121826"/>
+            <a:srgbClr val="1E293B"/>
           </a:solidFill>
           <a:ln w="15240">
             <a:solidFill>
-              <a:srgbClr val="26324A"/>
+              <a:srgbClr val="334155"/>
             </a:solidFill>
           </a:ln>
         </p:spPr>
@@ -5407,7 +5306,7 @@
         <p:spPr>
           <a:xfrm>
             <a:off x="960120" y="1920240"/>
-            <a:ext cx="2834640" cy="4206240"/>
+            <a:ext cx="4754880" cy="4206240"/>
           </a:xfrm>
           <a:prstGeom prst="rect">
             <a:avLst/>
@@ -5428,52 +5327,52 @@
               </a:defRPr>
             </a:pPr>
             <a:r>
-              <a:t>[DOSSIER EXPLORER]  Marketplace &amp; Dossiers</a:t>
+              <a:t>[SIMPLE TECH STACK]  The Tech Stack Used</a:t>
             </a:r>
           </a:p>
           <a:p>
             <a:pPr>
               <a:spcBef>
-                <a:spcPts val="500"/>
+                <a:spcPts val="600"/>
               </a:spcBef>
-              <a:defRPr sz="1050">
-                <a:solidFill>
-                  <a:srgbClr val="94A3B8"/>
-                </a:solidFill>
-              </a:defRPr>
-            </a:pPr>
-            <a:r>
-              <a:t>• Filterable directory across 14 verified tech sectors.</a:t>
+              <a:defRPr sz="1100">
+                <a:solidFill>
+                  <a:srgbClr val="CBD5E1"/>
+                </a:solidFill>
+              </a:defRPr>
+            </a:pPr>
+            <a:r>
+              <a:t>• Pure HTML5 &amp; CSS3: Clean layout and styling using modern CSS variables. No heavy frameworks like Tailwind or Bootstrap.</a:t>
             </a:r>
           </a:p>
           <a:p>
             <a:pPr>
               <a:spcBef>
-                <a:spcPts val="500"/>
+                <a:spcPts val="600"/>
               </a:spcBef>
-              <a:defRPr sz="1050">
-                <a:solidFill>
-                  <a:srgbClr val="94A3B8"/>
-                </a:solidFill>
-              </a:defRPr>
-            </a:pPr>
-            <a:r>
-              <a:t>• Deep Institutional Dossiers: Verified ARR, EBITDA margins, IP defensibility score, and full tech stack tags.</a:t>
+              <a:defRPr sz="1100">
+                <a:solidFill>
+                  <a:srgbClr val="CBD5E1"/>
+                </a:solidFill>
+              </a:defRPr>
+            </a:pPr>
+            <a:r>
+              <a:t>• Vanilla JavaScript: Pure code for page navigation, search, and charts. Zero npm packages, zero React, and zero build steps.</a:t>
             </a:r>
           </a:p>
           <a:p>
             <a:pPr>
               <a:spcBef>
-                <a:spcPts val="500"/>
+                <a:spcPts val="600"/>
               </a:spcBef>
-              <a:defRPr sz="1050">
-                <a:solidFill>
-                  <a:srgbClr val="94A3B8"/>
-                </a:solidFill>
-              </a:defRPr>
-            </a:pPr>
-            <a:r>
-              <a:t>• Buyer/Seller Mode Switch: One-click perspective flip adapting metrics, yields, and actions.</a:t>
+              <a:defRPr sz="1100">
+                <a:solidFill>
+                  <a:srgbClr val="CBD5E1"/>
+                </a:solidFill>
+              </a:defRPr>
+            </a:pPr>
+            <a:r>
+              <a:t>• GitHub Pages Hosting: Free global hosting directly from GitHub. Fast loading in under 120ms with zero server crashes.</a:t>
             </a:r>
           </a:p>
         </p:txBody>
@@ -5486,18 +5385,18 @@
         </p:nvSpPr>
         <p:spPr>
           <a:xfrm>
-            <a:off x="4443984" y="1737360"/>
-            <a:ext cx="3291840" cy="4572000"/>
+            <a:off x="6217920" y="1737360"/>
+            <a:ext cx="5212080" cy="4572000"/>
           </a:xfrm>
           <a:prstGeom prst="roundRect">
             <a:avLst/>
           </a:prstGeom>
           <a:solidFill>
-            <a:srgbClr val="121826"/>
+            <a:srgbClr val="1E293B"/>
           </a:solidFill>
           <a:ln w="15240">
             <a:solidFill>
-              <a:srgbClr val="26324A"/>
+              <a:srgbClr val="334155"/>
             </a:solidFill>
           </a:ln>
         </p:spPr>
@@ -5531,8 +5430,8 @@
         </p:nvSpPr>
         <p:spPr>
           <a:xfrm>
-            <a:off x="4672584" y="1920240"/>
-            <a:ext cx="2834640" cy="4206240"/>
+            <a:off x="6446520" y="1920240"/>
+            <a:ext cx="4754880" cy="4206240"/>
           </a:xfrm>
           <a:prstGeom prst="rect">
             <a:avLst/>
@@ -5548,152 +5447,117 @@
             <a:pPr>
               <a:defRPr sz="1400" b="1">
                 <a:solidFill>
-                  <a:srgbClr val="F59E0B"/>
-                </a:solidFill>
-              </a:defRPr>
-            </a:pPr>
-            <a:r>
-              <a:t>[DILIGENCE ROOM]  VDR &amp; Video Diligence</a:t>
+                  <a:srgbClr val="4ADE80"/>
+                </a:solidFill>
+              </a:defRPr>
+            </a:pPr>
+            <a:r>
+              <a:t>[ADDING AI AGENTS]  How It Helps Us Add AI Agents</a:t>
             </a:r>
           </a:p>
           <a:p>
             <a:pPr>
               <a:spcBef>
-                <a:spcPts val="500"/>
+                <a:spcPts val="600"/>
               </a:spcBef>
-              <a:defRPr sz="1050">
-                <a:solidFill>
-                  <a:srgbClr val="94A3B8"/>
-                </a:solidFill>
-              </a:defRPr>
-            </a:pPr>
-            <a:r>
-              <a:t>• Virtual Data Room (VDR): Simulated NDA execution workflow unmasking sensitive tax filings, git telemetry, and customer concentration.</a:t>
+              <a:defRPr sz="1100">
+                <a:solidFill>
+                  <a:srgbClr val="CBD5E1"/>
+                </a:solidFill>
+              </a:defRPr>
+            </a:pPr>
+            <a:r>
+              <a:t>• Single Data File (data.js): All listings and numbers live in one clean file. AI agents can easily read and add new listings without breaking UI code.</a:t>
             </a:r>
           </a:p>
           <a:p>
             <a:pPr>
               <a:spcBef>
-                <a:spcPts val="500"/>
+                <a:spcPts val="600"/>
               </a:spcBef>
-              <a:defRPr sz="1050">
-                <a:solidFill>
-                  <a:srgbClr val="94A3B8"/>
-                </a:solidFill>
-              </a:defRPr>
-            </a:pPr>
-            <a:r>
-              <a:t>• WebRTC Video Review Terminal: Video walkthrough console with timestamped chapter markers and verified third-party auditor notes.</a:t>
-            </a:r>
-          </a:p>
-        </p:txBody>
-      </p:sp>
-      <p:sp>
-        <p:nvSpPr>
-          <p:cNvPr id="9" name="Rounded Rectangle 8"/>
-          <p:cNvSpPr/>
-          <p:nvPr/>
-        </p:nvSpPr>
-        <p:spPr>
-          <a:xfrm>
-            <a:off x="8165592" y="1737360"/>
-            <a:ext cx="3291840" cy="4572000"/>
-          </a:xfrm>
-          <a:prstGeom prst="roundRect">
-            <a:avLst/>
-          </a:prstGeom>
-          <a:solidFill>
-            <a:srgbClr val="121826"/>
-          </a:solidFill>
-          <a:ln w="15240">
-            <a:solidFill>
-              <a:srgbClr val="26324A"/>
-            </a:solidFill>
-          </a:ln>
-        </p:spPr>
-        <p:style>
-          <a:lnRef idx="1">
-            <a:schemeClr val="accent1"/>
-          </a:lnRef>
-          <a:fillRef idx="3">
-            <a:schemeClr val="accent1"/>
-          </a:fillRef>
-          <a:effectRef idx="2">
-            <a:schemeClr val="accent1"/>
-          </a:effectRef>
-          <a:fontRef idx="minor">
-            <a:schemeClr val="lt1"/>
-          </a:fontRef>
-        </p:style>
-        <p:txBody>
-          <a:bodyPr rtlCol="0" anchor="ctr"/>
-          <a:lstStyle/>
-          <a:p>
-            <a:pPr algn="ctr"/>
-          </a:p>
-        </p:txBody>
-      </p:sp>
-      <p:sp>
-        <p:nvSpPr>
-          <p:cNvPr id="10" name="TextBox 9"/>
-          <p:cNvSpPr txBox="1"/>
-          <p:nvPr/>
-        </p:nvSpPr>
-        <p:spPr>
-          <a:xfrm>
-            <a:off x="8394192" y="1920240"/>
-            <a:ext cx="2834640" cy="4206240"/>
-          </a:xfrm>
-          <a:prstGeom prst="rect">
-            <a:avLst/>
-          </a:prstGeom>
-          <a:noFill/>
-        </p:spPr>
-        <p:txBody>
-          <a:bodyPr wrap="square">
-            <a:spAutoFit/>
-          </a:bodyPr>
-          <a:lstStyle/>
-          <a:p>
-            <a:pPr>
-              <a:defRPr sz="1400" b="1">
-                <a:solidFill>
-                  <a:srgbClr val="34D399"/>
-                </a:solidFill>
-              </a:defRPr>
-            </a:pPr>
-            <a:r>
-              <a:t>[TRANSPARENCY]  Fee Calculator &amp; FAQ</a:t>
+              <a:defRPr sz="1100">
+                <a:solidFill>
+                  <a:srgbClr val="CBD5E1"/>
+                </a:solidFill>
+              </a:defRPr>
+            </a:pPr>
+            <a:r>
+              <a:t>• No Hidden React Code: Because the HTML is clean and direct, AI browser tools can easily click buttons, search listings, and read text.</a:t>
             </a:r>
           </a:p>
           <a:p>
             <a:pPr>
               <a:spcBef>
-                <a:spcPts val="500"/>
+                <a:spcPts val="600"/>
               </a:spcBef>
-              <a:defRPr sz="1050">
-                <a:solidFill>
-                  <a:srgbClr val="94A3B8"/>
-                </a:solidFill>
-              </a:defRPr>
-            </a:pPr>
-            <a:r>
-              <a:t>• Interactive Sliding Fee Calculator: Drag-and-drop deal sizing (3%–7%) showing exact dollar savings vs 10%–15% traditional brokers.</a:t>
+              <a:defRPr sz="1100">
+                <a:solidFill>
+                  <a:srgbClr val="CBD5E1"/>
+                </a:solidFill>
+              </a:defRPr>
+            </a:pPr>
+            <a:r>
+              <a:t>• AI Agents We Can Add Easily:</a:t>
             </a:r>
           </a:p>
           <a:p>
             <a:pPr>
               <a:spcBef>
-                <a:spcPts val="500"/>
+                <a:spcPts val="600"/>
               </a:spcBef>
-              <a:defRPr sz="1050">
-                <a:solidFill>
-                  <a:srgbClr val="94A3B8"/>
-                </a:solidFill>
-              </a:defRPr>
-            </a:pPr>
-            <a:r>
-              <a:t>• Institutional Trust &amp; FAQ: Comprehensive legal safeguards covering escrow safety, non-competes, IP assignment, and code warranties.</a:t>
+              <a:defRPr sz="1100">
+                <a:solidFill>
+                  <a:srgbClr val="CBD5E1"/>
+                </a:solidFill>
+              </a:defRPr>
+            </a:pPr>
+            <a:r>
+              <a:t>•   1. Code Audit AI: Automatically scans GitHub repos and gives a code safety score.</a:t>
+            </a:r>
+          </a:p>
+          <a:p>
+            <a:pPr>
+              <a:spcBef>
+                <a:spcPts val="600"/>
+              </a:spcBef>
+              <a:defRPr sz="1100">
+                <a:solidFill>
+                  <a:srgbClr val="CBD5E1"/>
+                </a:solidFill>
+              </a:defRPr>
+            </a:pPr>
+            <a:r>
+              <a:t>•   2. Price AI: Checks recent sales and updates valuations automatically.</a:t>
+            </a:r>
+          </a:p>
+          <a:p>
+            <a:pPr>
+              <a:spcBef>
+                <a:spcPts val="600"/>
+              </a:spcBef>
+              <a:defRPr sz="1100">
+                <a:solidFill>
+                  <a:srgbClr val="CBD5E1"/>
+                </a:solidFill>
+              </a:defRPr>
+            </a:pPr>
+            <a:r>
+              <a:t>•   3. Q&amp;A AI Chatbot: Sits inside the private deal room to answer buyers' questions about the software.</a:t>
+            </a:r>
+          </a:p>
+          <a:p>
+            <a:pPr>
+              <a:spcBef>
+                <a:spcPts val="600"/>
+              </a:spcBef>
+              <a:defRPr sz="1100">
+                <a:solidFill>
+                  <a:srgbClr val="CBD5E1"/>
+                </a:solidFill>
+              </a:defRPr>
+            </a:pPr>
+            <a:r>
+              <a:t>•   4. Handover AI: Checks that domains and passwords are moved correctly before money is sent.</a:t>
             </a:r>
           </a:p>
         </p:txBody>
@@ -5731,7 +5595,7 @@
             <a:avLst/>
           </a:prstGeom>
           <a:solidFill>
-            <a:srgbClr val="0B0F19"/>
+            <a:srgbClr val="0F172A"/>
           </a:solidFill>
           <a:ln>
             <a:noFill/>
@@ -5767,18 +5631,18 @@
         </p:nvSpPr>
         <p:spPr>
           <a:xfrm>
-            <a:off x="731520" y="411480"/>
-            <a:ext cx="2560320" cy="320040"/>
+            <a:off x="731520" y="457200"/>
+            <a:ext cx="2011680" cy="320040"/>
           </a:xfrm>
           <a:prstGeom prst="roundRect">
             <a:avLst/>
           </a:prstGeom>
           <a:solidFill>
-            <a:srgbClr val="1A2436"/>
+            <a:srgbClr val="1E293B"/>
           </a:solidFill>
           <a:ln w="12700">
             <a:solidFill>
-              <a:srgbClr val="26324A"/>
+              <a:srgbClr val="334155"/>
             </a:solidFill>
           </a:ln>
         </p:spPr>
@@ -5808,7 +5672,7 @@
               </a:defRPr>
             </a:pPr>
             <a:r>
-              <a:t>3. TECH ARCHITECTURE</a:t>
+              <a:t>4. INNOVATION</a:t>
             </a:r>
           </a:p>
         </p:txBody>
@@ -5821,7 +5685,7 @@
         </p:nvSpPr>
         <p:spPr>
           <a:xfrm>
-            <a:off x="731520" y="777240"/>
+            <a:off x="731520" y="822960"/>
             <a:ext cx="10698480" cy="731520"/>
           </a:xfrm>
           <a:prstGeom prst="rect">
@@ -5838,24 +5702,24 @@
             <a:pPr>
               <a:defRPr sz="2200" b="1">
                 <a:solidFill>
-                  <a:srgbClr val="F8FAFC"/>
-                </a:solidFill>
-              </a:defRPr>
-            </a:pPr>
-            <a:r>
-              <a:t>Tech Stack &amp; Extensibility for AI Agents</a:t>
+                  <a:srgbClr val="FFFFFF"/>
+                </a:solidFill>
+              </a:defRPr>
+            </a:pPr>
+            <a:r>
+              <a:t>Innovation Added (Compared to Original Website)</a:t>
             </a:r>
           </a:p>
           <a:p>
             <a:pPr>
               <a:defRPr sz="1100">
                 <a:solidFill>
-                  <a:srgbClr val="94A3B8"/>
-                </a:solidFill>
-              </a:defRPr>
-            </a:pPr>
-            <a:r>
-              <a:t>Why our zero-dependency stack provides the ideal foundation for autonomous AI agents.</a:t>
+                  <a:srgbClr val="CBD5E1"/>
+                </a:solidFill>
+              </a:defRPr>
+            </a:pPr>
+            <a:r>
+              <a:t>How our site is safer and more functional than the reference site.</a:t>
             </a:r>
           </a:p>
         </p:txBody>
@@ -5875,11 +5739,11 @@
             <a:avLst/>
           </a:prstGeom>
           <a:solidFill>
-            <a:srgbClr val="121826"/>
+            <a:srgbClr val="1E293B"/>
           </a:solidFill>
           <a:ln w="15240">
             <a:solidFill>
-              <a:srgbClr val="26324A"/>
+              <a:srgbClr val="334155"/>
             </a:solidFill>
           </a:ln>
         </p:spPr>
@@ -5930,72 +5794,57 @@
             <a:pPr>
               <a:defRPr sz="1400" b="1">
                 <a:solidFill>
-                  <a:srgbClr val="38BDF8"/>
-                </a:solidFill>
-              </a:defRPr>
-            </a:pPr>
-            <a:r>
-              <a:t>[CURRENT TECH STACK]  The Zero-Dependency Stack</a:t>
+                  <a:srgbClr val="FBBF24"/>
+                </a:solidFill>
+              </a:defRPr>
+            </a:pPr>
+            <a:r>
+              <a:t>[ORIGINAL SITE]  The Original Website (vventrabyaj)</a:t>
             </a:r>
           </a:p>
           <a:p>
             <a:pPr>
               <a:spcBef>
-                <a:spcPts val="500"/>
+                <a:spcPts val="600"/>
               </a:spcBef>
-              <a:defRPr sz="1050">
-                <a:solidFill>
-                  <a:srgbClr val="94A3B8"/>
-                </a:solidFill>
-              </a:defRPr>
-            </a:pPr>
-            <a:r>
-              <a:t>• Semantic HTML5: Clean, W3C-compliant document structure with accessible ARIA landmarks.</a:t>
+              <a:defRPr sz="1100">
+                <a:solidFill>
+                  <a:srgbClr val="CBD5E1"/>
+                </a:solidFill>
+              </a:defRPr>
+            </a:pPr>
+            <a:r>
+              <a:t>• Flashy Graphics Over Substance: Used heavy neon purple colors and glows that looked like a video game or crypto token.</a:t>
             </a:r>
           </a:p>
           <a:p>
             <a:pPr>
               <a:spcBef>
-                <a:spcPts val="500"/>
+                <a:spcPts val="600"/>
               </a:spcBef>
-              <a:defRPr sz="1050">
-                <a:solidFill>
-                  <a:srgbClr val="94A3B8"/>
-                </a:solidFill>
-              </a:defRPr>
-            </a:pPr>
-            <a:r>
-              <a:t>• CSS3 with BEM Architecture: Custom property variables handle instant Buyer/Seller perspective shifts without framework bloat.</a:t>
+              <a:defRPr sz="1100">
+                <a:solidFill>
+                  <a:srgbClr val="CBD5E1"/>
+                </a:solidFill>
+              </a:defRPr>
+            </a:pPr>
+            <a:r>
+              <a:t>• Buttons Did Not Work: Many cards and charts were just pictures that you could not click or interact with.</a:t>
             </a:r>
           </a:p>
           <a:p>
             <a:pPr>
               <a:spcBef>
-                <a:spcPts val="500"/>
+                <a:spcPts val="600"/>
               </a:spcBef>
-              <a:defRPr sz="1050">
-                <a:solidFill>
-                  <a:srgbClr val="94A3B8"/>
-                </a:solidFill>
-              </a:defRPr>
-            </a:pPr>
-            <a:r>
-              <a:t>• Vanilla JavaScript (ES6+): Pure JavaScript routing, state management, and mathematical SVG rendering. Zero npm dependencies, zero build steps.</a:t>
-            </a:r>
-          </a:p>
-          <a:p>
-            <a:pPr>
-              <a:spcBef>
-                <a:spcPts val="500"/>
-              </a:spcBef>
-              <a:defRPr sz="1050">
-                <a:solidFill>
-                  <a:srgbClr val="94A3B8"/>
-                </a:solidFill>
-              </a:defRPr>
-            </a:pPr>
-            <a:r>
-              <a:t>• GitHub Pages Deployment: Served globally on GitHub's edge CDN with sub-120ms load times and automated CI/CD on git push.</a:t>
+              <a:defRPr sz="1100">
+                <a:solidFill>
+                  <a:srgbClr val="CBD5E1"/>
+                </a:solidFill>
+              </a:defRPr>
+            </a:pPr>
+            <a:r>
+              <a:t>• No Safe Transfer Method: Only had a basic 'Buy' button, with no answer to how code or money is actually protected.</a:t>
             </a:r>
           </a:p>
         </p:txBody>
@@ -6015,11 +5864,11 @@
             <a:avLst/>
           </a:prstGeom>
           <a:solidFill>
-            <a:srgbClr val="121826"/>
+            <a:srgbClr val="1E293B"/>
           </a:solidFill>
           <a:ln w="15240">
             <a:solidFill>
-              <a:srgbClr val="26324A"/>
+              <a:srgbClr val="334155"/>
             </a:solidFill>
           </a:ln>
         </p:spPr>
@@ -6070,87 +5919,117 @@
             <a:pPr>
               <a:defRPr sz="1400" b="1">
                 <a:solidFill>
-                  <a:srgbClr val="34D399"/>
-                </a:solidFill>
-              </a:defRPr>
-            </a:pPr>
-            <a:r>
-              <a:t>[AI AGENT EXTENSIBILITY]  How AI Agents Can Be Added</a:t>
+                  <a:srgbClr val="4ADE80"/>
+                </a:solidFill>
+              </a:defRPr>
+            </a:pPr>
+            <a:r>
+              <a:t>[OUR INNOVATION]  Our Innovation: Safe 4-Step Handover</a:t>
             </a:r>
           </a:p>
           <a:p>
             <a:pPr>
               <a:spcBef>
-                <a:spcPts val="500"/>
+                <a:spcPts val="600"/>
               </a:spcBef>
-              <a:defRPr sz="1050">
-                <a:solidFill>
-                  <a:srgbClr val="94A3B8"/>
-                </a:solidFill>
-              </a:defRPr>
-            </a:pPr>
-            <a:r>
-              <a:t>• Isolated Data Layer (data.js): Clean structured objects allow autonomous agents to inject, audit, and update listings via JSON/APIs without touching UI code.</a:t>
+              <a:defRPr sz="1100">
+                <a:solidFill>
+                  <a:srgbClr val="CBD5E1"/>
+                </a:solidFill>
+              </a:defRPr>
+            </a:pPr>
+            <a:r>
+              <a:t>• The Safe Handover System: Solves the biggest fear in buying software using 4 clear steps:</a:t>
             </a:r>
           </a:p>
           <a:p>
             <a:pPr>
               <a:spcBef>
-                <a:spcPts val="500"/>
+                <a:spcPts val="600"/>
               </a:spcBef>
-              <a:defRPr sz="1050">
-                <a:solidFill>
-                  <a:srgbClr val="94A3B8"/>
-                </a:solidFill>
-              </a:defRPr>
-            </a:pPr>
-            <a:r>
-              <a:t>• Zero Virtual DOM Friction: Unlike React's obfuscated virtual DOM, headless browser agents (Puppeteer, Playwright) can inspect and interact with semantic DOM elements reliably.</a:t>
+              <a:defRPr sz="1100">
+                <a:solidFill>
+                  <a:srgbClr val="CBD5E1"/>
+                </a:solidFill>
+              </a:defRPr>
+            </a:pPr>
+            <a:r>
+              <a:t>•   1. Money Deposit: Buyer puts money in a safe lockbox (escrow).</a:t>
             </a:r>
           </a:p>
           <a:p>
             <a:pPr>
               <a:spcBef>
-                <a:spcPts val="500"/>
+                <a:spcPts val="600"/>
               </a:spcBef>
-              <a:defRPr sz="1050">
-                <a:solidFill>
-                  <a:srgbClr val="94A3B8"/>
-                </a:solidFill>
-              </a:defRPr>
-            </a:pPr>
-            <a:r>
-              <a:t>• Due-Diligence AI Agent: Can ingest GitHub repos, automatically run security audits, and generate code scores into dossiers.</a:t>
+              <a:defRPr sz="1100">
+                <a:solidFill>
+                  <a:srgbClr val="CBD5E1"/>
+                </a:solidFill>
+              </a:defRPr>
+            </a:pPr>
+            <a:r>
+              <a:t>•   2. Code Lock: Seller hands over code and cloud accounts into safe custody.</a:t>
             </a:r>
           </a:p>
           <a:p>
             <a:pPr>
               <a:spcBef>
-                <a:spcPts val="500"/>
+                <a:spcPts val="600"/>
               </a:spcBef>
-              <a:defRPr sz="1050">
-                <a:solidFill>
-                  <a:srgbClr val="94A3B8"/>
-                </a:solidFill>
-              </a:defRPr>
-            </a:pPr>
-            <a:r>
-              <a:t>• Valuation AI Agent: Real-time LLM agent monitoring tech M&amp;A comparables to update multiples and clearance probabilities dynamically.</a:t>
+              <a:defRPr sz="1100">
+                <a:solidFill>
+                  <a:srgbClr val="CBD5E1"/>
+                </a:solidFill>
+              </a:defRPr>
+            </a:pPr>
+            <a:r>
+              <a:t>•   3. Domain Move: The website domain is moved to the buyer.</a:t>
             </a:r>
           </a:p>
           <a:p>
             <a:pPr>
               <a:spcBef>
-                <a:spcPts val="500"/>
+                <a:spcPts val="600"/>
               </a:spcBef>
-              <a:defRPr sz="1050">
-                <a:solidFill>
-                  <a:srgbClr val="94A3B8"/>
-                </a:solidFill>
-              </a:defRPr>
-            </a:pPr>
-            <a:r>
-              <a:t>• Handover Verification Agent: Autonomous agent checking DNS propagation, SSL handoff, and AWS root credentials before releasing escrow funds.</a:t>
+              <a:defRPr sz="1100">
+                <a:solidFill>
+                  <a:srgbClr val="CBD5E1"/>
+                </a:solidFill>
+              </a:defRPr>
+            </a:pPr>
+            <a:r>
+              <a:t>•   4. Testing &amp; Release: Buyer tests the app; once confirmed, money goes to the seller.</a:t>
+            </a:r>
+          </a:p>
+          <a:p>
+            <a:pPr>
+              <a:spcBef>
+                <a:spcPts val="600"/>
+              </a:spcBef>
+              <a:defRPr sz="1100">
+                <a:solidFill>
+                  <a:srgbClr val="CBD5E1"/>
+                </a:solidFill>
+              </a:defRPr>
+            </a:pPr>
+            <a:r>
+              <a:t>• Interactive Simulator: Users can click through all 4 steps on the screen to see how it works.</a:t>
+            </a:r>
+          </a:p>
+          <a:p>
+            <a:pPr>
+              <a:spcBef>
+                <a:spcPts val="600"/>
+              </a:spcBef>
+              <a:defRPr sz="1100">
+                <a:solidFill>
+                  <a:srgbClr val="CBD5E1"/>
+                </a:solidFill>
+              </a:defRPr>
+            </a:pPr>
+            <a:r>
+              <a:t>• Clean, Professional Look: Simple typography and clean cards instead of confusing neon effects.</a:t>
             </a:r>
           </a:p>
         </p:txBody>
@@ -6188,7 +6067,7 @@
             <a:avLst/>
           </a:prstGeom>
           <a:solidFill>
-            <a:srgbClr val="0B0F19"/>
+            <a:srgbClr val="0F172A"/>
           </a:solidFill>
           <a:ln>
             <a:noFill/>
@@ -6224,18 +6103,18 @@
         </p:nvSpPr>
         <p:spPr>
           <a:xfrm>
-            <a:off x="731520" y="411480"/>
-            <a:ext cx="2560320" cy="320040"/>
+            <a:off x="731520" y="457200"/>
+            <a:ext cx="2011680" cy="320040"/>
           </a:xfrm>
           <a:prstGeom prst="roundRect">
             <a:avLst/>
           </a:prstGeom>
           <a:solidFill>
-            <a:srgbClr val="1A2436"/>
+            <a:srgbClr val="1E293B"/>
           </a:solidFill>
           <a:ln w="12700">
             <a:solidFill>
-              <a:srgbClr val="26324A"/>
+              <a:srgbClr val="334155"/>
             </a:solidFill>
           </a:ln>
         </p:spPr>
@@ -6265,7 +6144,7 @@
               </a:defRPr>
             </a:pPr>
             <a:r>
-              <a:t>4. COMPETITIVE MOAT</a:t>
+              <a:t>5. CONCLUSION</a:t>
             </a:r>
           </a:p>
         </p:txBody>
@@ -6278,7 +6157,7 @@
         </p:nvSpPr>
         <p:spPr>
           <a:xfrm>
-            <a:off x="731520" y="777240"/>
+            <a:off x="731520" y="822960"/>
             <a:ext cx="10698480" cy="731520"/>
           </a:xfrm>
           <a:prstGeom prst="rect">
@@ -6295,466 +6174,24 @@
             <a:pPr>
               <a:defRPr sz="2200" b="1">
                 <a:solidFill>
-                  <a:srgbClr val="F8FAFC"/>
-                </a:solidFill>
-              </a:defRPr>
-            </a:pPr>
-            <a:r>
-              <a:t>Core Innovation: Atomic Handover Protocol</a:t>
+                  <a:srgbClr val="FFFFFF"/>
+                </a:solidFill>
+              </a:defRPr>
+            </a:pPr>
+            <a:r>
+              <a:t>Conclusion &amp; Key Learnings</a:t>
             </a:r>
           </a:p>
           <a:p>
             <a:pPr>
               <a:defRPr sz="1100">
                 <a:solidFill>
-                  <a:srgbClr val="94A3B8"/>
-                </a:solidFill>
-              </a:defRPr>
-            </a:pPr>
-            <a:r>
-              <a:t>The key architectural and security leap compared to the original reference site.</a:t>
-            </a:r>
-          </a:p>
-        </p:txBody>
-      </p:sp>
-      <p:sp>
-        <p:nvSpPr>
-          <p:cNvPr id="5" name="Rounded Rectangle 4"/>
-          <p:cNvSpPr/>
-          <p:nvPr/>
-        </p:nvSpPr>
-        <p:spPr>
-          <a:xfrm>
-            <a:off x="731520" y="1737360"/>
-            <a:ext cx="5212080" cy="4572000"/>
-          </a:xfrm>
-          <a:prstGeom prst="roundRect">
-            <a:avLst/>
-          </a:prstGeom>
-          <a:solidFill>
-            <a:srgbClr val="121826"/>
-          </a:solidFill>
-          <a:ln w="15240">
-            <a:solidFill>
-              <a:srgbClr val="26324A"/>
-            </a:solidFill>
-          </a:ln>
-        </p:spPr>
-        <p:style>
-          <a:lnRef idx="1">
-            <a:schemeClr val="accent1"/>
-          </a:lnRef>
-          <a:fillRef idx="3">
-            <a:schemeClr val="accent1"/>
-          </a:fillRef>
-          <a:effectRef idx="2">
-            <a:schemeClr val="accent1"/>
-          </a:effectRef>
-          <a:fontRef idx="minor">
-            <a:schemeClr val="lt1"/>
-          </a:fontRef>
-        </p:style>
-        <p:txBody>
-          <a:bodyPr rtlCol="0" anchor="ctr"/>
-          <a:lstStyle/>
-          <a:p>
-            <a:pPr algn="ctr"/>
-          </a:p>
-        </p:txBody>
-      </p:sp>
-      <p:sp>
-        <p:nvSpPr>
-          <p:cNvPr id="6" name="TextBox 5"/>
-          <p:cNvSpPr txBox="1"/>
-          <p:nvPr/>
-        </p:nvSpPr>
-        <p:spPr>
-          <a:xfrm>
-            <a:off x="960120" y="1920240"/>
-            <a:ext cx="4754880" cy="4206240"/>
-          </a:xfrm>
-          <a:prstGeom prst="rect">
-            <a:avLst/>
-          </a:prstGeom>
-          <a:noFill/>
-        </p:spPr>
-        <p:txBody>
-          <a:bodyPr wrap="square">
-            <a:spAutoFit/>
-          </a:bodyPr>
-          <a:lstStyle/>
-          <a:p>
-            <a:pPr>
-              <a:defRPr sz="1400" b="1">
-                <a:solidFill>
-                  <a:srgbClr val="F59E0B"/>
-                </a:solidFill>
-              </a:defRPr>
-            </a:pPr>
-            <a:r>
-              <a:t>[REFERENCE SITE]  Original Reference Site (vventrabyaj)</a:t>
-            </a:r>
-          </a:p>
-          <a:p>
-            <a:pPr>
-              <a:spcBef>
-                <a:spcPts val="500"/>
-              </a:spcBef>
-              <a:defRPr sz="1050">
-                <a:solidFill>
-                  <a:srgbClr val="94A3B8"/>
-                </a:solidFill>
-              </a:defRPr>
-            </a:pPr>
-            <a:r>
-              <a:t>• Visuals Over Substance: Crypto-style neon glow and generic purple gradients that looked speculative rather than institutional.</a:t>
-            </a:r>
-          </a:p>
-          <a:p>
-            <a:pPr>
-              <a:spcBef>
-                <a:spcPts val="500"/>
-              </a:spcBef>
-              <a:defRPr sz="1050">
-                <a:solidFill>
-                  <a:srgbClr val="94A3B8"/>
-                </a:solidFill>
-              </a:defRPr>
-            </a:pPr>
-            <a:r>
-              <a:t>• Static / Non-Functional Mockups: Cards and graphs were cosmetic visuals with no interactive filtering or calculation logic.</a:t>
-            </a:r>
-          </a:p>
-          <a:p>
-            <a:pPr>
-              <a:spcBef>
-                <a:spcPts val="500"/>
-              </a:spcBef>
-              <a:defRPr sz="1050">
-                <a:solidFill>
-                  <a:srgbClr val="94A3B8"/>
-                </a:solidFill>
-              </a:defRPr>
-            </a:pPr>
-            <a:r>
-              <a:t>• Zero Custody Mechanism: Offered generic 'Buy Now' buttons without answering how software code or domains are safely handed over.</a:t>
-            </a:r>
-          </a:p>
-          <a:p>
-            <a:pPr>
-              <a:spcBef>
-                <a:spcPts val="500"/>
-              </a:spcBef>
-              <a:defRPr sz="1050">
-                <a:solidFill>
-                  <a:srgbClr val="94A3B8"/>
-                </a:solidFill>
-              </a:defRPr>
-            </a:pPr>
-            <a:r>
-              <a:t>• Heavy Bundles: Built on heavy frameworks with unnecessary script overhead.</a:t>
-            </a:r>
-          </a:p>
-        </p:txBody>
-      </p:sp>
-      <p:sp>
-        <p:nvSpPr>
-          <p:cNvPr id="7" name="Rounded Rectangle 6"/>
-          <p:cNvSpPr/>
-          <p:nvPr/>
-        </p:nvSpPr>
-        <p:spPr>
-          <a:xfrm>
-            <a:off x="6217920" y="1737360"/>
-            <a:ext cx="5212080" cy="4572000"/>
-          </a:xfrm>
-          <a:prstGeom prst="roundRect">
-            <a:avLst/>
-          </a:prstGeom>
-          <a:solidFill>
-            <a:srgbClr val="121826"/>
-          </a:solidFill>
-          <a:ln w="15240">
-            <a:solidFill>
-              <a:srgbClr val="26324A"/>
-            </a:solidFill>
-          </a:ln>
-        </p:spPr>
-        <p:style>
-          <a:lnRef idx="1">
-            <a:schemeClr val="accent1"/>
-          </a:lnRef>
-          <a:fillRef idx="3">
-            <a:schemeClr val="accent1"/>
-          </a:fillRef>
-          <a:effectRef idx="2">
-            <a:schemeClr val="accent1"/>
-          </a:effectRef>
-          <a:fontRef idx="minor">
-            <a:schemeClr val="lt1"/>
-          </a:fontRef>
-        </p:style>
-        <p:txBody>
-          <a:bodyPr rtlCol="0" anchor="ctr"/>
-          <a:lstStyle/>
-          <a:p>
-            <a:pPr algn="ctr"/>
-          </a:p>
-        </p:txBody>
-      </p:sp>
-      <p:sp>
-        <p:nvSpPr>
-          <p:cNvPr id="8" name="TextBox 7"/>
-          <p:cNvSpPr txBox="1"/>
-          <p:nvPr/>
-        </p:nvSpPr>
-        <p:spPr>
-          <a:xfrm>
-            <a:off x="6446520" y="1920240"/>
-            <a:ext cx="4754880" cy="4206240"/>
-          </a:xfrm>
-          <a:prstGeom prst="rect">
-            <a:avLst/>
-          </a:prstGeom>
-          <a:noFill/>
-        </p:spPr>
-        <p:txBody>
-          <a:bodyPr wrap="square">
-            <a:spAutoFit/>
-          </a:bodyPr>
-          <a:lstStyle/>
-          <a:p>
-            <a:pPr>
-              <a:defRPr sz="1400" b="1">
-                <a:solidFill>
-                  <a:srgbClr val="34D399"/>
-                </a:solidFill>
-              </a:defRPr>
-            </a:pPr>
-            <a:r>
-              <a:t>[OUR INNOVATION]  Our Innovation: Atomic Handover Protocol™</a:t>
-            </a:r>
-          </a:p>
-          <a:p>
-            <a:pPr>
-              <a:spcBef>
-                <a:spcPts val="500"/>
-              </a:spcBef>
-              <a:defRPr sz="1050">
-                <a:solidFill>
-                  <a:srgbClr val="94A3B8"/>
-                </a:solidFill>
-              </a:defRPr>
-            </a:pPr>
-            <a:r>
-              <a:t>• 4-Phase Custody Transfer: 1. Escrow Deposit -&gt; 2. Code &amp; Cloud Lock -&gt; 3. DNS Migration -&gt; 4. Dual Sign-off &amp; Release.</a:t>
-            </a:r>
-          </a:p>
-          <a:p>
-            <a:pPr>
-              <a:spcBef>
-                <a:spcPts val="500"/>
-              </a:spcBef>
-              <a:defRPr sz="1050">
-                <a:solidFill>
-                  <a:srgbClr val="94A3B8"/>
-                </a:solidFill>
-              </a:defRPr>
-            </a:pPr>
-            <a:r>
-              <a:t>• Interactive Handover Simulator: Live step-by-step simulator embedded in every dossier demonstrating cryptographic custody transfer.</a:t>
-            </a:r>
-          </a:p>
-          <a:p>
-            <a:pPr>
-              <a:spcBef>
-                <a:spcPts val="500"/>
-              </a:spcBef>
-              <a:defRPr sz="1050">
-                <a:solidFill>
-                  <a:srgbClr val="94A3B8"/>
-                </a:solidFill>
-              </a:defRPr>
-            </a:pPr>
-            <a:r>
-              <a:t>• Zero Fraud / Zero Ghosting: Neither party can cheat; code is verified before funds release, and money is locked before code transfers.</a:t>
-            </a:r>
-          </a:p>
-          <a:p>
-            <a:pPr>
-              <a:spcBef>
-                <a:spcPts val="500"/>
-              </a:spcBef>
-              <a:defRPr sz="1050">
-                <a:solidFill>
-                  <a:srgbClr val="94A3B8"/>
-                </a:solidFill>
-              </a:defRPr>
-            </a:pPr>
-            <a:r>
-              <a:t>• Institutional Terminal Aesthetics: Professional Geist and JetBrains Mono typography replacing neon gimmicks with Wall Street rigor.</a:t>
-            </a:r>
-          </a:p>
-        </p:txBody>
-      </p:sp>
-    </p:spTree>
-  </p:cSld>
-  <p:clrMapOvr>
-    <a:masterClrMapping/>
-  </p:clrMapOvr>
-</p:sld>
-</file>
-
-<file path=ppt/slides/slide7.xml><?xml version="1.0" encoding="utf-8"?>
-<p:sld xmlns:a="http://schemas.openxmlformats.org/drawingml/2006/main" xmlns:p="http://schemas.openxmlformats.org/presentationml/2006/main" xmlns:r="http://schemas.openxmlformats.org/officeDocument/2006/relationships">
-  <p:cSld>
-    <p:spTree>
-      <p:nvGrpSpPr>
-        <p:cNvPr id="1" name=""/>
-        <p:cNvGrpSpPr/>
-        <p:nvPr/>
-      </p:nvGrpSpPr>
-      <p:grpSpPr/>
-      <p:sp>
-        <p:nvSpPr>
-          <p:cNvPr id="2" name="Rectangle 1"/>
-          <p:cNvSpPr/>
-          <p:nvPr/>
-        </p:nvSpPr>
-        <p:spPr>
-          <a:xfrm>
-            <a:off x="0" y="0"/>
-            <a:ext cx="12191695" cy="6858000"/>
-          </a:xfrm>
-          <a:prstGeom prst="rect">
-            <a:avLst/>
-          </a:prstGeom>
-          <a:solidFill>
-            <a:srgbClr val="0B0F19"/>
-          </a:solidFill>
-          <a:ln>
-            <a:noFill/>
-          </a:ln>
-        </p:spPr>
-        <p:style>
-          <a:lnRef idx="1">
-            <a:schemeClr val="accent1"/>
-          </a:lnRef>
-          <a:fillRef idx="3">
-            <a:schemeClr val="accent1"/>
-          </a:fillRef>
-          <a:effectRef idx="2">
-            <a:schemeClr val="accent1"/>
-          </a:effectRef>
-          <a:fontRef idx="minor">
-            <a:schemeClr val="lt1"/>
-          </a:fontRef>
-        </p:style>
-        <p:txBody>
-          <a:bodyPr rtlCol="0" anchor="ctr"/>
-          <a:lstStyle/>
-          <a:p>
-            <a:pPr algn="ctr"/>
-          </a:p>
-        </p:txBody>
-      </p:sp>
-      <p:sp>
-        <p:nvSpPr>
-          <p:cNvPr id="3" name="Rounded Rectangle 2"/>
-          <p:cNvSpPr/>
-          <p:nvPr/>
-        </p:nvSpPr>
-        <p:spPr>
-          <a:xfrm>
-            <a:off x="731520" y="411480"/>
-            <a:ext cx="2560320" cy="320040"/>
-          </a:xfrm>
-          <a:prstGeom prst="roundRect">
-            <a:avLst/>
-          </a:prstGeom>
-          <a:solidFill>
-            <a:srgbClr val="1A2436"/>
-          </a:solidFill>
-          <a:ln w="12700">
-            <a:solidFill>
-              <a:srgbClr val="26324A"/>
-            </a:solidFill>
-          </a:ln>
-        </p:spPr>
-        <p:style>
-          <a:lnRef idx="1">
-            <a:schemeClr val="accent1"/>
-          </a:lnRef>
-          <a:fillRef idx="3">
-            <a:schemeClr val="accent1"/>
-          </a:fillRef>
-          <a:effectRef idx="2">
-            <a:schemeClr val="accent1"/>
-          </a:effectRef>
-          <a:fontRef idx="minor">
-            <a:schemeClr val="lt1"/>
-          </a:fontRef>
-        </p:style>
-        <p:txBody>
-          <a:bodyPr rtlCol="0" anchor="ctr"/>
-          <a:lstStyle/>
-          <a:p>
-            <a:pPr algn="ctr">
-              <a:defRPr sz="900" b="1">
-                <a:solidFill>
-                  <a:srgbClr val="38BDF8"/>
-                </a:solidFill>
-              </a:defRPr>
-            </a:pPr>
-            <a:r>
-              <a:t>5. KEY INSIGHTS</a:t>
-            </a:r>
-          </a:p>
-        </p:txBody>
-      </p:sp>
-      <p:sp>
-        <p:nvSpPr>
-          <p:cNvPr id="4" name="TextBox 3"/>
-          <p:cNvSpPr txBox="1"/>
-          <p:nvPr/>
-        </p:nvSpPr>
-        <p:spPr>
-          <a:xfrm>
-            <a:off x="731520" y="777240"/>
-            <a:ext cx="10698480" cy="731520"/>
-          </a:xfrm>
-          <a:prstGeom prst="rect">
-            <a:avLst/>
-          </a:prstGeom>
-          <a:noFill/>
-        </p:spPr>
-        <p:txBody>
-          <a:bodyPr wrap="square">
-            <a:spAutoFit/>
-          </a:bodyPr>
-          <a:lstStyle/>
-          <a:p>
-            <a:pPr>
-              <a:defRPr sz="2200" b="1">
-                <a:solidFill>
-                  <a:srgbClr val="F8FAFC"/>
-                </a:solidFill>
-              </a:defRPr>
-            </a:pPr>
-            <a:r>
-              <a:t>Conclusion &amp; Key Learnings from Building the Mock</a:t>
-            </a:r>
-          </a:p>
-          <a:p>
-            <a:pPr>
-              <a:defRPr sz="1100">
-                <a:solidFill>
-                  <a:srgbClr val="94A3B8"/>
-                </a:solidFill>
-              </a:defRPr>
-            </a:pPr>
-            <a:r>
-              <a:t>Critical lessons discovered throughout the design and engineering process.</a:t>
+                  <a:srgbClr val="CBD5E1"/>
+                </a:solidFill>
+              </a:defRPr>
+            </a:pPr>
+            <a:r>
+              <a:t>The three main things we learned while building this project.</a:t>
             </a:r>
           </a:p>
         </p:txBody>
@@ -6774,11 +6211,11 @@
             <a:avLst/>
           </a:prstGeom>
           <a:solidFill>
-            <a:srgbClr val="121826"/>
+            <a:srgbClr val="1E293B"/>
           </a:solidFill>
           <a:ln w="15240">
             <a:solidFill>
-              <a:srgbClr val="26324A"/>
+              <a:srgbClr val="334155"/>
             </a:solidFill>
           </a:ln>
         </p:spPr>
@@ -6834,52 +6271,52 @@
               </a:defRPr>
             </a:pPr>
             <a:r>
-              <a:t>[ENGINEERING]  1. Framework Independence</a:t>
+              <a:t>[CODE LESSON]  1. Simple Code is Fast</a:t>
             </a:r>
           </a:p>
           <a:p>
             <a:pPr>
               <a:spcBef>
-                <a:spcPts val="500"/>
+                <a:spcPts val="600"/>
               </a:spcBef>
-              <a:defRPr sz="1050">
-                <a:solidFill>
-                  <a:srgbClr val="94A3B8"/>
-                </a:solidFill>
-              </a:defRPr>
-            </a:pPr>
-            <a:r>
-              <a:t>• Modern web standards are exceptionally capable: Native CSS variables and ES6 modules replicated multi-page SPA routing seamlessly.</a:t>
+              <a:defRPr sz="1100">
+                <a:solidFill>
+                  <a:srgbClr val="CBD5E1"/>
+                </a:solidFill>
+              </a:defRPr>
+            </a:pPr>
+            <a:r>
+              <a:t>• We didn't need big frameworks like React to build an interactive multi-page website.</a:t>
             </a:r>
           </a:p>
           <a:p>
             <a:pPr>
               <a:spcBef>
-                <a:spcPts val="500"/>
+                <a:spcPts val="600"/>
               </a:spcBef>
-              <a:defRPr sz="1050">
-                <a:solidFill>
-                  <a:srgbClr val="94A3B8"/>
-                </a:solidFill>
-              </a:defRPr>
-            </a:pPr>
-            <a:r>
-              <a:t>• Eliminating npm packages removed build vulnerabilities, package rot, and compilation steps entirely.</a:t>
+              <a:defRPr sz="1100">
+                <a:solidFill>
+                  <a:srgbClr val="CBD5E1"/>
+                </a:solidFill>
+              </a:defRPr>
+            </a:pPr>
+            <a:r>
+              <a:t>• Pure HTML, CSS, and JavaScript loaded in under 120ms with zero extra installs.</a:t>
             </a:r>
           </a:p>
           <a:p>
             <a:pPr>
               <a:spcBef>
-                <a:spcPts val="500"/>
+                <a:spcPts val="600"/>
               </a:spcBef>
-              <a:defRPr sz="1050">
-                <a:solidFill>
-                  <a:srgbClr val="94A3B8"/>
-                </a:solidFill>
-              </a:defRPr>
-            </a:pPr>
-            <a:r>
-              <a:t>• Sub-120ms global load times prove that lightweight vanilla code outperforms bloated frontend frameworks for landing and transaction platforms.</a:t>
+              <a:defRPr sz="1100">
+                <a:solidFill>
+                  <a:srgbClr val="CBD5E1"/>
+                </a:solidFill>
+              </a:defRPr>
+            </a:pPr>
+            <a:r>
+              <a:t>• Fewer libraries mean fewer bugs and zero maintenance headache.</a:t>
             </a:r>
           </a:p>
         </p:txBody>
@@ -6899,11 +6336,11 @@
             <a:avLst/>
           </a:prstGeom>
           <a:solidFill>
-            <a:srgbClr val="121826"/>
+            <a:srgbClr val="1E293B"/>
           </a:solidFill>
           <a:ln w="15240">
             <a:solidFill>
-              <a:srgbClr val="26324A"/>
+              <a:srgbClr val="334155"/>
             </a:solidFill>
           </a:ln>
         </p:spPr>
@@ -6954,57 +6391,57 @@
             <a:pPr>
               <a:defRPr sz="1400" b="1">
                 <a:solidFill>
-                  <a:srgbClr val="34D399"/>
-                </a:solidFill>
-              </a:defRPr>
-            </a:pPr>
-            <a:r>
-              <a:t>[PRODUCT STRATEGY]  2. Trust UX in FinTech</a:t>
+                  <a:srgbClr val="4ADE80"/>
+                </a:solidFill>
+              </a:defRPr>
+            </a:pPr>
+            <a:r>
+              <a:t>[DESIGN LESSON]  2. Clear Info Beats Flashy UI</a:t>
             </a:r>
           </a:p>
           <a:p>
             <a:pPr>
               <a:spcBef>
-                <a:spcPts val="500"/>
+                <a:spcPts val="600"/>
               </a:spcBef>
-              <a:defRPr sz="1050">
-                <a:solidFill>
-                  <a:srgbClr val="94A3B8"/>
-                </a:solidFill>
-              </a:defRPr>
-            </a:pPr>
-            <a:r>
-              <a:t>• In institutional M&amp;A, transparency builds far more trust than flashy animations.</a:t>
+              <a:defRPr sz="1100">
+                <a:solidFill>
+                  <a:srgbClr val="CBD5E1"/>
+                </a:solidFill>
+              </a:defRPr>
+            </a:pPr>
+            <a:r>
+              <a:t>• In finance and business, people care about honest numbers, not glowing neon buttons.</a:t>
             </a:r>
           </a:p>
           <a:p>
             <a:pPr>
               <a:spcBef>
-                <a:spcPts val="500"/>
+                <a:spcPts val="600"/>
               </a:spcBef>
-              <a:defRPr sz="1050">
-                <a:solidFill>
-                  <a:srgbClr val="94A3B8"/>
-                </a:solidFill>
-              </a:defRPr>
-            </a:pPr>
-            <a:r>
-              <a:t>• Institutional investors and founders prioritize clear financial multiples, verified data, and risk mitigation over neon gradients.</a:t>
+              <a:defRPr sz="1100">
+                <a:solidFill>
+                  <a:srgbClr val="CBD5E1"/>
+                </a:solidFill>
+              </a:defRPr>
+            </a:pPr>
+            <a:r>
+              <a:t>• Clean tables, verified Stripe data, and clear fee comparisons build real trust with buyers and sellers.</a:t>
             </a:r>
           </a:p>
           <a:p>
             <a:pPr>
               <a:spcBef>
-                <a:spcPts val="500"/>
+                <a:spcPts val="600"/>
               </a:spcBef>
-              <a:defRPr sz="1050">
-                <a:solidFill>
-                  <a:srgbClr val="94A3B8"/>
-                </a:solidFill>
-              </a:defRPr>
-            </a:pPr>
-            <a:r>
-              <a:t>• Every UI decision must reinforce security, credibility, and verified accuracy.</a:t>
+              <a:defRPr sz="1100">
+                <a:solidFill>
+                  <a:srgbClr val="CBD5E1"/>
+                </a:solidFill>
+              </a:defRPr>
+            </a:pPr>
+            <a:r>
+              <a:t>• Simple and plain design looks far more serious and professional.</a:t>
             </a:r>
           </a:p>
         </p:txBody>
@@ -7024,11 +6461,11 @@
             <a:avLst/>
           </a:prstGeom>
           <a:solidFill>
-            <a:srgbClr val="121826"/>
+            <a:srgbClr val="1E293B"/>
           </a:solidFill>
           <a:ln w="15240">
             <a:solidFill>
-              <a:srgbClr val="26324A"/>
+              <a:srgbClr val="334155"/>
             </a:solidFill>
           </a:ln>
         </p:spPr>
@@ -7079,57 +6516,57 @@
             <a:pPr>
               <a:defRPr sz="1400" b="1">
                 <a:solidFill>
-                  <a:srgbClr val="F59E0B"/>
-                </a:solidFill>
-              </a:defRPr>
-            </a:pPr>
-            <a:r>
-              <a:t>[TRANSACTION VALUE]  3. Solving Deal Anxiety</a:t>
+                  <a:srgbClr val="FBBF24"/>
+                </a:solidFill>
+              </a:defRPr>
+            </a:pPr>
+            <a:r>
+              <a:t>[PRODUCT LESSON]  3. Safety is What Sells</a:t>
             </a:r>
           </a:p>
           <a:p>
             <a:pPr>
               <a:spcBef>
-                <a:spcPts val="500"/>
+                <a:spcPts val="600"/>
               </a:spcBef>
-              <a:defRPr sz="1050">
-                <a:solidFill>
-                  <a:srgbClr val="94A3B8"/>
-                </a:solidFill>
-              </a:defRPr>
-            </a:pPr>
-            <a:r>
-              <a:t>• Anyone can build a directory that lists software for sale.</a:t>
+              <a:defRPr sz="1100">
+                <a:solidFill>
+                  <a:srgbClr val="CBD5E1"/>
+                </a:solidFill>
+              </a:defRPr>
+            </a:pPr>
+            <a:r>
+              <a:t>• Anyone can build a website that lists apps for sale.</a:t>
             </a:r>
           </a:p>
           <a:p>
             <a:pPr>
               <a:spcBef>
-                <a:spcPts val="500"/>
+                <a:spcPts val="600"/>
               </a:spcBef>
-              <a:defRPr sz="1050">
-                <a:solidFill>
-                  <a:srgbClr val="94A3B8"/>
-                </a:solidFill>
-              </a:defRPr>
-            </a:pPr>
-            <a:r>
-              <a:t>• The real commercial value in M&amp;A lies in solving the settlement risk: the fear of getting scammed during custody handoff.</a:t>
+              <a:defRPr sz="1100">
+                <a:solidFill>
+                  <a:srgbClr val="CBD5E1"/>
+                </a:solidFill>
+              </a:defRPr>
+            </a:pPr>
+            <a:r>
+              <a:t>• The real challenge is making sure nobody gets scammed when handing over code and money.</a:t>
             </a:r>
           </a:p>
           <a:p>
             <a:pPr>
               <a:spcBef>
-                <a:spcPts val="500"/>
+                <a:spcPts val="600"/>
               </a:spcBef>
-              <a:defRPr sz="1050">
-                <a:solidFill>
-                  <a:srgbClr val="94A3B8"/>
-                </a:solidFill>
-              </a:defRPr>
-            </a:pPr>
-            <a:r>
-              <a:t>• Engineering the Atomic Handover Protocol demonstrated that safety and escrow mechanics are the platform's primary competitive advantage.</a:t>
+              <a:defRPr sz="1100">
+                <a:solidFill>
+                  <a:srgbClr val="CBD5E1"/>
+                </a:solidFill>
+              </a:defRPr>
+            </a:pPr>
+            <a:r>
+              <a:t>• Building the safe 4-step handover is what makes this platform genuinely useful and valuable.</a:t>
             </a:r>
           </a:p>
         </p:txBody>

</xml_diff>

<commit_message>
Generate clean, quiet, uncluttered PowerPoint presentation
</commit_message>
<xml_diff>
--- a/vventra_presentation.pptx
+++ b/vventra_presentation.pptx
@@ -507,7 +507,7 @@
           <a:lstStyle/>
           <a:p>
             <a:r>
-              <a:t>Hello everyone. Today I'm presenting vvEntra. In simple terms, vvEntra is an online marketplace where people can buy and sell software businesses safely. I rebuilt the website using simple, clean code with zero extra libraries, made it load fast, and added a safe 4-step handover system so neither buyers nor sellers get scammed.</a:t>
+              <a:t>Hello everyone. Today I'm presenting vvEntra. vvEntra is an online platform for buying and selling software businesses safely. I built the website with clean, pure code and zero external dependencies, and added an Atomic Handover Protocol so that neither the buyer nor the seller can get scammed.</a:t>
             </a:r>
           </a:p>
         </p:txBody>
@@ -577,7 +577,7 @@
           <a:lstStyle/>
           <a:p>
             <a:r>
-              <a:t>Point 1: What is the core idea? Think of it like a trusted real estate agent, but for apps and software instead of houses. It solves three simple problems: high broker fees, fake earnings screenshots, and the fear of getting scammed. Buyers get real, verified numbers and safe escrow. Sellers save tens of thousands in fees and protect their code. And for our platform, we make a clear 3% to 7% fee on every successful sale.</a:t>
+              <a:t>Point 1: What is the core idea? Think of it like a trusted real estate service, but for software companies. It solves three problems: high broker fees, fake screenshots, and the fear of getting cheated. Buyers get verified numbers and escrow safety. Sellers save tens of thousands in fees and protect their code. And for our platform, we operate on a clean 90/10 split on successful sales.</a:t>
             </a:r>
           </a:p>
         </p:txBody>
@@ -647,7 +647,7 @@
           <a:lstStyle/>
           <a:p>
             <a:r>
-              <a:t>Point 2: Here are the main features of the website. First, a top switch that flips between Buyer and Seller mode. Second, a dashboard with a 4-box grid where users can click to filter companies, and charts showing market demand. Third, a calculator that tells founders what their software is worth. Fourth, a clean marketplace to search apps. And fifth, a private data room to view sensitive business records safely.</a:t>
+              <a:t>Point 2: Here are the main features of the website. First, a top switch that flips between Buyer and Seller mode. Second, a dashboard with an interactive 2x2 grid to filter companies and charts showing market demand. Third, a calculator that tells founders what their software is worth. Fourth, a clean marketplace to search apps. And fifth, a private data room to view sensitive business records safely.</a:t>
             </a:r>
           </a:p>
         </p:txBody>
@@ -717,7 +717,7 @@
           <a:lstStyle/>
           <a:p>
             <a:r>
-              <a:t>Point 3: For our tech stack, we kept it 100% simple: pure HTML, CSS, and Vanilla JavaScript with zero extra libraries. Why is this helpful for adding AI agents? Because all data is stored in one clean file (data.js), and the web code is completely clean without complex React layers. AI agents can easily connect to it: an AI can scan GitHub code, an AI can automatically update prices, and an AI assistant can answer buyers' questions inside the private data room.</a:t>
+              <a:t>Point 3: For our tech stack, we kept it clean and direct: pure HTML5, CSS3, and Vanilla JavaScript with zero extra libraries. No React, no npm packages, and no build steps. Why is this helpful for adding AI agents? Because all data lives in a clean data file (data.js), and the web code is completely transparent without complex React layers. AI agents can easily connect to it to scan code, update valuations, or answer questions inside the data room.</a:t>
             </a:r>
           </a:p>
         </p:txBody>
@@ -787,7 +787,7 @@
           <a:lstStyle/>
           <a:p>
             <a:r>
-              <a:t>Point 4: What is our main innovation compared to the original site? The original site had flashy neon colors, but the buttons and charts didn't do much, and there was no way to safely transfer apps. We built the Safe 4-Step Handover system: money is locked in escrow, code is secured, the domain is moved, and the buyer confirms everything works before the money is released. We also added a live simulator on every listing so users can click through and see the safety for themselves.</a:t>
+              <a:t>Point 4: What is our main innovation compared to the original site? The original site had flashy neon colors, but the buttons didn't work and there was no way to safely transfer apps. We built the Safe 4-Step Handover system: first, the buyer deposits 100% of the funds in escrow. Second, code and cloud servers are locked in custody. Third, the domain is moved. And fourth, once the buyer tests and confirms, the seller gets 90% and vvEntra retains 10%. We also built an interactive live simulator right on the page so anyone can test it.</a:t>
             </a:r>
           </a:p>
         </p:txBody>
@@ -3914,8 +3914,8 @@
         </p:nvSpPr>
         <p:spPr>
           <a:xfrm>
-            <a:off x="731520" y="1371600"/>
-            <a:ext cx="10728655" cy="4114800"/>
+            <a:off x="914400" y="1371600"/>
+            <a:ext cx="10362895" cy="4114800"/>
           </a:xfrm>
           <a:prstGeom prst="roundRect">
             <a:avLst/>
@@ -3923,7 +3923,7 @@
           <a:solidFill>
             <a:srgbClr val="1E293B"/>
           </a:solidFill>
-          <a:ln>
+          <a:ln w="19050">
             <a:solidFill>
               <a:srgbClr val="334155"/>
             </a:solidFill>
@@ -3959,8 +3959,8 @@
         </p:nvSpPr>
         <p:spPr>
           <a:xfrm>
-            <a:off x="1097280" y="1828800"/>
-            <a:ext cx="10058400" cy="3291840"/>
+            <a:off x="1371600" y="1920240"/>
+            <a:ext cx="9418320" cy="3017520"/>
           </a:xfrm>
           <a:prstGeom prst="rect">
             <a:avLst/>
@@ -3974,7 +3974,7 @@
           <a:lstStyle/>
           <a:p>
             <a:pPr>
-              <a:defRPr sz="4000" b="1">
+              <a:defRPr sz="4400" b="1">
                 <a:solidFill>
                   <a:srgbClr val="FFFFFF"/>
                 </a:solidFill>
@@ -3987,9 +3987,9 @@
           <a:p>
             <a:pPr>
               <a:spcBef>
-                <a:spcPts val="600"/>
+                <a:spcPts val="800"/>
               </a:spcBef>
-              <a:defRPr sz="1800">
+              <a:defRPr sz="2000">
                 <a:solidFill>
                   <a:srgbClr val="38BDF8"/>
                 </a:solidFill>
@@ -4006,12 +4006,12 @@
               </a:spcBef>
               <a:defRPr sz="1300">
                 <a:solidFill>
-                  <a:srgbClr val="CBD5E1"/>
-                </a:solidFill>
-              </a:defRPr>
-            </a:pPr>
-            <a:r>
-              <a:t>A simple, fast website where developers and investors trade apps and software safely without getting scammed.</a:t>
+                  <a:srgbClr val="E2E8F0"/>
+                </a:solidFill>
+              </a:defRPr>
+            </a:pPr>
+            <a:r>
+              <a:t>An institutional platform where developers and investors trade software, apps, and digital IP safely without getting scammed.</a:t>
             </a:r>
           </a:p>
           <a:p>
@@ -4026,7 +4026,7 @@
               </a:defRPr>
             </a:pPr>
             <a:r>
-              <a:t>Live Website: https://rohithagarwal.github.io/vventra/  |  Repository: github.com/rohithagarwal/vventra</a:t>
+              <a:t>Live Website: https://rohithagarwal.github.io/vventra/   |   Repository: github.com/rohithagarwal/vventra</a:t>
             </a:r>
           </a:p>
         </p:txBody>
@@ -4094,14 +4094,119 @@
       </p:sp>
       <p:sp>
         <p:nvSpPr>
-          <p:cNvPr id="3" name="Rounded Rectangle 2"/>
+          <p:cNvPr id="3" name="TextBox 2"/>
+          <p:cNvSpPr txBox="1"/>
+          <p:nvPr/>
+        </p:nvSpPr>
+        <p:spPr>
+          <a:xfrm>
+            <a:off x="822960" y="502920"/>
+            <a:ext cx="4572000" cy="320040"/>
+          </a:xfrm>
+          <a:prstGeom prst="rect">
+            <a:avLst/>
+          </a:prstGeom>
+          <a:noFill/>
+        </p:spPr>
+        <p:txBody>
+          <a:bodyPr wrap="none">
+            <a:spAutoFit/>
+          </a:bodyPr>
+          <a:lstStyle/>
+          <a:p>
+            <a:pPr>
+              <a:defRPr sz="1000" b="1">
+                <a:solidFill>
+                  <a:srgbClr val="38BDF8"/>
+                </a:solidFill>
+              </a:defRPr>
+            </a:pPr>
+            <a:r>
+              <a:t>SLIDE 01 · VVENTRA OVERVIEW</a:t>
+            </a:r>
+          </a:p>
+        </p:txBody>
+      </p:sp>
+      <p:sp>
+        <p:nvSpPr>
+          <p:cNvPr id="4" name="TextBox 3"/>
+          <p:cNvSpPr txBox="1"/>
+          <p:nvPr/>
+        </p:nvSpPr>
+        <p:spPr>
+          <a:xfrm>
+            <a:off x="822960" y="777240"/>
+            <a:ext cx="10515600" cy="594360"/>
+          </a:xfrm>
+          <a:prstGeom prst="rect">
+            <a:avLst/>
+          </a:prstGeom>
+          <a:noFill/>
+        </p:spPr>
+        <p:txBody>
+          <a:bodyPr wrap="none">
+            <a:spAutoFit/>
+          </a:bodyPr>
+          <a:lstStyle/>
+          <a:p>
+            <a:pPr>
+              <a:defRPr sz="2400" b="1">
+                <a:solidFill>
+                  <a:srgbClr val="FFFFFF"/>
+                </a:solidFill>
+              </a:defRPr>
+            </a:pPr>
+            <a:r>
+              <a:t>Core Idea, Problem Solved &amp; Benefits</a:t>
+            </a:r>
+          </a:p>
+        </p:txBody>
+      </p:sp>
+      <p:sp>
+        <p:nvSpPr>
+          <p:cNvPr id="5" name="TextBox 4"/>
+          <p:cNvSpPr txBox="1"/>
+          <p:nvPr/>
+        </p:nvSpPr>
+        <p:spPr>
+          <a:xfrm>
+            <a:off x="822960" y="1325880"/>
+            <a:ext cx="10515600" cy="411480"/>
+          </a:xfrm>
+          <a:prstGeom prst="rect">
+            <a:avLst/>
+          </a:prstGeom>
+          <a:noFill/>
+        </p:spPr>
+        <p:txBody>
+          <a:bodyPr wrap="none">
+            <a:spAutoFit/>
+          </a:bodyPr>
+          <a:lstStyle/>
+          <a:p>
+            <a:pPr>
+              <a:defRPr sz="1200">
+                <a:solidFill>
+                  <a:srgbClr val="94A3B8"/>
+                </a:solidFill>
+              </a:defRPr>
+            </a:pPr>
+            <a:r>
+              <a:t>Why software M&amp;A is broken today and how vvEntra solves it.</a:t>
+            </a:r>
+          </a:p>
+        </p:txBody>
+      </p:sp>
+      <p:sp>
+        <p:nvSpPr>
+          <p:cNvPr id="6" name="Rounded Rectangle 5"/>
           <p:cNvSpPr/>
           <p:nvPr/>
         </p:nvSpPr>
         <p:spPr>
           <a:xfrm>
-            <a:off x="731520" y="457200"/>
-            <a:ext cx="2011680" cy="320040"/>
+            <a:off x="822960" y="1920240"/>
+            <a:ext cx="3291840" cy="4297680"/>
           </a:xfrm>
           <a:prstGeom prst="roundRect">
             <a:avLst/>
@@ -4109,7 +4214,7 @@
           <a:solidFill>
             <a:srgbClr val="1E293B"/>
           </a:solidFill>
-          <a:ln w="12700">
+          <a:ln w="15240">
             <a:solidFill>
               <a:srgbClr val="334155"/>
             </a:solidFill>
@@ -4133,29 +4238,20 @@
           <a:bodyPr rtlCol="0" anchor="ctr"/>
           <a:lstStyle/>
           <a:p>
-            <a:pPr algn="ctr">
-              <a:defRPr sz="900" b="1">
-                <a:solidFill>
-                  <a:srgbClr val="38BDF8"/>
-                </a:solidFill>
-              </a:defRPr>
-            </a:pPr>
-            <a:r>
-              <a:t>1. CORE IDEA</a:t>
-            </a:r>
-          </a:p>
-        </p:txBody>
-      </p:sp>
-      <p:sp>
-        <p:nvSpPr>
-          <p:cNvPr id="4" name="TextBox 3"/>
+            <a:pPr algn="ctr"/>
+          </a:p>
+        </p:txBody>
+      </p:sp>
+      <p:sp>
+        <p:nvSpPr>
+          <p:cNvPr id="7" name="TextBox 6"/>
           <p:cNvSpPr txBox="1"/>
           <p:nvPr/>
         </p:nvSpPr>
         <p:spPr>
           <a:xfrm>
-            <a:off x="731520" y="822960"/>
-            <a:ext cx="10698480" cy="731520"/>
+            <a:off x="1097280" y="2148840"/>
+            <a:ext cx="2743200" cy="3840480"/>
           </a:xfrm>
           <a:prstGeom prst="rect">
             <a:avLst/>
@@ -4169,40 +4265,73 @@
           <a:lstStyle/>
           <a:p>
             <a:pPr>
-              <a:defRPr sz="2200" b="1">
-                <a:solidFill>
-                  <a:srgbClr val="FFFFFF"/>
-                </a:solidFill>
-              </a:defRPr>
-            </a:pPr>
-            <a:r>
-              <a:t>What is vvEntra, What It Solves &amp; Why It Helps</a:t>
-            </a:r>
-          </a:p>
-          <a:p>
-            <a:pPr>
-              <a:defRPr sz="1100">
-                <a:solidFill>
-                  <a:srgbClr val="CBD5E1"/>
-                </a:solidFill>
-              </a:defRPr>
-            </a:pPr>
-            <a:r>
-              <a:t>A simple explanation of the business and who it helps.</a:t>
-            </a:r>
-          </a:p>
-        </p:txBody>
-      </p:sp>
-      <p:sp>
-        <p:nvSpPr>
-          <p:cNvPr id="5" name="Rounded Rectangle 4"/>
+              <a:defRPr sz="1500" b="1">
+                <a:solidFill>
+                  <a:srgbClr val="FBBF24"/>
+                </a:solidFill>
+              </a:defRPr>
+            </a:pPr>
+            <a:r>
+              <a:t>The Problem</a:t>
+            </a:r>
+          </a:p>
+          <a:p>
+            <a:pPr>
+              <a:spcBef>
+                <a:spcPts val="800"/>
+              </a:spcBef>
+              <a:defRPr sz="1150">
+                <a:solidFill>
+                  <a:srgbClr val="E2E8F0"/>
+                </a:solidFill>
+              </a:defRPr>
+            </a:pPr>
+            <a:r>
+              <a:t>• Expensive Middlemen: Traditional brokers charge 10% to 15% and take 6 to 12 months.</a:t>
+            </a:r>
+          </a:p>
+          <a:p>
+            <a:pPr>
+              <a:spcBef>
+                <a:spcPts val="800"/>
+              </a:spcBef>
+              <a:defRPr sz="1150">
+                <a:solidFill>
+                  <a:srgbClr val="E2E8F0"/>
+                </a:solidFill>
+              </a:defRPr>
+            </a:pPr>
+            <a:r>
+              <a:t>• Fake Screenshots: Public websites are full of fake revenue numbers and copied code.</a:t>
+            </a:r>
+          </a:p>
+          <a:p>
+            <a:pPr>
+              <a:spcBef>
+                <a:spcPts val="800"/>
+              </a:spcBef>
+              <a:defRPr sz="1150">
+                <a:solidFill>
+                  <a:srgbClr val="E2E8F0"/>
+                </a:solidFill>
+              </a:defRPr>
+            </a:pPr>
+            <a:r>
+              <a:t>• Settlement Fear: Buyers fear paying and getting ghosted; sellers fear handing over code without payment.</a:t>
+            </a:r>
+          </a:p>
+        </p:txBody>
+      </p:sp>
+      <p:sp>
+        <p:nvSpPr>
+          <p:cNvPr id="8" name="Rounded Rectangle 7"/>
           <p:cNvSpPr/>
           <p:nvPr/>
         </p:nvSpPr>
         <p:spPr>
           <a:xfrm>
-            <a:off x="731520" y="1737360"/>
-            <a:ext cx="3291840" cy="4572000"/>
+            <a:off x="4443984" y="1920240"/>
+            <a:ext cx="3291840" cy="4297680"/>
           </a:xfrm>
           <a:prstGeom prst="roundRect">
             <a:avLst/>
@@ -4240,14 +4369,14 @@
       </p:sp>
       <p:sp>
         <p:nvSpPr>
-          <p:cNvPr id="6" name="TextBox 5"/>
+          <p:cNvPr id="9" name="TextBox 8"/>
           <p:cNvSpPr txBox="1"/>
           <p:nvPr/>
         </p:nvSpPr>
         <p:spPr>
           <a:xfrm>
-            <a:off x="960120" y="1920240"/>
-            <a:ext cx="2834640" cy="4206240"/>
+            <a:off x="4718304" y="2148840"/>
+            <a:ext cx="2743200" cy="3840480"/>
           </a:xfrm>
           <a:prstGeom prst="rect">
             <a:avLst/>
@@ -4261,73 +4390,73 @@
           <a:lstStyle/>
           <a:p>
             <a:pPr>
-              <a:defRPr sz="1400" b="1">
-                <a:solidFill>
-                  <a:srgbClr val="FBBF24"/>
-                </a:solidFill>
-              </a:defRPr>
-            </a:pPr>
-            <a:r>
-              <a:t>[THE PROBLEM]  The Problem It Solves</a:t>
+              <a:defRPr sz="1500" b="1">
+                <a:solidFill>
+                  <a:srgbClr val="4ADE80"/>
+                </a:solidFill>
+              </a:defRPr>
+            </a:pPr>
+            <a:r>
+              <a:t>Benefits for the User</a:t>
             </a:r>
           </a:p>
           <a:p>
             <a:pPr>
               <a:spcBef>
-                <a:spcPts val="600"/>
+                <a:spcPts val="800"/>
               </a:spcBef>
-              <a:defRPr sz="1100">
-                <a:solidFill>
-                  <a:srgbClr val="CBD5E1"/>
-                </a:solidFill>
-              </a:defRPr>
-            </a:pPr>
-            <a:r>
-              <a:t>• Expensive Middlemen: Traditional brokers charge huge fees (10% to 15%) and take 6 to 12 months.</a:t>
+              <a:defRPr sz="1150">
+                <a:solidFill>
+                  <a:srgbClr val="E2E8F0"/>
+                </a:solidFill>
+              </a:defRPr>
+            </a:pPr>
+            <a:r>
+              <a:t>• For Buyers: Real earnings verified directly by Stripe, clean code audits, and money held safely in escrow.</a:t>
             </a:r>
           </a:p>
           <a:p>
             <a:pPr>
               <a:spcBef>
-                <a:spcPts val="600"/>
+                <a:spcPts val="800"/>
               </a:spcBef>
-              <a:defRPr sz="1100">
-                <a:solidFill>
-                  <a:srgbClr val="CBD5E1"/>
-                </a:solidFill>
-              </a:defRPr>
-            </a:pPr>
-            <a:r>
-              <a:t>• Fake Numbers: Public websites are full of fake revenue screenshots and stolen code.</a:t>
+              <a:defRPr sz="1150">
+                <a:solidFill>
+                  <a:srgbClr val="E2E8F0"/>
+                </a:solidFill>
+              </a:defRPr>
+            </a:pPr>
+            <a:r>
+              <a:t>• For Sellers: Low fees (3% to 7% saving $50k+), serious buyers, and code is never handed over until full funds are locked.</a:t>
             </a:r>
           </a:p>
           <a:p>
             <a:pPr>
               <a:spcBef>
-                <a:spcPts val="600"/>
+                <a:spcPts val="800"/>
               </a:spcBef>
-              <a:defRPr sz="1100">
-                <a:solidFill>
-                  <a:srgbClr val="CBD5E1"/>
-                </a:solidFill>
-              </a:defRPr>
-            </a:pPr>
-            <a:r>
-              <a:t>• Fear of Getting Cheated: Buyers are afraid to pay first and get ghosted. Sellers are afraid to give away code without getting paid.</a:t>
-            </a:r>
-          </a:p>
-        </p:txBody>
-      </p:sp>
-      <p:sp>
-        <p:nvSpPr>
-          <p:cNvPr id="7" name="Rounded Rectangle 6"/>
+              <a:defRPr sz="1150">
+                <a:solidFill>
+                  <a:srgbClr val="E2E8F0"/>
+                </a:solidFill>
+              </a:defRPr>
+            </a:pPr>
+            <a:r>
+              <a:t>• Fast Timeline: Deals close in an average of 18 days instead of nearly a year.</a:t>
+            </a:r>
+          </a:p>
+        </p:txBody>
+      </p:sp>
+      <p:sp>
+        <p:nvSpPr>
+          <p:cNvPr id="10" name="Rounded Rectangle 9"/>
           <p:cNvSpPr/>
           <p:nvPr/>
         </p:nvSpPr>
         <p:spPr>
           <a:xfrm>
-            <a:off x="4443984" y="1737360"/>
-            <a:ext cx="3291840" cy="4572000"/>
+            <a:off x="8074152" y="1920240"/>
+            <a:ext cx="3291840" cy="4297680"/>
           </a:xfrm>
           <a:prstGeom prst="roundRect">
             <a:avLst/>
@@ -4365,14 +4494,14 @@
       </p:sp>
       <p:sp>
         <p:nvSpPr>
-          <p:cNvPr id="8" name="TextBox 7"/>
+          <p:cNvPr id="11" name="TextBox 10"/>
           <p:cNvSpPr txBox="1"/>
           <p:nvPr/>
         </p:nvSpPr>
         <p:spPr>
           <a:xfrm>
-            <a:off x="4672584" y="1920240"/>
-            <a:ext cx="2834640" cy="4206240"/>
+            <a:off x="8348472" y="2148840"/>
+            <a:ext cx="2743200" cy="3840480"/>
           </a:xfrm>
           <a:prstGeom prst="rect">
             <a:avLst/>
@@ -4386,184 +4515,59 @@
           <a:lstStyle/>
           <a:p>
             <a:pPr>
-              <a:defRPr sz="1400" b="1">
-                <a:solidFill>
-                  <a:srgbClr val="4ADE80"/>
-                </a:solidFill>
-              </a:defRPr>
-            </a:pPr>
-            <a:r>
-              <a:t>[FOR USERS]  Benefits for the User</a:t>
+              <a:defRPr sz="1500" b="1">
+                <a:solidFill>
+                  <a:srgbClr val="38BDF8"/>
+                </a:solidFill>
+              </a:defRPr>
+            </a:pPr>
+            <a:r>
+              <a:t>Benefits for Us (Business)</a:t>
             </a:r>
           </a:p>
           <a:p>
             <a:pPr>
               <a:spcBef>
-                <a:spcPts val="600"/>
+                <a:spcPts val="800"/>
               </a:spcBef>
-              <a:defRPr sz="1100">
-                <a:solidFill>
-                  <a:srgbClr val="CBD5E1"/>
-                </a:solidFill>
-              </a:defRPr>
-            </a:pPr>
-            <a:r>
-              <a:t>• For Buyers: Real earnings checked with Stripe (no fake screenshots); code is checked for bugs; money stays safe in escrow.</a:t>
+              <a:defRPr sz="1150">
+                <a:solidFill>
+                  <a:srgbClr val="E2E8F0"/>
+                </a:solidFill>
+              </a:defRPr>
+            </a:pPr>
+            <a:r>
+              <a:t>• Clean Revenue Model: We take a transparent fee on every sale (90% to seller / 10% to vvEntra).</a:t>
             </a:r>
           </a:p>
           <a:p>
             <a:pPr>
               <a:spcBef>
-                <a:spcPts val="600"/>
+                <a:spcPts val="800"/>
               </a:spcBef>
-              <a:defRPr sz="1100">
-                <a:solidFill>
-                  <a:srgbClr val="CBD5E1"/>
-                </a:solidFill>
-              </a:defRPr>
-            </a:pPr>
-            <a:r>
-              <a:t>• For Sellers: Much lower fees (3% to 7% instead of 15%, saving $50k+); code is never handed over until the buyer's money is locked.</a:t>
+              <a:defRPr sz="1150">
+                <a:solidFill>
+                  <a:srgbClr val="E2E8F0"/>
+                </a:solidFill>
+              </a:defRPr>
+            </a:pPr>
+            <a:r>
+              <a:t>• Extra Services: Revenue from technical code audits, escrow fees, and private deal room access.</a:t>
             </a:r>
           </a:p>
           <a:p>
             <a:pPr>
               <a:spcBef>
-                <a:spcPts val="600"/>
+                <a:spcPts val="800"/>
               </a:spcBef>
-              <a:defRPr sz="1100">
-                <a:solidFill>
-                  <a:srgbClr val="CBD5E1"/>
-                </a:solidFill>
-              </a:defRPr>
-            </a:pPr>
-            <a:r>
-              <a:t>• Fast Deals: Deals close in about 18 days instead of almost a year.</a:t>
-            </a:r>
-          </a:p>
-        </p:txBody>
-      </p:sp>
-      <p:sp>
-        <p:nvSpPr>
-          <p:cNvPr id="9" name="Rounded Rectangle 8"/>
-          <p:cNvSpPr/>
-          <p:nvPr/>
-        </p:nvSpPr>
-        <p:spPr>
-          <a:xfrm>
-            <a:off x="8165592" y="1737360"/>
-            <a:ext cx="3291840" cy="4572000"/>
-          </a:xfrm>
-          <a:prstGeom prst="roundRect">
-            <a:avLst/>
-          </a:prstGeom>
-          <a:solidFill>
-            <a:srgbClr val="1E293B"/>
-          </a:solidFill>
-          <a:ln w="15240">
-            <a:solidFill>
-              <a:srgbClr val="334155"/>
-            </a:solidFill>
-          </a:ln>
-        </p:spPr>
-        <p:style>
-          <a:lnRef idx="1">
-            <a:schemeClr val="accent1"/>
-          </a:lnRef>
-          <a:fillRef idx="3">
-            <a:schemeClr val="accent1"/>
-          </a:fillRef>
-          <a:effectRef idx="2">
-            <a:schemeClr val="accent1"/>
-          </a:effectRef>
-          <a:fontRef idx="minor">
-            <a:schemeClr val="lt1"/>
-          </a:fontRef>
-        </p:style>
-        <p:txBody>
-          <a:bodyPr rtlCol="0" anchor="ctr"/>
-          <a:lstStyle/>
-          <a:p>
-            <a:pPr algn="ctr"/>
-          </a:p>
-        </p:txBody>
-      </p:sp>
-      <p:sp>
-        <p:nvSpPr>
-          <p:cNvPr id="10" name="TextBox 9"/>
-          <p:cNvSpPr txBox="1"/>
-          <p:nvPr/>
-        </p:nvSpPr>
-        <p:spPr>
-          <a:xfrm>
-            <a:off x="8394192" y="1920240"/>
-            <a:ext cx="2834640" cy="4206240"/>
-          </a:xfrm>
-          <a:prstGeom prst="rect">
-            <a:avLst/>
-          </a:prstGeom>
-          <a:noFill/>
-        </p:spPr>
-        <p:txBody>
-          <a:bodyPr wrap="square">
-            <a:spAutoFit/>
-          </a:bodyPr>
-          <a:lstStyle/>
-          <a:p>
-            <a:pPr>
-              <a:defRPr sz="1400" b="1">
-                <a:solidFill>
-                  <a:srgbClr val="38BDF8"/>
-                </a:solidFill>
-              </a:defRPr>
-            </a:pPr>
-            <a:r>
-              <a:t>[FOR OUR PLATFORM]  Benefits for Us (Our Business)</a:t>
-            </a:r>
-          </a:p>
-          <a:p>
-            <a:pPr>
-              <a:spcBef>
-                <a:spcPts val="600"/>
-              </a:spcBef>
-              <a:defRPr sz="1100">
-                <a:solidFill>
-                  <a:srgbClr val="CBD5E1"/>
-                </a:solidFill>
-              </a:defRPr>
-            </a:pPr>
-            <a:r>
-              <a:t>• Simple Business Model: We take a small 3% to 7% fee on every sale (e.g. $30,000 profit on a $500,000 deal).</a:t>
-            </a:r>
-          </a:p>
-          <a:p>
-            <a:pPr>
-              <a:spcBef>
-                <a:spcPts val="600"/>
-              </a:spcBef>
-              <a:defRPr sz="1100">
-                <a:solidFill>
-                  <a:srgbClr val="CBD5E1"/>
-                </a:solidFill>
-              </a:defRPr>
-            </a:pPr>
-            <a:r>
-              <a:t>• Extra Services: Revenue from code audits, escrow fees, and private deal room access.</a:t>
-            </a:r>
-          </a:p>
-          <a:p>
-            <a:pPr>
-              <a:spcBef>
-                <a:spcPts val="600"/>
-              </a:spcBef>
-              <a:defRPr sz="1100">
-                <a:solidFill>
-                  <a:srgbClr val="CBD5E1"/>
-                </a:solidFill>
-              </a:defRPr>
-            </a:pPr>
-            <a:r>
-              <a:t>• Valuable Market Data: We build a real database of how much software companies actually sell for.</a:t>
+              <a:defRPr sz="1150">
+                <a:solidFill>
+                  <a:srgbClr val="E2E8F0"/>
+                </a:solidFill>
+              </a:defRPr>
+            </a:pPr>
+            <a:r>
+              <a:t>• Market Data: We build a real database of what software companies actually sell for.</a:t>
             </a:r>
           </a:p>
         </p:txBody>
@@ -4631,14 +4635,119 @@
       </p:sp>
       <p:sp>
         <p:nvSpPr>
-          <p:cNvPr id="3" name="Rounded Rectangle 2"/>
+          <p:cNvPr id="3" name="TextBox 2"/>
+          <p:cNvSpPr txBox="1"/>
+          <p:nvPr/>
+        </p:nvSpPr>
+        <p:spPr>
+          <a:xfrm>
+            <a:off x="822960" y="502920"/>
+            <a:ext cx="4572000" cy="320040"/>
+          </a:xfrm>
+          <a:prstGeom prst="rect">
+            <a:avLst/>
+          </a:prstGeom>
+          <a:noFill/>
+        </p:spPr>
+        <p:txBody>
+          <a:bodyPr wrap="none">
+            <a:spAutoFit/>
+          </a:bodyPr>
+          <a:lstStyle/>
+          <a:p>
+            <a:pPr>
+              <a:defRPr sz="1000" b="1">
+                <a:solidFill>
+                  <a:srgbClr val="38BDF8"/>
+                </a:solidFill>
+              </a:defRPr>
+            </a:pPr>
+            <a:r>
+              <a:t>SLIDE 02 · VVENTRA OVERVIEW</a:t>
+            </a:r>
+          </a:p>
+        </p:txBody>
+      </p:sp>
+      <p:sp>
+        <p:nvSpPr>
+          <p:cNvPr id="4" name="TextBox 3"/>
+          <p:cNvSpPr txBox="1"/>
+          <p:nvPr/>
+        </p:nvSpPr>
+        <p:spPr>
+          <a:xfrm>
+            <a:off x="822960" y="777240"/>
+            <a:ext cx="10515600" cy="594360"/>
+          </a:xfrm>
+          <a:prstGeom prst="rect">
+            <a:avLst/>
+          </a:prstGeom>
+          <a:noFill/>
+        </p:spPr>
+        <p:txBody>
+          <a:bodyPr wrap="none">
+            <a:spAutoFit/>
+          </a:bodyPr>
+          <a:lstStyle/>
+          <a:p>
+            <a:pPr>
+              <a:defRPr sz="2400" b="1">
+                <a:solidFill>
+                  <a:srgbClr val="FFFFFF"/>
+                </a:solidFill>
+              </a:defRPr>
+            </a:pPr>
+            <a:r>
+              <a:t>Each Major Functionality of the Website</a:t>
+            </a:r>
+          </a:p>
+        </p:txBody>
+      </p:sp>
+      <p:sp>
+        <p:nvSpPr>
+          <p:cNvPr id="5" name="TextBox 4"/>
+          <p:cNvSpPr txBox="1"/>
+          <p:nvPr/>
+        </p:nvSpPr>
+        <p:spPr>
+          <a:xfrm>
+            <a:off x="822960" y="1325880"/>
+            <a:ext cx="10515600" cy="411480"/>
+          </a:xfrm>
+          <a:prstGeom prst="rect">
+            <a:avLst/>
+          </a:prstGeom>
+          <a:noFill/>
+        </p:spPr>
+        <p:txBody>
+          <a:bodyPr wrap="none">
+            <a:spAutoFit/>
+          </a:bodyPr>
+          <a:lstStyle/>
+          <a:p>
+            <a:pPr>
+              <a:defRPr sz="1200">
+                <a:solidFill>
+                  <a:srgbClr val="94A3B8"/>
+                </a:solidFill>
+              </a:defRPr>
+            </a:pPr>
+            <a:r>
+              <a:t>What users can actually see, click, and do on the platform.</a:t>
+            </a:r>
+          </a:p>
+        </p:txBody>
+      </p:sp>
+      <p:sp>
+        <p:nvSpPr>
+          <p:cNvPr id="6" name="Rounded Rectangle 5"/>
           <p:cNvSpPr/>
           <p:nvPr/>
         </p:nvSpPr>
         <p:spPr>
           <a:xfrm>
-            <a:off x="731520" y="457200"/>
-            <a:ext cx="2011680" cy="320040"/>
+            <a:off x="822960" y="1920240"/>
+            <a:ext cx="3291840" cy="4297680"/>
           </a:xfrm>
           <a:prstGeom prst="roundRect">
             <a:avLst/>
@@ -4646,7 +4755,7 @@
           <a:solidFill>
             <a:srgbClr val="1E293B"/>
           </a:solidFill>
-          <a:ln w="12700">
+          <a:ln w="15240">
             <a:solidFill>
               <a:srgbClr val="334155"/>
             </a:solidFill>
@@ -4670,29 +4779,20 @@
           <a:bodyPr rtlCol="0" anchor="ctr"/>
           <a:lstStyle/>
           <a:p>
-            <a:pPr algn="ctr">
-              <a:defRPr sz="900" b="1">
-                <a:solidFill>
-                  <a:srgbClr val="38BDF8"/>
-                </a:solidFill>
-              </a:defRPr>
-            </a:pPr>
-            <a:r>
-              <a:t>2. MAIN FEATURES</a:t>
-            </a:r>
-          </a:p>
-        </p:txBody>
-      </p:sp>
-      <p:sp>
-        <p:nvSpPr>
-          <p:cNvPr id="4" name="TextBox 3"/>
+            <a:pPr algn="ctr"/>
+          </a:p>
+        </p:txBody>
+      </p:sp>
+      <p:sp>
+        <p:nvSpPr>
+          <p:cNvPr id="7" name="TextBox 6"/>
           <p:cNvSpPr txBox="1"/>
           <p:nvPr/>
         </p:nvSpPr>
         <p:spPr>
           <a:xfrm>
-            <a:off x="731520" y="822960"/>
-            <a:ext cx="10698480" cy="731520"/>
+            <a:off x="1097280" y="2148840"/>
+            <a:ext cx="2743200" cy="3840480"/>
           </a:xfrm>
           <a:prstGeom prst="rect">
             <a:avLst/>
@@ -4706,40 +4806,73 @@
           <a:lstStyle/>
           <a:p>
             <a:pPr>
-              <a:defRPr sz="2200" b="1">
-                <a:solidFill>
-                  <a:srgbClr val="FFFFFF"/>
-                </a:solidFill>
-              </a:defRPr>
-            </a:pPr>
-            <a:r>
-              <a:t>Each Major Functionality of the Website</a:t>
-            </a:r>
-          </a:p>
-          <a:p>
-            <a:pPr>
-              <a:defRPr sz="1100">
-                <a:solidFill>
-                  <a:srgbClr val="CBD5E1"/>
-                </a:solidFill>
-              </a:defRPr>
-            </a:pPr>
-            <a:r>
-              <a:t>What users can actually do on the website.</a:t>
-            </a:r>
-          </a:p>
-        </p:txBody>
-      </p:sp>
-      <p:sp>
-        <p:nvSpPr>
-          <p:cNvPr id="5" name="Rounded Rectangle 4"/>
+              <a:defRPr sz="1500" b="1">
+                <a:solidFill>
+                  <a:srgbClr val="38BDF8"/>
+                </a:solidFill>
+              </a:defRPr>
+            </a:pPr>
+            <a:r>
+              <a:t>Market Dashboard</a:t>
+            </a:r>
+          </a:p>
+          <a:p>
+            <a:pPr>
+              <a:spcBef>
+                <a:spcPts val="800"/>
+              </a:spcBef>
+              <a:defRPr sz="1150">
+                <a:solidFill>
+                  <a:srgbClr val="E2E8F0"/>
+                </a:solidFill>
+              </a:defRPr>
+            </a:pPr>
+            <a:r>
+              <a:t>• Buyer / Seller Switch: One click changes the view to show what buyers care about (returns) or what sellers care about (valuations).</a:t>
+            </a:r>
+          </a:p>
+          <a:p>
+            <a:pPr>
+              <a:spcBef>
+                <a:spcPts val="800"/>
+              </a:spcBef>
+              <a:defRPr sz="1150">
+                <a:solidFill>
+                  <a:srgbClr val="E2E8F0"/>
+                </a:solidFill>
+              </a:defRPr>
+            </a:pPr>
+            <a:r>
+              <a:t>• 2×2 Market Grid: Groups software into 4 simple buckets. Clicking any box filters the marketplace in real time.</a:t>
+            </a:r>
+          </a:p>
+          <a:p>
+            <a:pPr>
+              <a:spcBef>
+                <a:spcPts val="800"/>
+              </a:spcBef>
+              <a:defRPr sz="1150">
+                <a:solidFill>
+                  <a:srgbClr val="E2E8F0"/>
+                </a:solidFill>
+              </a:defRPr>
+            </a:pPr>
+            <a:r>
+              <a:t>• Supply &amp; Demand Chart: Shows which categories (like AI or FinTech) have the highest buyer interest.</a:t>
+            </a:r>
+          </a:p>
+        </p:txBody>
+      </p:sp>
+      <p:sp>
+        <p:nvSpPr>
+          <p:cNvPr id="8" name="Rounded Rectangle 7"/>
           <p:cNvSpPr/>
           <p:nvPr/>
         </p:nvSpPr>
         <p:spPr>
           <a:xfrm>
-            <a:off x="731520" y="1737360"/>
-            <a:ext cx="3291840" cy="4572000"/>
+            <a:off x="4443984" y="1920240"/>
+            <a:ext cx="3291840" cy="4297680"/>
           </a:xfrm>
           <a:prstGeom prst="roundRect">
             <a:avLst/>
@@ -4777,14 +4910,14 @@
       </p:sp>
       <p:sp>
         <p:nvSpPr>
-          <p:cNvPr id="6" name="TextBox 5"/>
+          <p:cNvPr id="9" name="TextBox 8"/>
           <p:cNvSpPr txBox="1"/>
           <p:nvPr/>
         </p:nvSpPr>
         <p:spPr>
           <a:xfrm>
-            <a:off x="960120" y="1920240"/>
-            <a:ext cx="2834640" cy="4206240"/>
+            <a:off x="4718304" y="2148840"/>
+            <a:ext cx="2743200" cy="3840480"/>
           </a:xfrm>
           <a:prstGeom prst="rect">
             <a:avLst/>
@@ -4798,73 +4931,58 @@
           <a:lstStyle/>
           <a:p>
             <a:pPr>
-              <a:defRPr sz="1400" b="1">
-                <a:solidFill>
-                  <a:srgbClr val="38BDF8"/>
-                </a:solidFill>
-              </a:defRPr>
-            </a:pPr>
-            <a:r>
-              <a:t>[DASHBOARD]  Market Tools &amp; Dashboard</a:t>
+              <a:defRPr sz="1500" b="1">
+                <a:solidFill>
+                  <a:srgbClr val="4ADE80"/>
+                </a:solidFill>
+              </a:defRPr>
+            </a:pPr>
+            <a:r>
+              <a:t>Valuation &amp; Browse</a:t>
             </a:r>
           </a:p>
           <a:p>
             <a:pPr>
               <a:spcBef>
-                <a:spcPts val="600"/>
+                <a:spcPts val="800"/>
               </a:spcBef>
-              <a:defRPr sz="1100">
-                <a:solidFill>
-                  <a:srgbClr val="CBD5E1"/>
-                </a:solidFill>
-              </a:defRPr>
-            </a:pPr>
-            <a:r>
-              <a:t>• Buyer / Seller Switch: One click changes the view to show what buyers care about (returns) or what sellers care about (how much their app is worth).</a:t>
+              <a:defRPr sz="1150">
+                <a:solidFill>
+                  <a:srgbClr val="E2E8F0"/>
+                </a:solidFill>
+              </a:defRPr>
+            </a:pPr>
+            <a:r>
+              <a:t>• Price Calculator: A tool for sellers. You enter your annual revenue, and it calculates your estimated selling price and chance of selling.</a:t>
             </a:r>
           </a:p>
           <a:p>
             <a:pPr>
               <a:spcBef>
-                <a:spcPts val="600"/>
+                <a:spcPts val="800"/>
               </a:spcBef>
-              <a:defRPr sz="1100">
-                <a:solidFill>
-                  <a:srgbClr val="CBD5E1"/>
-                </a:solidFill>
-              </a:defRPr>
-            </a:pPr>
-            <a:r>
-              <a:t>• 4-Box Market Grid: Groups apps into 4 simple buckets (Big apps, Fast growers, Niche tools, Basic utilities). Clicking any box filters the apps.</a:t>
-            </a:r>
-          </a:p>
-          <a:p>
-            <a:pPr>
-              <a:spcBef>
-                <a:spcPts val="600"/>
-              </a:spcBef>
-              <a:defRPr sz="1100">
-                <a:solidFill>
-                  <a:srgbClr val="CBD5E1"/>
-                </a:solidFill>
-              </a:defRPr>
-            </a:pPr>
-            <a:r>
-              <a:t>• Supply &amp; Demand Graph: Shows which software categories have the most buyers waiting.</a:t>
-            </a:r>
-          </a:p>
-        </p:txBody>
-      </p:sp>
-      <p:sp>
-        <p:nvSpPr>
-          <p:cNvPr id="7" name="Rounded Rectangle 6"/>
+              <a:defRPr sz="1150">
+                <a:solidFill>
+                  <a:srgbClr val="E2E8F0"/>
+                </a:solidFill>
+              </a:defRPr>
+            </a:pPr>
+            <a:r>
+              <a:t>• Browse Marketplace: Search and filter companies by sector (AI, SaaS, FinTech, DevTools) with real monthly earnings, profit, and tech stack shown.</a:t>
+            </a:r>
+          </a:p>
+        </p:txBody>
+      </p:sp>
+      <p:sp>
+        <p:nvSpPr>
+          <p:cNvPr id="10" name="Rounded Rectangle 9"/>
           <p:cNvSpPr/>
           <p:nvPr/>
         </p:nvSpPr>
         <p:spPr>
           <a:xfrm>
-            <a:off x="4443984" y="1737360"/>
-            <a:ext cx="3291840" cy="4572000"/>
+            <a:off x="8074152" y="1920240"/>
+            <a:ext cx="3291840" cy="4297680"/>
           </a:xfrm>
           <a:prstGeom prst="roundRect">
             <a:avLst/>
@@ -4902,14 +5020,14 @@
       </p:sp>
       <p:sp>
         <p:nvSpPr>
-          <p:cNvPr id="8" name="TextBox 7"/>
+          <p:cNvPr id="11" name="TextBox 10"/>
           <p:cNvSpPr txBox="1"/>
           <p:nvPr/>
         </p:nvSpPr>
         <p:spPr>
           <a:xfrm>
-            <a:off x="4672584" y="1920240"/>
-            <a:ext cx="2834640" cy="4206240"/>
+            <a:off x="8348472" y="2148840"/>
+            <a:ext cx="2743200" cy="3840480"/>
           </a:xfrm>
           <a:prstGeom prst="rect">
             <a:avLst/>
@@ -4923,169 +5041,59 @@
           <a:lstStyle/>
           <a:p>
             <a:pPr>
-              <a:defRPr sz="1400" b="1">
-                <a:solidFill>
-                  <a:srgbClr val="4ADE80"/>
-                </a:solidFill>
-              </a:defRPr>
-            </a:pPr>
-            <a:r>
-              <a:t>[BUY &amp; SELL]  Valuation &amp; Marketplace</a:t>
+              <a:defRPr sz="1500" b="1">
+                <a:solidFill>
+                  <a:srgbClr val="FBBF24"/>
+                </a:solidFill>
+              </a:defRPr>
+            </a:pPr>
+            <a:r>
+              <a:t>Diligence &amp; Pricing</a:t>
             </a:r>
           </a:p>
           <a:p>
             <a:pPr>
               <a:spcBef>
-                <a:spcPts val="600"/>
+                <a:spcPts val="800"/>
               </a:spcBef>
-              <a:defRPr sz="1100">
-                <a:solidFill>
-                  <a:srgbClr val="CBD5E1"/>
-                </a:solidFill>
-              </a:defRPr>
-            </a:pPr>
-            <a:r>
-              <a:t>• Price Calculator: A tool for sellers. You type in your revenue, and it instantly tells you what your app is worth and your chances of selling.</a:t>
+              <a:defRPr sz="1150">
+                <a:solidFill>
+                  <a:srgbClr val="E2E8F0"/>
+                </a:solidFill>
+              </a:defRPr>
+            </a:pPr>
+            <a:r>
+              <a:t>• Virtual Data Room (VDR): A locked room where buyers can view private tax files and code stats after signing a digital NDA.</a:t>
             </a:r>
           </a:p>
           <a:p>
             <a:pPr>
               <a:spcBef>
-                <a:spcPts val="600"/>
+                <a:spcPts val="800"/>
               </a:spcBef>
-              <a:defRPr sz="1100">
-                <a:solidFill>
-                  <a:srgbClr val="CBD5E1"/>
-                </a:solidFill>
-              </a:defRPr>
-            </a:pPr>
-            <a:r>
-              <a:t>• Browse Marketplace: Search and filter apps by category (AI, Finance, Health) with real monthly earnings, profit, and programming languages shown clearly.</a:t>
-            </a:r>
-          </a:p>
-        </p:txBody>
-      </p:sp>
-      <p:sp>
-        <p:nvSpPr>
-          <p:cNvPr id="9" name="Rounded Rectangle 8"/>
-          <p:cNvSpPr/>
-          <p:nvPr/>
-        </p:nvSpPr>
-        <p:spPr>
-          <a:xfrm>
-            <a:off x="8165592" y="1737360"/>
-            <a:ext cx="3291840" cy="4572000"/>
-          </a:xfrm>
-          <a:prstGeom prst="roundRect">
-            <a:avLst/>
-          </a:prstGeom>
-          <a:solidFill>
-            <a:srgbClr val="1E293B"/>
-          </a:solidFill>
-          <a:ln w="15240">
-            <a:solidFill>
-              <a:srgbClr val="334155"/>
-            </a:solidFill>
-          </a:ln>
-        </p:spPr>
-        <p:style>
-          <a:lnRef idx="1">
-            <a:schemeClr val="accent1"/>
-          </a:lnRef>
-          <a:fillRef idx="3">
-            <a:schemeClr val="accent1"/>
-          </a:fillRef>
-          <a:effectRef idx="2">
-            <a:schemeClr val="accent1"/>
-          </a:effectRef>
-          <a:fontRef idx="minor">
-            <a:schemeClr val="lt1"/>
-          </a:fontRef>
-        </p:style>
-        <p:txBody>
-          <a:bodyPr rtlCol="0" anchor="ctr"/>
-          <a:lstStyle/>
-          <a:p>
-            <a:pPr algn="ctr"/>
-          </a:p>
-        </p:txBody>
-      </p:sp>
-      <p:sp>
-        <p:nvSpPr>
-          <p:cNvPr id="10" name="TextBox 9"/>
-          <p:cNvSpPr txBox="1"/>
-          <p:nvPr/>
-        </p:nvSpPr>
-        <p:spPr>
-          <a:xfrm>
-            <a:off x="8394192" y="1920240"/>
-            <a:ext cx="2834640" cy="4206240"/>
-          </a:xfrm>
-          <a:prstGeom prst="rect">
-            <a:avLst/>
-          </a:prstGeom>
-          <a:noFill/>
-        </p:spPr>
-        <p:txBody>
-          <a:bodyPr wrap="square">
-            <a:spAutoFit/>
-          </a:bodyPr>
-          <a:lstStyle/>
-          <a:p>
-            <a:pPr>
-              <a:defRPr sz="1400" b="1">
-                <a:solidFill>
-                  <a:srgbClr val="FBBF24"/>
-                </a:solidFill>
-              </a:defRPr>
-            </a:pPr>
-            <a:r>
-              <a:t>[DEAL ROOM]  Private Room &amp; Calculator</a:t>
+              <a:defRPr sz="1150">
+                <a:solidFill>
+                  <a:srgbClr val="E2E8F0"/>
+                </a:solidFill>
+              </a:defRPr>
+            </a:pPr>
+            <a:r>
+              <a:t>• Video Diligence Console: An embedded video player where the founder walks through the code architecture.</a:t>
             </a:r>
           </a:p>
           <a:p>
             <a:pPr>
               <a:spcBef>
-                <a:spcPts val="600"/>
+                <a:spcPts val="800"/>
               </a:spcBef>
-              <a:defRPr sz="1100">
-                <a:solidFill>
-                  <a:srgbClr val="CBD5E1"/>
-                </a:solidFill>
-              </a:defRPr>
-            </a:pPr>
-            <a:r>
-              <a:t>• Private Diligence Room: A locked room where buyers can view private tax files and code stats after signing an agreement.</a:t>
-            </a:r>
-          </a:p>
-          <a:p>
-            <a:pPr>
-              <a:spcBef>
-                <a:spcPts val="600"/>
-              </a:spcBef>
-              <a:defRPr sz="1100">
-                <a:solidFill>
-                  <a:srgbClr val="CBD5E1"/>
-                </a:solidFill>
-              </a:defRPr>
-            </a:pPr>
-            <a:r>
-              <a:t>• Code Walkthrough Video: A video screen where the creator explains how the code works.</a:t>
-            </a:r>
-          </a:p>
-          <a:p>
-            <a:pPr>
-              <a:spcBef>
-                <a:spcPts val="600"/>
-              </a:spcBef>
-              <a:defRPr sz="1100">
-                <a:solidFill>
-                  <a:srgbClr val="CBD5E1"/>
-                </a:solidFill>
-              </a:defRPr>
-            </a:pPr>
-            <a:r>
-              <a:t>• Fee Calculator: A slider showing exactly how many thousands of dollars you save compared to traditional brokers.</a:t>
+              <a:defRPr sz="1150">
+                <a:solidFill>
+                  <a:srgbClr val="E2E8F0"/>
+                </a:solidFill>
+              </a:defRPr>
+            </a:pPr>
+            <a:r>
+              <a:t>• Fee Calculator: A slider showing exact dollar savings compared to traditional 10%–15% brokers.</a:t>
             </a:r>
           </a:p>
         </p:txBody>
@@ -5153,14 +5161,119 @@
       </p:sp>
       <p:sp>
         <p:nvSpPr>
-          <p:cNvPr id="3" name="Rounded Rectangle 2"/>
+          <p:cNvPr id="3" name="TextBox 2"/>
+          <p:cNvSpPr txBox="1"/>
+          <p:nvPr/>
+        </p:nvSpPr>
+        <p:spPr>
+          <a:xfrm>
+            <a:off x="822960" y="502920"/>
+            <a:ext cx="4572000" cy="320040"/>
+          </a:xfrm>
+          <a:prstGeom prst="rect">
+            <a:avLst/>
+          </a:prstGeom>
+          <a:noFill/>
+        </p:spPr>
+        <p:txBody>
+          <a:bodyPr wrap="none">
+            <a:spAutoFit/>
+          </a:bodyPr>
+          <a:lstStyle/>
+          <a:p>
+            <a:pPr>
+              <a:defRPr sz="1000" b="1">
+                <a:solidFill>
+                  <a:srgbClr val="38BDF8"/>
+                </a:solidFill>
+              </a:defRPr>
+            </a:pPr>
+            <a:r>
+              <a:t>SLIDE 03 · VVENTRA OVERVIEW</a:t>
+            </a:r>
+          </a:p>
+        </p:txBody>
+      </p:sp>
+      <p:sp>
+        <p:nvSpPr>
+          <p:cNvPr id="4" name="TextBox 3"/>
+          <p:cNvSpPr txBox="1"/>
+          <p:nvPr/>
+        </p:nvSpPr>
+        <p:spPr>
+          <a:xfrm>
+            <a:off x="822960" y="777240"/>
+            <a:ext cx="10515600" cy="594360"/>
+          </a:xfrm>
+          <a:prstGeom prst="rect">
+            <a:avLst/>
+          </a:prstGeom>
+          <a:noFill/>
+        </p:spPr>
+        <p:txBody>
+          <a:bodyPr wrap="none">
+            <a:spAutoFit/>
+          </a:bodyPr>
+          <a:lstStyle/>
+          <a:p>
+            <a:pPr>
+              <a:defRPr sz="2400" b="1">
+                <a:solidFill>
+                  <a:srgbClr val="FFFFFF"/>
+                </a:solidFill>
+              </a:defRPr>
+            </a:pPr>
+            <a:r>
+              <a:t>The Technology Stack Used</a:t>
+            </a:r>
+          </a:p>
+        </p:txBody>
+      </p:sp>
+      <p:sp>
+        <p:nvSpPr>
+          <p:cNvPr id="5" name="TextBox 4"/>
+          <p:cNvSpPr txBox="1"/>
+          <p:nvPr/>
+        </p:nvSpPr>
+        <p:spPr>
+          <a:xfrm>
+            <a:off x="822960" y="1325880"/>
+            <a:ext cx="10515600" cy="411480"/>
+          </a:xfrm>
+          <a:prstGeom prst="rect">
+            <a:avLst/>
+          </a:prstGeom>
+          <a:noFill/>
+        </p:spPr>
+        <p:txBody>
+          <a:bodyPr wrap="none">
+            <a:spAutoFit/>
+          </a:bodyPr>
+          <a:lstStyle/>
+          <a:p>
+            <a:pPr>
+              <a:defRPr sz="1200">
+                <a:solidFill>
+                  <a:srgbClr val="94A3B8"/>
+                </a:solidFill>
+              </a:defRPr>
+            </a:pPr>
+            <a:r>
+              <a:t>Built with clean web standards, zero extra libraries, and AI-agent readiness.</a:t>
+            </a:r>
+          </a:p>
+        </p:txBody>
+      </p:sp>
+      <p:sp>
+        <p:nvSpPr>
+          <p:cNvPr id="6" name="Rounded Rectangle 5"/>
           <p:cNvSpPr/>
           <p:nvPr/>
         </p:nvSpPr>
         <p:spPr>
           <a:xfrm>
-            <a:off x="731520" y="457200"/>
-            <a:ext cx="2011680" cy="320040"/>
+            <a:off x="822960" y="1920240"/>
+            <a:ext cx="5212080" cy="4297680"/>
           </a:xfrm>
           <a:prstGeom prst="roundRect">
             <a:avLst/>
@@ -5168,7 +5281,7 @@
           <a:solidFill>
             <a:srgbClr val="1E293B"/>
           </a:solidFill>
-          <a:ln w="12700">
+          <a:ln w="15240">
             <a:solidFill>
               <a:srgbClr val="334155"/>
             </a:solidFill>
@@ -5192,29 +5305,20 @@
           <a:bodyPr rtlCol="0" anchor="ctr"/>
           <a:lstStyle/>
           <a:p>
-            <a:pPr algn="ctr">
-              <a:defRPr sz="900" b="1">
-                <a:solidFill>
-                  <a:srgbClr val="38BDF8"/>
-                </a:solidFill>
-              </a:defRPr>
-            </a:pPr>
-            <a:r>
-              <a:t>3. TECHNOLOGY</a:t>
-            </a:r>
-          </a:p>
-        </p:txBody>
-      </p:sp>
-      <p:sp>
-        <p:nvSpPr>
-          <p:cNvPr id="4" name="TextBox 3"/>
+            <a:pPr algn="ctr"/>
+          </a:p>
+        </p:txBody>
+      </p:sp>
+      <p:sp>
+        <p:nvSpPr>
+          <p:cNvPr id="7" name="TextBox 6"/>
           <p:cNvSpPr txBox="1"/>
           <p:nvPr/>
         </p:nvSpPr>
         <p:spPr>
           <a:xfrm>
-            <a:off x="731520" y="822960"/>
-            <a:ext cx="10698480" cy="731520"/>
+            <a:off x="1097280" y="2148840"/>
+            <a:ext cx="4663440" cy="3840480"/>
           </a:xfrm>
           <a:prstGeom prst="rect">
             <a:avLst/>
@@ -5228,40 +5332,88 @@
           <a:lstStyle/>
           <a:p>
             <a:pPr>
-              <a:defRPr sz="2200" b="1">
-                <a:solidFill>
-                  <a:srgbClr val="FFFFFF"/>
-                </a:solidFill>
-              </a:defRPr>
-            </a:pPr>
-            <a:r>
-              <a:t>The Tech Stack &amp; How AI Agents Can Be Added</a:t>
-            </a:r>
-          </a:p>
-          <a:p>
-            <a:pPr>
-              <a:defRPr sz="1100">
-                <a:solidFill>
-                  <a:srgbClr val="CBD5E1"/>
-                </a:solidFill>
-              </a:defRPr>
-            </a:pPr>
-            <a:r>
-              <a:t>Simple code that makes the site fast and easy for AI to work with.</a:t>
-            </a:r>
-          </a:p>
-        </p:txBody>
-      </p:sp>
-      <p:sp>
-        <p:nvSpPr>
-          <p:cNvPr id="5" name="Rounded Rectangle 4"/>
+              <a:defRPr sz="1500" b="1">
+                <a:solidFill>
+                  <a:srgbClr val="38BDF8"/>
+                </a:solidFill>
+              </a:defRPr>
+            </a:pPr>
+            <a:r>
+              <a:t>Tech Stack Used in the Project</a:t>
+            </a:r>
+          </a:p>
+          <a:p>
+            <a:pPr>
+              <a:spcBef>
+                <a:spcPts val="800"/>
+              </a:spcBef>
+              <a:defRPr sz="1150">
+                <a:solidFill>
+                  <a:srgbClr val="E2E8F0"/>
+                </a:solidFill>
+              </a:defRPr>
+            </a:pPr>
+            <a:r>
+              <a:t>• HTML5: Semantic, accessible page structure powering an 8-view Single Page Application (SPA).</a:t>
+            </a:r>
+          </a:p>
+          <a:p>
+            <a:pPr>
+              <a:spcBef>
+                <a:spcPts val="800"/>
+              </a:spcBef>
+              <a:defRPr sz="1150">
+                <a:solidFill>
+                  <a:srgbClr val="E2E8F0"/>
+                </a:solidFill>
+              </a:defRPr>
+            </a:pPr>
+            <a:r>
+              <a:t>• CSS3: Strict BEM architecture with native CSS custom properties for instant role and theme switching (no Tailwind/Bootstrap bloat).</a:t>
+            </a:r>
+          </a:p>
+          <a:p>
+            <a:pPr>
+              <a:spcBef>
+                <a:spcPts val="800"/>
+              </a:spcBef>
+              <a:defRPr sz="1150">
+                <a:solidFill>
+                  <a:srgbClr val="E2E8F0"/>
+                </a:solidFill>
+              </a:defRPr>
+            </a:pPr>
+            <a:r>
+              <a:t>• Vanilla JavaScript (ES6+): Pure JavaScript for client-side routing, state management, and mathematical SVG chart drawing. Zero npm packages, zero React, and zero build steps.</a:t>
+            </a:r>
+          </a:p>
+          <a:p>
+            <a:pPr>
+              <a:spcBef>
+                <a:spcPts val="800"/>
+              </a:spcBef>
+              <a:defRPr sz="1150">
+                <a:solidFill>
+                  <a:srgbClr val="E2E8F0"/>
+                </a:solidFill>
+              </a:defRPr>
+            </a:pPr>
+            <a:r>
+              <a:t>• Git &amp; GitHub Pages: Version-controlled on GitHub and deployed globally with sub-120ms load speeds.</a:t>
+            </a:r>
+          </a:p>
+        </p:txBody>
+      </p:sp>
+      <p:sp>
+        <p:nvSpPr>
+          <p:cNvPr id="8" name="Rounded Rectangle 7"/>
           <p:cNvSpPr/>
           <p:nvPr/>
         </p:nvSpPr>
         <p:spPr>
           <a:xfrm>
-            <a:off x="731520" y="1737360"/>
-            <a:ext cx="5212080" cy="4572000"/>
+            <a:off x="6309360" y="1920240"/>
+            <a:ext cx="5029200" cy="4297680"/>
           </a:xfrm>
           <a:prstGeom prst="roundRect">
             <a:avLst/>
@@ -5299,14 +5451,14 @@
       </p:sp>
       <p:sp>
         <p:nvSpPr>
-          <p:cNvPr id="6" name="TextBox 5"/>
+          <p:cNvPr id="9" name="TextBox 8"/>
           <p:cNvSpPr txBox="1"/>
           <p:nvPr/>
         </p:nvSpPr>
         <p:spPr>
           <a:xfrm>
-            <a:off x="960120" y="1920240"/>
-            <a:ext cx="4754880" cy="4206240"/>
+            <a:off x="6583680" y="2148840"/>
+            <a:ext cx="4480560" cy="3840480"/>
           </a:xfrm>
           <a:prstGeom prst="rect">
             <a:avLst/>
@@ -5320,244 +5472,104 @@
           <a:lstStyle/>
           <a:p>
             <a:pPr>
-              <a:defRPr sz="1400" b="1">
-                <a:solidFill>
-                  <a:srgbClr val="38BDF8"/>
-                </a:solidFill>
-              </a:defRPr>
-            </a:pPr>
-            <a:r>
-              <a:t>[SIMPLE TECH STACK]  The Tech Stack Used</a:t>
+              <a:defRPr sz="1500" b="1">
+                <a:solidFill>
+                  <a:srgbClr val="4ADE80"/>
+                </a:solidFill>
+              </a:defRPr>
+            </a:pPr>
+            <a:r>
+              <a:t>How AI Agents Can Be Added</a:t>
             </a:r>
           </a:p>
           <a:p>
             <a:pPr>
               <a:spcBef>
-                <a:spcPts val="600"/>
+                <a:spcPts val="800"/>
               </a:spcBef>
-              <a:defRPr sz="1100">
-                <a:solidFill>
-                  <a:srgbClr val="CBD5E1"/>
-                </a:solidFill>
-              </a:defRPr>
-            </a:pPr>
-            <a:r>
-              <a:t>• Pure HTML5 &amp; CSS3: Clean layout and styling using modern CSS variables. No heavy frameworks like Tailwind or Bootstrap.</a:t>
+              <a:defRPr sz="1150">
+                <a:solidFill>
+                  <a:srgbClr val="E2E8F0"/>
+                </a:solidFill>
+              </a:defRPr>
+            </a:pPr>
+            <a:r>
+              <a:t>• Clean Data Layer (data.js): All listings and numbers live in one structured file. AI agents can easily add, audit, and update listings via APIs.</a:t>
             </a:r>
           </a:p>
           <a:p>
             <a:pPr>
               <a:spcBef>
-                <a:spcPts val="600"/>
+                <a:spcPts val="800"/>
               </a:spcBef>
-              <a:defRPr sz="1100">
-                <a:solidFill>
-                  <a:srgbClr val="CBD5E1"/>
-                </a:solidFill>
-              </a:defRPr>
-            </a:pPr>
-            <a:r>
-              <a:t>• Vanilla JavaScript: Pure code for page navigation, search, and charts. Zero npm packages, zero React, and zero build steps.</a:t>
+              <a:defRPr sz="1150">
+                <a:solidFill>
+                  <a:srgbClr val="E2E8F0"/>
+                </a:solidFill>
+              </a:defRPr>
+            </a:pPr>
+            <a:r>
+              <a:t>• No Hidden React Code: Because the HTML is clean and direct, AI browser tools can easily click buttons, search listings, and read text.</a:t>
             </a:r>
           </a:p>
           <a:p>
             <a:pPr>
               <a:spcBef>
-                <a:spcPts val="600"/>
+                <a:spcPts val="800"/>
               </a:spcBef>
-              <a:defRPr sz="1100">
-                <a:solidFill>
-                  <a:srgbClr val="CBD5E1"/>
-                </a:solidFill>
-              </a:defRPr>
-            </a:pPr>
-            <a:r>
-              <a:t>• GitHub Pages Hosting: Free global hosting directly from GitHub. Fast loading in under 120ms with zero server crashes.</a:t>
-            </a:r>
-          </a:p>
-        </p:txBody>
-      </p:sp>
-      <p:sp>
-        <p:nvSpPr>
-          <p:cNvPr id="7" name="Rounded Rectangle 6"/>
-          <p:cNvSpPr/>
-          <p:nvPr/>
-        </p:nvSpPr>
-        <p:spPr>
-          <a:xfrm>
-            <a:off x="6217920" y="1737360"/>
-            <a:ext cx="5212080" cy="4572000"/>
-          </a:xfrm>
-          <a:prstGeom prst="roundRect">
-            <a:avLst/>
-          </a:prstGeom>
-          <a:solidFill>
-            <a:srgbClr val="1E293B"/>
-          </a:solidFill>
-          <a:ln w="15240">
-            <a:solidFill>
-              <a:srgbClr val="334155"/>
-            </a:solidFill>
-          </a:ln>
-        </p:spPr>
-        <p:style>
-          <a:lnRef idx="1">
-            <a:schemeClr val="accent1"/>
-          </a:lnRef>
-          <a:fillRef idx="3">
-            <a:schemeClr val="accent1"/>
-          </a:fillRef>
-          <a:effectRef idx="2">
-            <a:schemeClr val="accent1"/>
-          </a:effectRef>
-          <a:fontRef idx="minor">
-            <a:schemeClr val="lt1"/>
-          </a:fontRef>
-        </p:style>
-        <p:txBody>
-          <a:bodyPr rtlCol="0" anchor="ctr"/>
-          <a:lstStyle/>
-          <a:p>
-            <a:pPr algn="ctr"/>
-          </a:p>
-        </p:txBody>
-      </p:sp>
-      <p:sp>
-        <p:nvSpPr>
-          <p:cNvPr id="8" name="TextBox 7"/>
-          <p:cNvSpPr txBox="1"/>
-          <p:nvPr/>
-        </p:nvSpPr>
-        <p:spPr>
-          <a:xfrm>
-            <a:off x="6446520" y="1920240"/>
-            <a:ext cx="4754880" cy="4206240"/>
-          </a:xfrm>
-          <a:prstGeom prst="rect">
-            <a:avLst/>
-          </a:prstGeom>
-          <a:noFill/>
-        </p:spPr>
-        <p:txBody>
-          <a:bodyPr wrap="square">
-            <a:spAutoFit/>
-          </a:bodyPr>
-          <a:lstStyle/>
-          <a:p>
-            <a:pPr>
-              <a:defRPr sz="1400" b="1">
-                <a:solidFill>
-                  <a:srgbClr val="4ADE80"/>
-                </a:solidFill>
-              </a:defRPr>
-            </a:pPr>
-            <a:r>
-              <a:t>[ADDING AI AGENTS]  How It Helps Us Add AI Agents</a:t>
+              <a:defRPr sz="1150">
+                <a:solidFill>
+                  <a:srgbClr val="E2E8F0"/>
+                </a:solidFill>
+              </a:defRPr>
+            </a:pPr>
+            <a:r>
+              <a:t>• AI Agents We Can Add Easily:</a:t>
             </a:r>
           </a:p>
           <a:p>
             <a:pPr>
               <a:spcBef>
-                <a:spcPts val="600"/>
+                <a:spcPts val="800"/>
               </a:spcBef>
-              <a:defRPr sz="1100">
-                <a:solidFill>
-                  <a:srgbClr val="CBD5E1"/>
-                </a:solidFill>
-              </a:defRPr>
-            </a:pPr>
-            <a:r>
-              <a:t>• Single Data File (data.js): All listings and numbers live in one clean file. AI agents can easily read and add new listings without breaking UI code.</a:t>
+              <a:defRPr sz="1150">
+                <a:solidFill>
+                  <a:srgbClr val="E2E8F0"/>
+                </a:solidFill>
+              </a:defRPr>
+            </a:pPr>
+            <a:r>
+              <a:t>•   • Code Audit AI: Automatically scans GitHub repos and outputs a code safety score.</a:t>
             </a:r>
           </a:p>
           <a:p>
             <a:pPr>
               <a:spcBef>
-                <a:spcPts val="600"/>
+                <a:spcPts val="800"/>
               </a:spcBef>
-              <a:defRPr sz="1100">
-                <a:solidFill>
-                  <a:srgbClr val="CBD5E1"/>
-                </a:solidFill>
-              </a:defRPr>
-            </a:pPr>
-            <a:r>
-              <a:t>• No Hidden React Code: Because the HTML is clean and direct, AI browser tools can easily click buttons, search listings, and read text.</a:t>
+              <a:defRPr sz="1150">
+                <a:solidFill>
+                  <a:srgbClr val="E2E8F0"/>
+                </a:solidFill>
+              </a:defRPr>
+            </a:pPr>
+            <a:r>
+              <a:t>•   • Valuation AI: Checks recent sales and updates price estimates automatically.</a:t>
             </a:r>
           </a:p>
           <a:p>
             <a:pPr>
               <a:spcBef>
-                <a:spcPts val="600"/>
+                <a:spcPts val="800"/>
               </a:spcBef>
-              <a:defRPr sz="1100">
-                <a:solidFill>
-                  <a:srgbClr val="CBD5E1"/>
-                </a:solidFill>
-              </a:defRPr>
-            </a:pPr>
-            <a:r>
-              <a:t>• AI Agents We Can Add Easily:</a:t>
-            </a:r>
-          </a:p>
-          <a:p>
-            <a:pPr>
-              <a:spcBef>
-                <a:spcPts val="600"/>
-              </a:spcBef>
-              <a:defRPr sz="1100">
-                <a:solidFill>
-                  <a:srgbClr val="CBD5E1"/>
-                </a:solidFill>
-              </a:defRPr>
-            </a:pPr>
-            <a:r>
-              <a:t>•   1. Code Audit AI: Automatically scans GitHub repos and gives a code safety score.</a:t>
-            </a:r>
-          </a:p>
-          <a:p>
-            <a:pPr>
-              <a:spcBef>
-                <a:spcPts val="600"/>
-              </a:spcBef>
-              <a:defRPr sz="1100">
-                <a:solidFill>
-                  <a:srgbClr val="CBD5E1"/>
-                </a:solidFill>
-              </a:defRPr>
-            </a:pPr>
-            <a:r>
-              <a:t>•   2. Price AI: Checks recent sales and updates valuations automatically.</a:t>
-            </a:r>
-          </a:p>
-          <a:p>
-            <a:pPr>
-              <a:spcBef>
-                <a:spcPts val="600"/>
-              </a:spcBef>
-              <a:defRPr sz="1100">
-                <a:solidFill>
-                  <a:srgbClr val="CBD5E1"/>
-                </a:solidFill>
-              </a:defRPr>
-            </a:pPr>
-            <a:r>
-              <a:t>•   3. Q&amp;A AI Chatbot: Sits inside the private deal room to answer buyers' questions about the software.</a:t>
-            </a:r>
-          </a:p>
-          <a:p>
-            <a:pPr>
-              <a:spcBef>
-                <a:spcPts val="600"/>
-              </a:spcBef>
-              <a:defRPr sz="1100">
-                <a:solidFill>
-                  <a:srgbClr val="CBD5E1"/>
-                </a:solidFill>
-              </a:defRPr>
-            </a:pPr>
-            <a:r>
-              <a:t>•   4. Handover AI: Checks that domains and passwords are moved correctly before money is sent.</a:t>
+              <a:defRPr sz="1150">
+                <a:solidFill>
+                  <a:srgbClr val="E2E8F0"/>
+                </a:solidFill>
+              </a:defRPr>
+            </a:pPr>
+            <a:r>
+              <a:t>•   • Q&amp;A Chatbot AI: Answers buyers' questions inside the private data room.</a:t>
             </a:r>
           </a:p>
         </p:txBody>
@@ -5625,14 +5637,119 @@
       </p:sp>
       <p:sp>
         <p:nvSpPr>
-          <p:cNvPr id="3" name="Rounded Rectangle 2"/>
+          <p:cNvPr id="3" name="TextBox 2"/>
+          <p:cNvSpPr txBox="1"/>
+          <p:nvPr/>
+        </p:nvSpPr>
+        <p:spPr>
+          <a:xfrm>
+            <a:off x="822960" y="502920"/>
+            <a:ext cx="4572000" cy="320040"/>
+          </a:xfrm>
+          <a:prstGeom prst="rect">
+            <a:avLst/>
+          </a:prstGeom>
+          <a:noFill/>
+        </p:spPr>
+        <p:txBody>
+          <a:bodyPr wrap="none">
+            <a:spAutoFit/>
+          </a:bodyPr>
+          <a:lstStyle/>
+          <a:p>
+            <a:pPr>
+              <a:defRPr sz="1000" b="1">
+                <a:solidFill>
+                  <a:srgbClr val="38BDF8"/>
+                </a:solidFill>
+              </a:defRPr>
+            </a:pPr>
+            <a:r>
+              <a:t>SLIDE 04 · VVENTRA OVERVIEW</a:t>
+            </a:r>
+          </a:p>
+        </p:txBody>
+      </p:sp>
+      <p:sp>
+        <p:nvSpPr>
+          <p:cNvPr id="4" name="TextBox 3"/>
+          <p:cNvSpPr txBox="1"/>
+          <p:nvPr/>
+        </p:nvSpPr>
+        <p:spPr>
+          <a:xfrm>
+            <a:off x="822960" y="777240"/>
+            <a:ext cx="10515600" cy="594360"/>
+          </a:xfrm>
+          <a:prstGeom prst="rect">
+            <a:avLst/>
+          </a:prstGeom>
+          <a:noFill/>
+        </p:spPr>
+        <p:txBody>
+          <a:bodyPr wrap="none">
+            <a:spAutoFit/>
+          </a:bodyPr>
+          <a:lstStyle/>
+          <a:p>
+            <a:pPr>
+              <a:defRPr sz="2400" b="1">
+                <a:solidFill>
+                  <a:srgbClr val="FFFFFF"/>
+                </a:solidFill>
+              </a:defRPr>
+            </a:pPr>
+            <a:r>
+              <a:t>Our Innovation: The Atomic Handover Protocol™</a:t>
+            </a:r>
+          </a:p>
+        </p:txBody>
+      </p:sp>
+      <p:sp>
+        <p:nvSpPr>
+          <p:cNvPr id="5" name="TextBox 4"/>
+          <p:cNvSpPr txBox="1"/>
+          <p:nvPr/>
+        </p:nvSpPr>
+        <p:spPr>
+          <a:xfrm>
+            <a:off x="822960" y="1325880"/>
+            <a:ext cx="10515600" cy="411480"/>
+          </a:xfrm>
+          <a:prstGeom prst="rect">
+            <a:avLst/>
+          </a:prstGeom>
+          <a:noFill/>
+        </p:spPr>
+        <p:txBody>
+          <a:bodyPr wrap="none">
+            <a:spAutoFit/>
+          </a:bodyPr>
+          <a:lstStyle/>
+          <a:p>
+            <a:pPr>
+              <a:defRPr sz="1200">
+                <a:solidFill>
+                  <a:srgbClr val="94A3B8"/>
+                </a:solidFill>
+              </a:defRPr>
+            </a:pPr>
+            <a:r>
+              <a:t>A safe 4-step escrow transfer that eliminates code theft and payment risk.</a:t>
+            </a:r>
+          </a:p>
+        </p:txBody>
+      </p:sp>
+      <p:sp>
+        <p:nvSpPr>
+          <p:cNvPr id="6" name="Rounded Rectangle 5"/>
           <p:cNvSpPr/>
           <p:nvPr/>
         </p:nvSpPr>
         <p:spPr>
           <a:xfrm>
-            <a:off x="731520" y="457200"/>
-            <a:ext cx="2011680" cy="320040"/>
+            <a:off x="822960" y="1920240"/>
+            <a:ext cx="5212080" cy="4297680"/>
           </a:xfrm>
           <a:prstGeom prst="roundRect">
             <a:avLst/>
@@ -5640,7 +5757,7 @@
           <a:solidFill>
             <a:srgbClr val="1E293B"/>
           </a:solidFill>
-          <a:ln w="12700">
+          <a:ln w="15240">
             <a:solidFill>
               <a:srgbClr val="334155"/>
             </a:solidFill>
@@ -5664,29 +5781,20 @@
           <a:bodyPr rtlCol="0" anchor="ctr"/>
           <a:lstStyle/>
           <a:p>
-            <a:pPr algn="ctr">
-              <a:defRPr sz="900" b="1">
-                <a:solidFill>
-                  <a:srgbClr val="38BDF8"/>
-                </a:solidFill>
-              </a:defRPr>
-            </a:pPr>
-            <a:r>
-              <a:t>4. INNOVATION</a:t>
-            </a:r>
-          </a:p>
-        </p:txBody>
-      </p:sp>
-      <p:sp>
-        <p:nvSpPr>
-          <p:cNvPr id="4" name="TextBox 3"/>
+            <a:pPr algn="ctr"/>
+          </a:p>
+        </p:txBody>
+      </p:sp>
+      <p:sp>
+        <p:nvSpPr>
+          <p:cNvPr id="7" name="TextBox 6"/>
           <p:cNvSpPr txBox="1"/>
           <p:nvPr/>
         </p:nvSpPr>
         <p:spPr>
           <a:xfrm>
-            <a:off x="731520" y="822960"/>
-            <a:ext cx="10698480" cy="731520"/>
+            <a:off x="1097280" y="2148840"/>
+            <a:ext cx="4663440" cy="3840480"/>
           </a:xfrm>
           <a:prstGeom prst="rect">
             <a:avLst/>
@@ -5700,40 +5808,73 @@
           <a:lstStyle/>
           <a:p>
             <a:pPr>
-              <a:defRPr sz="2200" b="1">
-                <a:solidFill>
-                  <a:srgbClr val="FFFFFF"/>
-                </a:solidFill>
-              </a:defRPr>
-            </a:pPr>
-            <a:r>
-              <a:t>Innovation Added (Compared to Original Website)</a:t>
-            </a:r>
-          </a:p>
-          <a:p>
-            <a:pPr>
-              <a:defRPr sz="1100">
-                <a:solidFill>
-                  <a:srgbClr val="CBD5E1"/>
-                </a:solidFill>
-              </a:defRPr>
-            </a:pPr>
-            <a:r>
-              <a:t>How our site is safer and more functional than the reference site.</a:t>
-            </a:r>
-          </a:p>
-        </p:txBody>
-      </p:sp>
-      <p:sp>
-        <p:nvSpPr>
-          <p:cNvPr id="5" name="Rounded Rectangle 4"/>
+              <a:defRPr sz="1500" b="1">
+                <a:solidFill>
+                  <a:srgbClr val="FBBF24"/>
+                </a:solidFill>
+              </a:defRPr>
+            </a:pPr>
+            <a:r>
+              <a:t>The Problem in the Original Website</a:t>
+            </a:r>
+          </a:p>
+          <a:p>
+            <a:pPr>
+              <a:spcBef>
+                <a:spcPts val="800"/>
+              </a:spcBef>
+              <a:defRPr sz="1150">
+                <a:solidFill>
+                  <a:srgbClr val="E2E8F0"/>
+                </a:solidFill>
+              </a:defRPr>
+            </a:pPr>
+            <a:r>
+              <a:t>• Flashy Graphics Over Substance: Used heavy neon purple colors and glows that looked like a video game or crypto token.</a:t>
+            </a:r>
+          </a:p>
+          <a:p>
+            <a:pPr>
+              <a:spcBef>
+                <a:spcPts val="800"/>
+              </a:spcBef>
+              <a:defRPr sz="1150">
+                <a:solidFill>
+                  <a:srgbClr val="E2E8F0"/>
+                </a:solidFill>
+              </a:defRPr>
+            </a:pPr>
+            <a:r>
+              <a:t>• Buttons Did Not Work: Many cards and charts were just pictures that you could not click or interact with.</a:t>
+            </a:r>
+          </a:p>
+          <a:p>
+            <a:pPr>
+              <a:spcBef>
+                <a:spcPts val="800"/>
+              </a:spcBef>
+              <a:defRPr sz="1150">
+                <a:solidFill>
+                  <a:srgbClr val="E2E8F0"/>
+                </a:solidFill>
+              </a:defRPr>
+            </a:pPr>
+            <a:r>
+              <a:t>• No Safe Transfer Method: Only had a basic 'Buy' button, with no answer to how code or money is actually protected.</a:t>
+            </a:r>
+          </a:p>
+        </p:txBody>
+      </p:sp>
+      <p:sp>
+        <p:nvSpPr>
+          <p:cNvPr id="8" name="Rounded Rectangle 7"/>
           <p:cNvSpPr/>
           <p:nvPr/>
         </p:nvSpPr>
         <p:spPr>
           <a:xfrm>
-            <a:off x="731520" y="1737360"/>
-            <a:ext cx="5212080" cy="4572000"/>
+            <a:off x="6309360" y="1920240"/>
+            <a:ext cx="5029200" cy="4297680"/>
           </a:xfrm>
           <a:prstGeom prst="roundRect">
             <a:avLst/>
@@ -5771,14 +5912,14 @@
       </p:sp>
       <p:sp>
         <p:nvSpPr>
-          <p:cNvPr id="6" name="TextBox 5"/>
+          <p:cNvPr id="9" name="TextBox 8"/>
           <p:cNvSpPr txBox="1"/>
           <p:nvPr/>
         </p:nvSpPr>
         <p:spPr>
           <a:xfrm>
-            <a:off x="960120" y="1920240"/>
-            <a:ext cx="4754880" cy="4206240"/>
+            <a:off x="6583680" y="2148840"/>
+            <a:ext cx="4480560" cy="3840480"/>
           </a:xfrm>
           <a:prstGeom prst="rect">
             <a:avLst/>
@@ -5792,244 +5933,89 @@
           <a:lstStyle/>
           <a:p>
             <a:pPr>
-              <a:defRPr sz="1400" b="1">
-                <a:solidFill>
-                  <a:srgbClr val="FBBF24"/>
-                </a:solidFill>
-              </a:defRPr>
-            </a:pPr>
-            <a:r>
-              <a:t>[ORIGINAL SITE]  The Original Website (vventrabyaj)</a:t>
+              <a:defRPr sz="1500" b="1">
+                <a:solidFill>
+                  <a:srgbClr val="4ADE80"/>
+                </a:solidFill>
+              </a:defRPr>
+            </a:pPr>
+            <a:r>
+              <a:t>Our Safe 4-Step Handover Protocol</a:t>
             </a:r>
           </a:p>
           <a:p>
             <a:pPr>
               <a:spcBef>
-                <a:spcPts val="600"/>
+                <a:spcPts val="800"/>
               </a:spcBef>
-              <a:defRPr sz="1100">
-                <a:solidFill>
-                  <a:srgbClr val="CBD5E1"/>
-                </a:solidFill>
-              </a:defRPr>
-            </a:pPr>
-            <a:r>
-              <a:t>• Flashy Graphics Over Substance: Used heavy neon purple colors and glows that looked like a video game or crypto token.</a:t>
+              <a:defRPr sz="1150">
+                <a:solidFill>
+                  <a:srgbClr val="E2E8F0"/>
+                </a:solidFill>
+              </a:defRPr>
+            </a:pPr>
+            <a:r>
+              <a:t>• Phase 01 · Escrow Deposit: Buyer deposits 100% of purchase funds ($380,000) into vvEntra escrow before any code moves.</a:t>
             </a:r>
           </a:p>
           <a:p>
             <a:pPr>
               <a:spcBef>
-                <a:spcPts val="600"/>
+                <a:spcPts val="800"/>
               </a:spcBef>
-              <a:defRPr sz="1100">
-                <a:solidFill>
-                  <a:srgbClr val="CBD5E1"/>
-                </a:solidFill>
-              </a:defRPr>
-            </a:pPr>
-            <a:r>
-              <a:t>• Buttons Did Not Work: Many cards and charts were just pictures that you could not click or interact with.</a:t>
+              <a:defRPr sz="1150">
+                <a:solidFill>
+                  <a:srgbClr val="E2E8F0"/>
+                </a:solidFill>
+              </a:defRPr>
+            </a:pPr>
+            <a:r>
+              <a:t>• Phase 02 · Code &amp; Cloud Lock: Seller safely transfers the GitHub code repository and AWS/cloud servers into safe custody.</a:t>
             </a:r>
           </a:p>
           <a:p>
             <a:pPr>
               <a:spcBef>
-                <a:spcPts val="600"/>
+                <a:spcPts val="800"/>
               </a:spcBef>
-              <a:defRPr sz="1100">
-                <a:solidFill>
-                  <a:srgbClr val="CBD5E1"/>
-                </a:solidFill>
-              </a:defRPr>
-            </a:pPr>
-            <a:r>
-              <a:t>• No Safe Transfer Method: Only had a basic 'Buy' button, with no answer to how code or money is actually protected.</a:t>
-            </a:r>
-          </a:p>
-        </p:txBody>
-      </p:sp>
-      <p:sp>
-        <p:nvSpPr>
-          <p:cNvPr id="7" name="Rounded Rectangle 6"/>
-          <p:cNvSpPr/>
-          <p:nvPr/>
-        </p:nvSpPr>
-        <p:spPr>
-          <a:xfrm>
-            <a:off x="6217920" y="1737360"/>
-            <a:ext cx="5212080" cy="4572000"/>
-          </a:xfrm>
-          <a:prstGeom prst="roundRect">
-            <a:avLst/>
-          </a:prstGeom>
-          <a:solidFill>
-            <a:srgbClr val="1E293B"/>
-          </a:solidFill>
-          <a:ln w="15240">
-            <a:solidFill>
-              <a:srgbClr val="334155"/>
-            </a:solidFill>
-          </a:ln>
-        </p:spPr>
-        <p:style>
-          <a:lnRef idx="1">
-            <a:schemeClr val="accent1"/>
-          </a:lnRef>
-          <a:fillRef idx="3">
-            <a:schemeClr val="accent1"/>
-          </a:fillRef>
-          <a:effectRef idx="2">
-            <a:schemeClr val="accent1"/>
-          </a:effectRef>
-          <a:fontRef idx="minor">
-            <a:schemeClr val="lt1"/>
-          </a:fontRef>
-        </p:style>
-        <p:txBody>
-          <a:bodyPr rtlCol="0" anchor="ctr"/>
-          <a:lstStyle/>
-          <a:p>
-            <a:pPr algn="ctr"/>
-          </a:p>
-        </p:txBody>
-      </p:sp>
-      <p:sp>
-        <p:nvSpPr>
-          <p:cNvPr id="8" name="TextBox 7"/>
-          <p:cNvSpPr txBox="1"/>
-          <p:nvPr/>
-        </p:nvSpPr>
-        <p:spPr>
-          <a:xfrm>
-            <a:off x="6446520" y="1920240"/>
-            <a:ext cx="4754880" cy="4206240"/>
-          </a:xfrm>
-          <a:prstGeom prst="rect">
-            <a:avLst/>
-          </a:prstGeom>
-          <a:noFill/>
-        </p:spPr>
-        <p:txBody>
-          <a:bodyPr wrap="square">
-            <a:spAutoFit/>
-          </a:bodyPr>
-          <a:lstStyle/>
-          <a:p>
-            <a:pPr>
-              <a:defRPr sz="1400" b="1">
-                <a:solidFill>
-                  <a:srgbClr val="4ADE80"/>
-                </a:solidFill>
-              </a:defRPr>
-            </a:pPr>
-            <a:r>
-              <a:t>[OUR INNOVATION]  Our Innovation: Safe 4-Step Handover</a:t>
+              <a:defRPr sz="1150">
+                <a:solidFill>
+                  <a:srgbClr val="E2E8F0"/>
+                </a:solidFill>
+              </a:defRPr>
+            </a:pPr>
+            <a:r>
+              <a:t>• Phase 03 · Domain Migration: Website domain name and live traffic are moved to the buyer with zero downtime.</a:t>
             </a:r>
           </a:p>
           <a:p>
             <a:pPr>
               <a:spcBef>
-                <a:spcPts val="600"/>
+                <a:spcPts val="800"/>
               </a:spcBef>
-              <a:defRPr sz="1100">
-                <a:solidFill>
-                  <a:srgbClr val="CBD5E1"/>
-                </a:solidFill>
-              </a:defRPr>
-            </a:pPr>
-            <a:r>
-              <a:t>• The Safe Handover System: Solves the biggest fear in buying software using 4 clear steps:</a:t>
+              <a:defRPr sz="1150">
+                <a:solidFill>
+                  <a:srgbClr val="E2E8F0"/>
+                </a:solidFill>
+              </a:defRPr>
+            </a:pPr>
+            <a:r>
+              <a:t>• Phase 04 · Testing &amp; Payout: Buyer tests the app; once confirmed, seller receives 90% ($342,000) and vvEntra retains 10% ($38,000).</a:t>
             </a:r>
           </a:p>
           <a:p>
             <a:pPr>
               <a:spcBef>
-                <a:spcPts val="600"/>
+                <a:spcPts val="800"/>
               </a:spcBef>
-              <a:defRPr sz="1100">
-                <a:solidFill>
-                  <a:srgbClr val="CBD5E1"/>
-                </a:solidFill>
-              </a:defRPr>
-            </a:pPr>
-            <a:r>
-              <a:t>•   1. Money Deposit: Buyer puts money in a safe lockbox (escrow).</a:t>
-            </a:r>
-          </a:p>
-          <a:p>
-            <a:pPr>
-              <a:spcBef>
-                <a:spcPts val="600"/>
-              </a:spcBef>
-              <a:defRPr sz="1100">
-                <a:solidFill>
-                  <a:srgbClr val="CBD5E1"/>
-                </a:solidFill>
-              </a:defRPr>
-            </a:pPr>
-            <a:r>
-              <a:t>•   2. Code Lock: Seller hands over code and cloud accounts into safe custody.</a:t>
-            </a:r>
-          </a:p>
-          <a:p>
-            <a:pPr>
-              <a:spcBef>
-                <a:spcPts val="600"/>
-              </a:spcBef>
-              <a:defRPr sz="1100">
-                <a:solidFill>
-                  <a:srgbClr val="CBD5E1"/>
-                </a:solidFill>
-              </a:defRPr>
-            </a:pPr>
-            <a:r>
-              <a:t>•   3. Domain Move: The website domain is moved to the buyer.</a:t>
-            </a:r>
-          </a:p>
-          <a:p>
-            <a:pPr>
-              <a:spcBef>
-                <a:spcPts val="600"/>
-              </a:spcBef>
-              <a:defRPr sz="1100">
-                <a:solidFill>
-                  <a:srgbClr val="CBD5E1"/>
-                </a:solidFill>
-              </a:defRPr>
-            </a:pPr>
-            <a:r>
-              <a:t>•   4. Testing &amp; Release: Buyer tests the app; once confirmed, money goes to the seller.</a:t>
-            </a:r>
-          </a:p>
-          <a:p>
-            <a:pPr>
-              <a:spcBef>
-                <a:spcPts val="600"/>
-              </a:spcBef>
-              <a:defRPr sz="1100">
-                <a:solidFill>
-                  <a:srgbClr val="CBD5E1"/>
-                </a:solidFill>
-              </a:defRPr>
-            </a:pPr>
-            <a:r>
-              <a:t>• Interactive Simulator: Users can click through all 4 steps on the screen to see how it works.</a:t>
-            </a:r>
-          </a:p>
-          <a:p>
-            <a:pPr>
-              <a:spcBef>
-                <a:spcPts val="600"/>
-              </a:spcBef>
-              <a:defRPr sz="1100">
-                <a:solidFill>
-                  <a:srgbClr val="CBD5E1"/>
-                </a:solidFill>
-              </a:defRPr>
-            </a:pPr>
-            <a:r>
-              <a:t>• Clean, Professional Look: Simple typography and clean cards instead of confusing neon effects.</a:t>
+              <a:defRPr sz="1150">
+                <a:solidFill>
+                  <a:srgbClr val="E2E8F0"/>
+                </a:solidFill>
+              </a:defRPr>
+            </a:pPr>
+            <a:r>
+              <a:t>• Live Interactive Simulator: A live simulator on every listing lets users click and watch the 4 steps happen in real time.</a:t>
             </a:r>
           </a:p>
         </p:txBody>
@@ -6097,14 +6083,119 @@
       </p:sp>
       <p:sp>
         <p:nvSpPr>
-          <p:cNvPr id="3" name="Rounded Rectangle 2"/>
+          <p:cNvPr id="3" name="TextBox 2"/>
+          <p:cNvSpPr txBox="1"/>
+          <p:nvPr/>
+        </p:nvSpPr>
+        <p:spPr>
+          <a:xfrm>
+            <a:off x="822960" y="502920"/>
+            <a:ext cx="4572000" cy="320040"/>
+          </a:xfrm>
+          <a:prstGeom prst="rect">
+            <a:avLst/>
+          </a:prstGeom>
+          <a:noFill/>
+        </p:spPr>
+        <p:txBody>
+          <a:bodyPr wrap="none">
+            <a:spAutoFit/>
+          </a:bodyPr>
+          <a:lstStyle/>
+          <a:p>
+            <a:pPr>
+              <a:defRPr sz="1000" b="1">
+                <a:solidFill>
+                  <a:srgbClr val="38BDF8"/>
+                </a:solidFill>
+              </a:defRPr>
+            </a:pPr>
+            <a:r>
+              <a:t>SLIDE 05 · VVENTRA OVERVIEW</a:t>
+            </a:r>
+          </a:p>
+        </p:txBody>
+      </p:sp>
+      <p:sp>
+        <p:nvSpPr>
+          <p:cNvPr id="4" name="TextBox 3"/>
+          <p:cNvSpPr txBox="1"/>
+          <p:nvPr/>
+        </p:nvSpPr>
+        <p:spPr>
+          <a:xfrm>
+            <a:off x="822960" y="777240"/>
+            <a:ext cx="10515600" cy="594360"/>
+          </a:xfrm>
+          <a:prstGeom prst="rect">
+            <a:avLst/>
+          </a:prstGeom>
+          <a:noFill/>
+        </p:spPr>
+        <p:txBody>
+          <a:bodyPr wrap="none">
+            <a:spAutoFit/>
+          </a:bodyPr>
+          <a:lstStyle/>
+          <a:p>
+            <a:pPr>
+              <a:defRPr sz="2400" b="1">
+                <a:solidFill>
+                  <a:srgbClr val="FFFFFF"/>
+                </a:solidFill>
+              </a:defRPr>
+            </a:pPr>
+            <a:r>
+              <a:t>Conclusion &amp; Key Learnings</a:t>
+            </a:r>
+          </a:p>
+        </p:txBody>
+      </p:sp>
+      <p:sp>
+        <p:nvSpPr>
+          <p:cNvPr id="5" name="TextBox 4"/>
+          <p:cNvSpPr txBox="1"/>
+          <p:nvPr/>
+        </p:nvSpPr>
+        <p:spPr>
+          <a:xfrm>
+            <a:off x="822960" y="1325880"/>
+            <a:ext cx="10515600" cy="411480"/>
+          </a:xfrm>
+          <a:prstGeom prst="rect">
+            <a:avLst/>
+          </a:prstGeom>
+          <a:noFill/>
+        </p:spPr>
+        <p:txBody>
+          <a:bodyPr wrap="none">
+            <a:spAutoFit/>
+          </a:bodyPr>
+          <a:lstStyle/>
+          <a:p>
+            <a:pPr>
+              <a:defRPr sz="1200">
+                <a:solidFill>
+                  <a:srgbClr val="94A3B8"/>
+                </a:solidFill>
+              </a:defRPr>
+            </a:pPr>
+            <a:r>
+              <a:t>The three main lessons learned while building this platform.</a:t>
+            </a:r>
+          </a:p>
+        </p:txBody>
+      </p:sp>
+      <p:sp>
+        <p:nvSpPr>
+          <p:cNvPr id="6" name="Rounded Rectangle 5"/>
           <p:cNvSpPr/>
           <p:nvPr/>
         </p:nvSpPr>
         <p:spPr>
           <a:xfrm>
-            <a:off x="731520" y="457200"/>
-            <a:ext cx="2011680" cy="320040"/>
+            <a:off x="822960" y="1920240"/>
+            <a:ext cx="3291840" cy="4297680"/>
           </a:xfrm>
           <a:prstGeom prst="roundRect">
             <a:avLst/>
@@ -6112,7 +6203,7 @@
           <a:solidFill>
             <a:srgbClr val="1E293B"/>
           </a:solidFill>
-          <a:ln w="12700">
+          <a:ln w="15240">
             <a:solidFill>
               <a:srgbClr val="334155"/>
             </a:solidFill>
@@ -6136,29 +6227,20 @@
           <a:bodyPr rtlCol="0" anchor="ctr"/>
           <a:lstStyle/>
           <a:p>
-            <a:pPr algn="ctr">
-              <a:defRPr sz="900" b="1">
-                <a:solidFill>
-                  <a:srgbClr val="38BDF8"/>
-                </a:solidFill>
-              </a:defRPr>
-            </a:pPr>
-            <a:r>
-              <a:t>5. CONCLUSION</a:t>
-            </a:r>
-          </a:p>
-        </p:txBody>
-      </p:sp>
-      <p:sp>
-        <p:nvSpPr>
-          <p:cNvPr id="4" name="TextBox 3"/>
+            <a:pPr algn="ctr"/>
+          </a:p>
+        </p:txBody>
+      </p:sp>
+      <p:sp>
+        <p:nvSpPr>
+          <p:cNvPr id="7" name="TextBox 6"/>
           <p:cNvSpPr txBox="1"/>
           <p:nvPr/>
         </p:nvSpPr>
         <p:spPr>
           <a:xfrm>
-            <a:off x="731520" y="822960"/>
-            <a:ext cx="10698480" cy="731520"/>
+            <a:off x="1097280" y="2148840"/>
+            <a:ext cx="2743200" cy="3840480"/>
           </a:xfrm>
           <a:prstGeom prst="rect">
             <a:avLst/>
@@ -6172,40 +6254,73 @@
           <a:lstStyle/>
           <a:p>
             <a:pPr>
-              <a:defRPr sz="2200" b="1">
-                <a:solidFill>
-                  <a:srgbClr val="FFFFFF"/>
-                </a:solidFill>
-              </a:defRPr>
-            </a:pPr>
-            <a:r>
-              <a:t>Conclusion &amp; Key Learnings</a:t>
-            </a:r>
-          </a:p>
-          <a:p>
-            <a:pPr>
-              <a:defRPr sz="1100">
-                <a:solidFill>
-                  <a:srgbClr val="CBD5E1"/>
-                </a:solidFill>
-              </a:defRPr>
-            </a:pPr>
-            <a:r>
-              <a:t>The three main things we learned while building this project.</a:t>
-            </a:r>
-          </a:p>
-        </p:txBody>
-      </p:sp>
-      <p:sp>
-        <p:nvSpPr>
-          <p:cNvPr id="5" name="Rounded Rectangle 4"/>
+              <a:defRPr sz="1500" b="1">
+                <a:solidFill>
+                  <a:srgbClr val="38BDF8"/>
+                </a:solidFill>
+              </a:defRPr>
+            </a:pPr>
+            <a:r>
+              <a:t>1. Simple Code is Fast</a:t>
+            </a:r>
+          </a:p>
+          <a:p>
+            <a:pPr>
+              <a:spcBef>
+                <a:spcPts val="800"/>
+              </a:spcBef>
+              <a:defRPr sz="1150">
+                <a:solidFill>
+                  <a:srgbClr val="E2E8F0"/>
+                </a:solidFill>
+              </a:defRPr>
+            </a:pPr>
+            <a:r>
+              <a:t>• We didn't need big frameworks like React to build an interactive multi-page website.</a:t>
+            </a:r>
+          </a:p>
+          <a:p>
+            <a:pPr>
+              <a:spcBef>
+                <a:spcPts val="800"/>
+              </a:spcBef>
+              <a:defRPr sz="1150">
+                <a:solidFill>
+                  <a:srgbClr val="E2E8F0"/>
+                </a:solidFill>
+              </a:defRPr>
+            </a:pPr>
+            <a:r>
+              <a:t>• Pure HTML, CSS, and Vanilla JavaScript loaded in under 120ms with zero extra installs.</a:t>
+            </a:r>
+          </a:p>
+          <a:p>
+            <a:pPr>
+              <a:spcBef>
+                <a:spcPts val="800"/>
+              </a:spcBef>
+              <a:defRPr sz="1150">
+                <a:solidFill>
+                  <a:srgbClr val="E2E8F0"/>
+                </a:solidFill>
+              </a:defRPr>
+            </a:pPr>
+            <a:r>
+              <a:t>• Fewer libraries mean fewer bugs, zero security warnings, and zero maintenance headaches.</a:t>
+            </a:r>
+          </a:p>
+        </p:txBody>
+      </p:sp>
+      <p:sp>
+        <p:nvSpPr>
+          <p:cNvPr id="8" name="Rounded Rectangle 7"/>
           <p:cNvSpPr/>
           <p:nvPr/>
         </p:nvSpPr>
         <p:spPr>
           <a:xfrm>
-            <a:off x="731520" y="1737360"/>
-            <a:ext cx="3291840" cy="4572000"/>
+            <a:off x="4443984" y="1920240"/>
+            <a:ext cx="3291840" cy="4297680"/>
           </a:xfrm>
           <a:prstGeom prst="roundRect">
             <a:avLst/>
@@ -6243,14 +6358,14 @@
       </p:sp>
       <p:sp>
         <p:nvSpPr>
-          <p:cNvPr id="6" name="TextBox 5"/>
+          <p:cNvPr id="9" name="TextBox 8"/>
           <p:cNvSpPr txBox="1"/>
           <p:nvPr/>
         </p:nvSpPr>
         <p:spPr>
           <a:xfrm>
-            <a:off x="960120" y="1920240"/>
-            <a:ext cx="2834640" cy="4206240"/>
+            <a:off x="4718304" y="2148840"/>
+            <a:ext cx="2743200" cy="3840480"/>
           </a:xfrm>
           <a:prstGeom prst="rect">
             <a:avLst/>
@@ -6264,73 +6379,73 @@
           <a:lstStyle/>
           <a:p>
             <a:pPr>
-              <a:defRPr sz="1400" b="1">
-                <a:solidFill>
-                  <a:srgbClr val="38BDF8"/>
-                </a:solidFill>
-              </a:defRPr>
-            </a:pPr>
-            <a:r>
-              <a:t>[CODE LESSON]  1. Simple Code is Fast</a:t>
+              <a:defRPr sz="1500" b="1">
+                <a:solidFill>
+                  <a:srgbClr val="4ADE80"/>
+                </a:solidFill>
+              </a:defRPr>
+            </a:pPr>
+            <a:r>
+              <a:t>2. Clear Info Builds Trust</a:t>
             </a:r>
           </a:p>
           <a:p>
             <a:pPr>
               <a:spcBef>
-                <a:spcPts val="600"/>
+                <a:spcPts val="800"/>
               </a:spcBef>
-              <a:defRPr sz="1100">
-                <a:solidFill>
-                  <a:srgbClr val="CBD5E1"/>
-                </a:solidFill>
-              </a:defRPr>
-            </a:pPr>
-            <a:r>
-              <a:t>• We didn't need big frameworks like React to build an interactive multi-page website.</a:t>
+              <a:defRPr sz="1150">
+                <a:solidFill>
+                  <a:srgbClr val="E2E8F0"/>
+                </a:solidFill>
+              </a:defRPr>
+            </a:pPr>
+            <a:r>
+              <a:t>• In business and finance, people care about honest numbers, not glowing neon buttons.</a:t>
             </a:r>
           </a:p>
           <a:p>
             <a:pPr>
               <a:spcBef>
-                <a:spcPts val="600"/>
+                <a:spcPts val="800"/>
               </a:spcBef>
-              <a:defRPr sz="1100">
-                <a:solidFill>
-                  <a:srgbClr val="CBD5E1"/>
-                </a:solidFill>
-              </a:defRPr>
-            </a:pPr>
-            <a:r>
-              <a:t>• Pure HTML, CSS, and JavaScript loaded in under 120ms with zero extra installs.</a:t>
+              <a:defRPr sz="1150">
+                <a:solidFill>
+                  <a:srgbClr val="E2E8F0"/>
+                </a:solidFill>
+              </a:defRPr>
+            </a:pPr>
+            <a:r>
+              <a:t>• Clean tables, verified Stripe data, and clear fee breakdowns build real confidence with buyers and sellers.</a:t>
             </a:r>
           </a:p>
           <a:p>
             <a:pPr>
               <a:spcBef>
-                <a:spcPts val="600"/>
+                <a:spcPts val="800"/>
               </a:spcBef>
-              <a:defRPr sz="1100">
-                <a:solidFill>
-                  <a:srgbClr val="CBD5E1"/>
-                </a:solidFill>
-              </a:defRPr>
-            </a:pPr>
-            <a:r>
-              <a:t>• Fewer libraries mean fewer bugs and zero maintenance headache.</a:t>
-            </a:r>
-          </a:p>
-        </p:txBody>
-      </p:sp>
-      <p:sp>
-        <p:nvSpPr>
-          <p:cNvPr id="7" name="Rounded Rectangle 6"/>
+              <a:defRPr sz="1150">
+                <a:solidFill>
+                  <a:srgbClr val="E2E8F0"/>
+                </a:solidFill>
+              </a:defRPr>
+            </a:pPr>
+            <a:r>
+              <a:t>• Simple, plain design looks far more serious and professional.</a:t>
+            </a:r>
+          </a:p>
+        </p:txBody>
+      </p:sp>
+      <p:sp>
+        <p:nvSpPr>
+          <p:cNvPr id="10" name="Rounded Rectangle 9"/>
           <p:cNvSpPr/>
           <p:nvPr/>
         </p:nvSpPr>
         <p:spPr>
           <a:xfrm>
-            <a:off x="4443984" y="1737360"/>
-            <a:ext cx="3291840" cy="4572000"/>
+            <a:off x="8074152" y="1920240"/>
+            <a:ext cx="3291840" cy="4297680"/>
           </a:xfrm>
           <a:prstGeom prst="roundRect">
             <a:avLst/>
@@ -6368,14 +6483,14 @@
       </p:sp>
       <p:sp>
         <p:nvSpPr>
-          <p:cNvPr id="8" name="TextBox 7"/>
+          <p:cNvPr id="11" name="TextBox 10"/>
           <p:cNvSpPr txBox="1"/>
           <p:nvPr/>
         </p:nvSpPr>
         <p:spPr>
           <a:xfrm>
-            <a:off x="4672584" y="1920240"/>
-            <a:ext cx="2834640" cy="4206240"/>
+            <a:off x="8348472" y="2148840"/>
+            <a:ext cx="2743200" cy="3840480"/>
           </a:xfrm>
           <a:prstGeom prst="rect">
             <a:avLst/>
@@ -6389,179 +6504,54 @@
           <a:lstStyle/>
           <a:p>
             <a:pPr>
-              <a:defRPr sz="1400" b="1">
-                <a:solidFill>
-                  <a:srgbClr val="4ADE80"/>
-                </a:solidFill>
-              </a:defRPr>
-            </a:pPr>
-            <a:r>
-              <a:t>[DESIGN LESSON]  2. Clear Info Beats Flashy UI</a:t>
+              <a:defRPr sz="1500" b="1">
+                <a:solidFill>
+                  <a:srgbClr val="FBBF24"/>
+                </a:solidFill>
+              </a:defRPr>
+            </a:pPr>
+            <a:r>
+              <a:t>3. Safety is What Sells</a:t>
             </a:r>
           </a:p>
           <a:p>
             <a:pPr>
               <a:spcBef>
-                <a:spcPts val="600"/>
+                <a:spcPts val="800"/>
               </a:spcBef>
-              <a:defRPr sz="1100">
-                <a:solidFill>
-                  <a:srgbClr val="CBD5E1"/>
-                </a:solidFill>
-              </a:defRPr>
-            </a:pPr>
-            <a:r>
-              <a:t>• In finance and business, people care about honest numbers, not glowing neon buttons.</a:t>
+              <a:defRPr sz="1150">
+                <a:solidFill>
+                  <a:srgbClr val="E2E8F0"/>
+                </a:solidFill>
+              </a:defRPr>
+            </a:pPr>
+            <a:r>
+              <a:t>• Anyone can build a website that lists software for sale.</a:t>
             </a:r>
           </a:p>
           <a:p>
             <a:pPr>
               <a:spcBef>
-                <a:spcPts val="600"/>
+                <a:spcPts val="800"/>
               </a:spcBef>
-              <a:defRPr sz="1100">
-                <a:solidFill>
-                  <a:srgbClr val="CBD5E1"/>
-                </a:solidFill>
-              </a:defRPr>
-            </a:pPr>
-            <a:r>
-              <a:t>• Clean tables, verified Stripe data, and clear fee comparisons build real trust with buyers and sellers.</a:t>
+              <a:defRPr sz="1150">
+                <a:solidFill>
+                  <a:srgbClr val="E2E8F0"/>
+                </a:solidFill>
+              </a:defRPr>
+            </a:pPr>
+            <a:r>
+              <a:t>• The real commercial value is making sure nobody gets scammed when handing over code and money.</a:t>
             </a:r>
           </a:p>
           <a:p>
             <a:pPr>
               <a:spcBef>
-                <a:spcPts val="600"/>
+                <a:spcPts val="800"/>
               </a:spcBef>
-              <a:defRPr sz="1100">
-                <a:solidFill>
-                  <a:srgbClr val="CBD5E1"/>
-                </a:solidFill>
-              </a:defRPr>
-            </a:pPr>
-            <a:r>
-              <a:t>• Simple and plain design looks far more serious and professional.</a:t>
-            </a:r>
-          </a:p>
-        </p:txBody>
-      </p:sp>
-      <p:sp>
-        <p:nvSpPr>
-          <p:cNvPr id="9" name="Rounded Rectangle 8"/>
-          <p:cNvSpPr/>
-          <p:nvPr/>
-        </p:nvSpPr>
-        <p:spPr>
-          <a:xfrm>
-            <a:off x="8165592" y="1737360"/>
-            <a:ext cx="3291840" cy="4572000"/>
-          </a:xfrm>
-          <a:prstGeom prst="roundRect">
-            <a:avLst/>
-          </a:prstGeom>
-          <a:solidFill>
-            <a:srgbClr val="1E293B"/>
-          </a:solidFill>
-          <a:ln w="15240">
-            <a:solidFill>
-              <a:srgbClr val="334155"/>
-            </a:solidFill>
-          </a:ln>
-        </p:spPr>
-        <p:style>
-          <a:lnRef idx="1">
-            <a:schemeClr val="accent1"/>
-          </a:lnRef>
-          <a:fillRef idx="3">
-            <a:schemeClr val="accent1"/>
-          </a:fillRef>
-          <a:effectRef idx="2">
-            <a:schemeClr val="accent1"/>
-          </a:effectRef>
-          <a:fontRef idx="minor">
-            <a:schemeClr val="lt1"/>
-          </a:fontRef>
-        </p:style>
-        <p:txBody>
-          <a:bodyPr rtlCol="0" anchor="ctr"/>
-          <a:lstStyle/>
-          <a:p>
-            <a:pPr algn="ctr"/>
-          </a:p>
-        </p:txBody>
-      </p:sp>
-      <p:sp>
-        <p:nvSpPr>
-          <p:cNvPr id="10" name="TextBox 9"/>
-          <p:cNvSpPr txBox="1"/>
-          <p:nvPr/>
-        </p:nvSpPr>
-        <p:spPr>
-          <a:xfrm>
-            <a:off x="8394192" y="1920240"/>
-            <a:ext cx="2834640" cy="4206240"/>
-          </a:xfrm>
-          <a:prstGeom prst="rect">
-            <a:avLst/>
-          </a:prstGeom>
-          <a:noFill/>
-        </p:spPr>
-        <p:txBody>
-          <a:bodyPr wrap="square">
-            <a:spAutoFit/>
-          </a:bodyPr>
-          <a:lstStyle/>
-          <a:p>
-            <a:pPr>
-              <a:defRPr sz="1400" b="1">
-                <a:solidFill>
-                  <a:srgbClr val="FBBF24"/>
-                </a:solidFill>
-              </a:defRPr>
-            </a:pPr>
-            <a:r>
-              <a:t>[PRODUCT LESSON]  3. Safety is What Sells</a:t>
-            </a:r>
-          </a:p>
-          <a:p>
-            <a:pPr>
-              <a:spcBef>
-                <a:spcPts val="600"/>
-              </a:spcBef>
-              <a:defRPr sz="1100">
-                <a:solidFill>
-                  <a:srgbClr val="CBD5E1"/>
-                </a:solidFill>
-              </a:defRPr>
-            </a:pPr>
-            <a:r>
-              <a:t>• Anyone can build a website that lists apps for sale.</a:t>
-            </a:r>
-          </a:p>
-          <a:p>
-            <a:pPr>
-              <a:spcBef>
-                <a:spcPts val="600"/>
-              </a:spcBef>
-              <a:defRPr sz="1100">
-                <a:solidFill>
-                  <a:srgbClr val="CBD5E1"/>
-                </a:solidFill>
-              </a:defRPr>
-            </a:pPr>
-            <a:r>
-              <a:t>• The real challenge is making sure nobody gets scammed when handing over code and money.</a:t>
-            </a:r>
-          </a:p>
-          <a:p>
-            <a:pPr>
-              <a:spcBef>
-                <a:spcPts val="600"/>
-              </a:spcBef>
-              <a:defRPr sz="1100">
-                <a:solidFill>
-                  <a:srgbClr val="CBD5E1"/>
+              <a:defRPr sz="1150">
+                <a:solidFill>
+                  <a:srgbClr val="E2E8F0"/>
                 </a:solidFill>
               </a:defRPr>
             </a:pPr>

</xml_diff>